<commit_message>
start of ppt and updated component+class diagrams
</commit_message>
<xml_diff>
--- a/doc/presentation.pptx
+++ b/doc/presentation.pptx
@@ -11,9 +11,11 @@
     <p:sldId id="259" r:id="rId5"/>
     <p:sldId id="260" r:id="rId6"/>
     <p:sldId id="261" r:id="rId7"/>
-    <p:sldId id="262" r:id="rId8"/>
-    <p:sldId id="263" r:id="rId9"/>
-    <p:sldId id="264" r:id="rId10"/>
+    <p:sldId id="265" r:id="rId8"/>
+    <p:sldId id="266" r:id="rId9"/>
+    <p:sldId id="262" r:id="rId10"/>
+    <p:sldId id="263" r:id="rId11"/>
+    <p:sldId id="264" r:id="rId12"/>
   </p:sldIdLst>
   <p:sldSz cx="12192000" cy="6858000"/>
   <p:notesSz cx="6858000" cy="9144000"/>
@@ -269,7 +271,7 @@
           <a:p>
             <a:fld id="{7D708B82-F97F-4828-9186-4C6AB2EFCAFD}" type="datetimeFigureOut">
               <a:rPr lang="en-CH" smtClean="0"/>
-              <a:t>22/04/2026</a:t>
+              <a:t>05/27/2026</a:t>
             </a:fld>
             <a:endParaRPr lang="en-CH"/>
           </a:p>
@@ -323,7 +325,7 @@
           <a:p>
             <a:fld id="{4DF3A20D-DBCC-4BDF-9F56-7F610081343B}" type="slidenum">
               <a:rPr lang="en-CH" smtClean="0"/>
-              <a:t>‹#›</a:t>
+              <a:t>‹N°›</a:t>
             </a:fld>
             <a:endParaRPr lang="en-CH"/>
           </a:p>
@@ -469,7 +471,7 @@
           <a:p>
             <a:fld id="{7D708B82-F97F-4828-9186-4C6AB2EFCAFD}" type="datetimeFigureOut">
               <a:rPr lang="en-CH" smtClean="0"/>
-              <a:t>22/04/2026</a:t>
+              <a:t>05/27/2026</a:t>
             </a:fld>
             <a:endParaRPr lang="en-CH"/>
           </a:p>
@@ -523,7 +525,7 @@
           <a:p>
             <a:fld id="{4DF3A20D-DBCC-4BDF-9F56-7F610081343B}" type="slidenum">
               <a:rPr lang="en-CH" smtClean="0"/>
-              <a:t>‹#›</a:t>
+              <a:t>‹N°›</a:t>
             </a:fld>
             <a:endParaRPr lang="en-CH"/>
           </a:p>
@@ -679,7 +681,7 @@
           <a:p>
             <a:fld id="{7D708B82-F97F-4828-9186-4C6AB2EFCAFD}" type="datetimeFigureOut">
               <a:rPr lang="en-CH" smtClean="0"/>
-              <a:t>22/04/2026</a:t>
+              <a:t>05/27/2026</a:t>
             </a:fld>
             <a:endParaRPr lang="en-CH"/>
           </a:p>
@@ -733,7 +735,7 @@
           <a:p>
             <a:fld id="{4DF3A20D-DBCC-4BDF-9F56-7F610081343B}" type="slidenum">
               <a:rPr lang="en-CH" smtClean="0"/>
-              <a:t>‹#›</a:t>
+              <a:t>‹N°›</a:t>
             </a:fld>
             <a:endParaRPr lang="en-CH"/>
           </a:p>
@@ -879,7 +881,7 @@
           <a:p>
             <a:fld id="{7D708B82-F97F-4828-9186-4C6AB2EFCAFD}" type="datetimeFigureOut">
               <a:rPr lang="en-CH" smtClean="0"/>
-              <a:t>22/04/2026</a:t>
+              <a:t>05/27/2026</a:t>
             </a:fld>
             <a:endParaRPr lang="en-CH"/>
           </a:p>
@@ -933,7 +935,7 @@
           <a:p>
             <a:fld id="{4DF3A20D-DBCC-4BDF-9F56-7F610081343B}" type="slidenum">
               <a:rPr lang="en-CH" smtClean="0"/>
-              <a:t>‹#›</a:t>
+              <a:t>‹N°›</a:t>
             </a:fld>
             <a:endParaRPr lang="en-CH"/>
           </a:p>
@@ -1155,7 +1157,7 @@
           <a:p>
             <a:fld id="{7D708B82-F97F-4828-9186-4C6AB2EFCAFD}" type="datetimeFigureOut">
               <a:rPr lang="en-CH" smtClean="0"/>
-              <a:t>22/04/2026</a:t>
+              <a:t>05/27/2026</a:t>
             </a:fld>
             <a:endParaRPr lang="en-CH"/>
           </a:p>
@@ -1209,7 +1211,7 @@
           <a:p>
             <a:fld id="{4DF3A20D-DBCC-4BDF-9F56-7F610081343B}" type="slidenum">
               <a:rPr lang="en-CH" smtClean="0"/>
-              <a:t>‹#›</a:t>
+              <a:t>‹N°›</a:t>
             </a:fld>
             <a:endParaRPr lang="en-CH"/>
           </a:p>
@@ -1423,7 +1425,7 @@
           <a:p>
             <a:fld id="{7D708B82-F97F-4828-9186-4C6AB2EFCAFD}" type="datetimeFigureOut">
               <a:rPr lang="en-CH" smtClean="0"/>
-              <a:t>22/04/2026</a:t>
+              <a:t>05/27/2026</a:t>
             </a:fld>
             <a:endParaRPr lang="en-CH"/>
           </a:p>
@@ -1477,7 +1479,7 @@
           <a:p>
             <a:fld id="{4DF3A20D-DBCC-4BDF-9F56-7F610081343B}" type="slidenum">
               <a:rPr lang="en-CH" smtClean="0"/>
-              <a:t>‹#›</a:t>
+              <a:t>‹N°›</a:t>
             </a:fld>
             <a:endParaRPr lang="en-CH"/>
           </a:p>
@@ -1838,7 +1840,7 @@
           <a:p>
             <a:fld id="{7D708B82-F97F-4828-9186-4C6AB2EFCAFD}" type="datetimeFigureOut">
               <a:rPr lang="en-CH" smtClean="0"/>
-              <a:t>22/04/2026</a:t>
+              <a:t>05/27/2026</a:t>
             </a:fld>
             <a:endParaRPr lang="en-CH"/>
           </a:p>
@@ -1892,7 +1894,7 @@
           <a:p>
             <a:fld id="{4DF3A20D-DBCC-4BDF-9F56-7F610081343B}" type="slidenum">
               <a:rPr lang="en-CH" smtClean="0"/>
-              <a:t>‹#›</a:t>
+              <a:t>‹N°›</a:t>
             </a:fld>
             <a:endParaRPr lang="en-CH"/>
           </a:p>
@@ -1980,7 +1982,7 @@
           <a:p>
             <a:fld id="{7D708B82-F97F-4828-9186-4C6AB2EFCAFD}" type="datetimeFigureOut">
               <a:rPr lang="en-CH" smtClean="0"/>
-              <a:t>22/04/2026</a:t>
+              <a:t>05/27/2026</a:t>
             </a:fld>
             <a:endParaRPr lang="en-CH"/>
           </a:p>
@@ -2034,7 +2036,7 @@
           <a:p>
             <a:fld id="{4DF3A20D-DBCC-4BDF-9F56-7F610081343B}" type="slidenum">
               <a:rPr lang="en-CH" smtClean="0"/>
-              <a:t>‹#›</a:t>
+              <a:t>‹N°›</a:t>
             </a:fld>
             <a:endParaRPr lang="en-CH"/>
           </a:p>
@@ -2093,7 +2095,7 @@
           <a:p>
             <a:fld id="{7D708B82-F97F-4828-9186-4C6AB2EFCAFD}" type="datetimeFigureOut">
               <a:rPr lang="en-CH" smtClean="0"/>
-              <a:t>22/04/2026</a:t>
+              <a:t>05/27/2026</a:t>
             </a:fld>
             <a:endParaRPr lang="en-CH"/>
           </a:p>
@@ -2147,7 +2149,7 @@
           <a:p>
             <a:fld id="{4DF3A20D-DBCC-4BDF-9F56-7F610081343B}" type="slidenum">
               <a:rPr lang="en-CH" smtClean="0"/>
-              <a:t>‹#›</a:t>
+              <a:t>‹N°›</a:t>
             </a:fld>
             <a:endParaRPr lang="en-CH"/>
           </a:p>
@@ -2406,7 +2408,7 @@
           <a:p>
             <a:fld id="{7D708B82-F97F-4828-9186-4C6AB2EFCAFD}" type="datetimeFigureOut">
               <a:rPr lang="en-CH" smtClean="0"/>
-              <a:t>22/04/2026</a:t>
+              <a:t>05/27/2026</a:t>
             </a:fld>
             <a:endParaRPr lang="en-CH"/>
           </a:p>
@@ -2460,7 +2462,7 @@
           <a:p>
             <a:fld id="{4DF3A20D-DBCC-4BDF-9F56-7F610081343B}" type="slidenum">
               <a:rPr lang="en-CH" smtClean="0"/>
-              <a:t>‹#›</a:t>
+              <a:t>‹N°›</a:t>
             </a:fld>
             <a:endParaRPr lang="en-CH"/>
           </a:p>
@@ -2695,7 +2697,7 @@
           <a:p>
             <a:fld id="{7D708B82-F97F-4828-9186-4C6AB2EFCAFD}" type="datetimeFigureOut">
               <a:rPr lang="en-CH" smtClean="0"/>
-              <a:t>22/04/2026</a:t>
+              <a:t>05/27/2026</a:t>
             </a:fld>
             <a:endParaRPr lang="en-CH"/>
           </a:p>
@@ -2749,7 +2751,7 @@
           <a:p>
             <a:fld id="{4DF3A20D-DBCC-4BDF-9F56-7F610081343B}" type="slidenum">
               <a:rPr lang="en-CH" smtClean="0"/>
-              <a:t>‹#›</a:t>
+              <a:t>‹N°›</a:t>
             </a:fld>
             <a:endParaRPr lang="en-CH"/>
           </a:p>
@@ -2938,7 +2940,7 @@
           <a:p>
             <a:fld id="{7D708B82-F97F-4828-9186-4C6AB2EFCAFD}" type="datetimeFigureOut">
               <a:rPr lang="en-CH" smtClean="0"/>
-              <a:t>22/04/2026</a:t>
+              <a:t>05/27/2026</a:t>
             </a:fld>
             <a:endParaRPr lang="en-CH"/>
           </a:p>
@@ -3028,7 +3030,7 @@
           <a:p>
             <a:fld id="{4DF3A20D-DBCC-4BDF-9F56-7F610081343B}" type="slidenum">
               <a:rPr lang="en-CH" smtClean="0"/>
-              <a:t>‹#›</a:t>
+              <a:t>‹N°›</a:t>
             </a:fld>
             <a:endParaRPr lang="en-CH"/>
           </a:p>
@@ -3431,6 +3433,197 @@
 </p:sld>
 </file>
 
+<file path=ppt/slides/slide10.xml><?xml version="1.0" encoding="utf-8"?>
+<p:sld xmlns:a="http://schemas.openxmlformats.org/drawingml/2006/main" xmlns:r="http://schemas.openxmlformats.org/officeDocument/2006/relationships" xmlns:p="http://schemas.openxmlformats.org/presentationml/2006/main">
+  <p:cSld>
+    <p:spTree>
+      <p:nvGrpSpPr>
+        <p:cNvPr id="1" name=""/>
+        <p:cNvGrpSpPr/>
+        <p:nvPr/>
+      </p:nvGrpSpPr>
+      <p:grpSpPr>
+        <a:xfrm>
+          <a:off x="0" y="0"/>
+          <a:ext cx="0" cy="0"/>
+          <a:chOff x="0" y="0"/>
+          <a:chExt cx="0" cy="0"/>
+        </a:xfrm>
+      </p:grpSpPr>
+      <p:sp>
+        <p:nvSpPr>
+          <p:cNvPr id="2" name="Titre 1">
+            <a:extLst>
+              <a:ext uri="{FF2B5EF4-FFF2-40B4-BE49-F238E27FC236}">
+                <a16:creationId xmlns:a16="http://schemas.microsoft.com/office/drawing/2014/main" id="{1F944A1B-5D11-648A-2775-DC7C5644520E}"/>
+              </a:ext>
+            </a:extLst>
+          </p:cNvPr>
+          <p:cNvSpPr>
+            <a:spLocks noGrp="1"/>
+          </p:cNvSpPr>
+          <p:nvPr>
+            <p:ph type="title"/>
+          </p:nvPr>
+        </p:nvSpPr>
+        <p:spPr/>
+        <p:txBody>
+          <a:bodyPr/>
+          <a:lstStyle/>
+          <a:p>
+            <a:r>
+              <a:rPr lang="fr-FR" dirty="0"/>
+              <a:t>Diagramme de déploiement</a:t>
+            </a:r>
+            <a:endParaRPr lang="fr-CH" dirty="0"/>
+          </a:p>
+        </p:txBody>
+      </p:sp>
+      <p:pic>
+        <p:nvPicPr>
+          <p:cNvPr id="7" name="Espace réservé du contenu 6">
+            <a:extLst>
+              <a:ext uri="{FF2B5EF4-FFF2-40B4-BE49-F238E27FC236}">
+                <a16:creationId xmlns:a16="http://schemas.microsoft.com/office/drawing/2014/main" id="{5BA6DD6C-4CCD-D909-4577-093C98B4C25D}"/>
+              </a:ext>
+            </a:extLst>
+          </p:cNvPr>
+          <p:cNvPicPr>
+            <a:picLocks noGrp="1" noChangeAspect="1"/>
+          </p:cNvPicPr>
+          <p:nvPr>
+            <p:ph idx="1"/>
+          </p:nvPr>
+        </p:nvPicPr>
+        <p:blipFill>
+          <a:blip r:embed="rId2">
+            <a:extLst>
+              <a:ext uri="{28A0092B-C50C-407E-A947-70E740481C1C}">
+                <a14:useLocalDpi xmlns:a14="http://schemas.microsoft.com/office/drawing/2010/main" val="0"/>
+              </a:ext>
+            </a:extLst>
+          </a:blip>
+          <a:stretch>
+            <a:fillRect/>
+          </a:stretch>
+        </p:blipFill>
+        <p:spPr>
+          <a:xfrm>
+            <a:off x="650442" y="1933904"/>
+            <a:ext cx="10891115" cy="3802911"/>
+          </a:xfrm>
+          <a:prstGeom prst="rect">
+            <a:avLst/>
+          </a:prstGeom>
+        </p:spPr>
+      </p:pic>
+    </p:spTree>
+    <p:extLst>
+      <p:ext uri="{BB962C8B-B14F-4D97-AF65-F5344CB8AC3E}">
+        <p14:creationId xmlns:p14="http://schemas.microsoft.com/office/powerpoint/2010/main" val="2074015821"/>
+      </p:ext>
+    </p:extLst>
+  </p:cSld>
+  <p:clrMapOvr>
+    <a:masterClrMapping/>
+  </p:clrMapOvr>
+</p:sld>
+</file>
+
+<file path=ppt/slides/slide11.xml><?xml version="1.0" encoding="utf-8"?>
+<p:sld xmlns:a="http://schemas.openxmlformats.org/drawingml/2006/main" xmlns:r="http://schemas.openxmlformats.org/officeDocument/2006/relationships" xmlns:p="http://schemas.openxmlformats.org/presentationml/2006/main">
+  <p:cSld>
+    <p:spTree>
+      <p:nvGrpSpPr>
+        <p:cNvPr id="1" name=""/>
+        <p:cNvGrpSpPr/>
+        <p:nvPr/>
+      </p:nvGrpSpPr>
+      <p:grpSpPr>
+        <a:xfrm>
+          <a:off x="0" y="0"/>
+          <a:ext cx="0" cy="0"/>
+          <a:chOff x="0" y="0"/>
+          <a:chExt cx="0" cy="0"/>
+        </a:xfrm>
+      </p:grpSpPr>
+      <p:pic>
+        <p:nvPicPr>
+          <p:cNvPr id="5" name="Picture 4">
+            <a:extLst>
+              <a:ext uri="{FF2B5EF4-FFF2-40B4-BE49-F238E27FC236}">
+                <a16:creationId xmlns:a16="http://schemas.microsoft.com/office/drawing/2014/main" id="{FCAA996A-572F-3A44-9C59-61D35639F6B8}"/>
+              </a:ext>
+            </a:extLst>
+          </p:cNvPr>
+          <p:cNvPicPr>
+            <a:picLocks noChangeAspect="1"/>
+          </p:cNvPicPr>
+          <p:nvPr/>
+        </p:nvPicPr>
+        <p:blipFill>
+          <a:blip r:embed="rId2"/>
+          <a:stretch>
+            <a:fillRect/>
+          </a:stretch>
+        </p:blipFill>
+        <p:spPr>
+          <a:xfrm>
+            <a:off x="451630" y="597648"/>
+            <a:ext cx="6357962" cy="5662703"/>
+          </a:xfrm>
+          <a:prstGeom prst="rect">
+            <a:avLst/>
+          </a:prstGeom>
+        </p:spPr>
+      </p:pic>
+      <p:sp>
+        <p:nvSpPr>
+          <p:cNvPr id="2" name="Titre 1">
+            <a:extLst>
+              <a:ext uri="{FF2B5EF4-FFF2-40B4-BE49-F238E27FC236}">
+                <a16:creationId xmlns:a16="http://schemas.microsoft.com/office/drawing/2014/main" id="{6F105A26-303C-8840-D40C-00BB8493D222}"/>
+              </a:ext>
+            </a:extLst>
+          </p:cNvPr>
+          <p:cNvSpPr>
+            <a:spLocks noGrp="1"/>
+          </p:cNvSpPr>
+          <p:nvPr>
+            <p:ph type="title"/>
+          </p:nvPr>
+        </p:nvSpPr>
+        <p:spPr>
+          <a:xfrm>
+            <a:off x="7213002" y="2766218"/>
+            <a:ext cx="4377466" cy="1325563"/>
+          </a:xfrm>
+        </p:spPr>
+        <p:txBody>
+          <a:bodyPr/>
+          <a:lstStyle/>
+          <a:p>
+            <a:pPr algn="ctr"/>
+            <a:r>
+              <a:rPr lang="fr-CH" b="1" dirty="0"/>
+              <a:t>Démonstration</a:t>
+            </a:r>
+          </a:p>
+        </p:txBody>
+      </p:sp>
+    </p:spTree>
+    <p:extLst>
+      <p:ext uri="{BB962C8B-B14F-4D97-AF65-F5344CB8AC3E}">
+        <p14:creationId xmlns:p14="http://schemas.microsoft.com/office/powerpoint/2010/main" val="359236659"/>
+      </p:ext>
+    </p:extLst>
+  </p:cSld>
+  <p:clrMapOvr>
+    <a:masterClrMapping/>
+  </p:clrMapOvr>
+</p:sld>
+</file>
+
 <file path=ppt/slides/slide2.xml><?xml version="1.0" encoding="utf-8"?>
 <p:sld xmlns:a="http://schemas.openxmlformats.org/drawingml/2006/main" xmlns:r="http://schemas.openxmlformats.org/officeDocument/2006/relationships" xmlns:p="http://schemas.openxmlformats.org/presentationml/2006/main">
   <p:cSld>
@@ -3596,10 +3789,10 @@
       </p:sp>
       <p:pic>
         <p:nvPicPr>
-          <p:cNvPr id="5" name="Espace réservé du contenu 4">
-            <a:extLst>
-              <a:ext uri="{FF2B5EF4-FFF2-40B4-BE49-F238E27FC236}">
-                <a16:creationId xmlns:a16="http://schemas.microsoft.com/office/drawing/2014/main" id="{07BC83B2-1E85-3DE8-28CB-EEC0F20C5202}"/>
+          <p:cNvPr id="7" name="Espace réservé du contenu 6">
+            <a:extLst>
+              <a:ext uri="{FF2B5EF4-FFF2-40B4-BE49-F238E27FC236}">
+                <a16:creationId xmlns:a16="http://schemas.microsoft.com/office/drawing/2014/main" id="{46145EAE-B2DC-7C6C-6A5F-2F186CDA0BA8}"/>
               </a:ext>
             </a:extLst>
           </p:cNvPr>
@@ -3624,14 +3817,79 @@
         </p:blipFill>
         <p:spPr>
           <a:xfrm>
-            <a:off x="6331752" y="263387"/>
-            <a:ext cx="5400421" cy="6331226"/>
+            <a:off x="5363066" y="530144"/>
+            <a:ext cx="5620243" cy="5594869"/>
           </a:xfrm>
           <a:prstGeom prst="rect">
             <a:avLst/>
           </a:prstGeom>
         </p:spPr>
       </p:pic>
+      <p:sp>
+        <p:nvSpPr>
+          <p:cNvPr id="8" name="ZoneTexte 7">
+            <a:extLst>
+              <a:ext uri="{FF2B5EF4-FFF2-40B4-BE49-F238E27FC236}">
+                <a16:creationId xmlns:a16="http://schemas.microsoft.com/office/drawing/2014/main" id="{622F10BA-8BDE-647C-2FE3-05E029519E53}"/>
+              </a:ext>
+            </a:extLst>
+          </p:cNvPr>
+          <p:cNvSpPr txBox="1"/>
+          <p:nvPr/>
+        </p:nvSpPr>
+        <p:spPr>
+          <a:xfrm>
+            <a:off x="725214" y="2343807"/>
+            <a:ext cx="4267361" cy="1754326"/>
+          </a:xfrm>
+          <a:prstGeom prst="rect">
+            <a:avLst/>
+          </a:prstGeom>
+          <a:noFill/>
+        </p:spPr>
+        <p:txBody>
+          <a:bodyPr wrap="square" rtlCol="0">
+            <a:spAutoFit/>
+          </a:bodyPr>
+          <a:lstStyle/>
+          <a:p>
+            <a:r>
+              <a:rPr lang="fr-FR" dirty="0"/>
+              <a:t>Changement:</a:t>
+            </a:r>
+          </a:p>
+          <a:p>
+            <a:endParaRPr lang="fr-FR" dirty="0"/>
+          </a:p>
+          <a:p>
+            <a:pPr marL="285750" indent="-285750">
+              <a:buFontTx/>
+              <a:buChar char="-"/>
+            </a:pPr>
+            <a:r>
+              <a:rPr lang="fr-FR" dirty="0"/>
+              <a:t>Deux plateaux de jeu</a:t>
+            </a:r>
+          </a:p>
+          <a:p>
+            <a:pPr marL="285750" indent="-285750">
+              <a:buFontTx/>
+              <a:buChar char="-"/>
+            </a:pPr>
+            <a:endParaRPr lang="fr-FR" dirty="0"/>
+          </a:p>
+          <a:p>
+            <a:pPr marL="285750" indent="-285750">
+              <a:buFontTx/>
+              <a:buChar char="-"/>
+            </a:pPr>
+            <a:r>
+              <a:rPr lang="fr-FR" dirty="0"/>
+              <a:t>Les joueurs peuvent choisir le plateau sur lequel jouer entre chaque partie</a:t>
+            </a:r>
+          </a:p>
+        </p:txBody>
+      </p:sp>
     </p:spTree>
     <p:extLst>
       <p:ext uri="{BB962C8B-B14F-4D97-AF65-F5344CB8AC3E}">
@@ -3693,10 +3951,10 @@
       </p:sp>
       <p:pic>
         <p:nvPicPr>
-          <p:cNvPr id="5" name="Espace réservé du contenu 4">
-            <a:extLst>
-              <a:ext uri="{FF2B5EF4-FFF2-40B4-BE49-F238E27FC236}">
-                <a16:creationId xmlns:a16="http://schemas.microsoft.com/office/drawing/2014/main" id="{31E676A1-39B9-2806-A677-B2E9665FA8A3}"/>
+          <p:cNvPr id="7" name="Espace réservé du contenu 6">
+            <a:extLst>
+              <a:ext uri="{FF2B5EF4-FFF2-40B4-BE49-F238E27FC236}">
+                <a16:creationId xmlns:a16="http://schemas.microsoft.com/office/drawing/2014/main" id="{4987C348-78D1-4E51-9D58-97A6D15A2FAC}"/>
               </a:ext>
             </a:extLst>
           </p:cNvPr>
@@ -3721,14 +3979,103 @@
         </p:blipFill>
         <p:spPr>
           <a:xfrm>
-            <a:off x="2652548" y="517100"/>
-            <a:ext cx="8969221" cy="5823799"/>
+            <a:off x="4377894" y="234022"/>
+            <a:ext cx="6975906" cy="6258853"/>
           </a:xfrm>
           <a:prstGeom prst="rect">
             <a:avLst/>
           </a:prstGeom>
         </p:spPr>
       </p:pic>
+      <p:sp>
+        <p:nvSpPr>
+          <p:cNvPr id="8" name="ZoneTexte 7">
+            <a:extLst>
+              <a:ext uri="{FF2B5EF4-FFF2-40B4-BE49-F238E27FC236}">
+                <a16:creationId xmlns:a16="http://schemas.microsoft.com/office/drawing/2014/main" id="{8486416A-D519-8D5D-A582-E2519E7B9110}"/>
+              </a:ext>
+            </a:extLst>
+          </p:cNvPr>
+          <p:cNvSpPr txBox="1"/>
+          <p:nvPr/>
+        </p:nvSpPr>
+        <p:spPr>
+          <a:xfrm>
+            <a:off x="262759" y="1690688"/>
+            <a:ext cx="4035972" cy="3416320"/>
+          </a:xfrm>
+          <a:prstGeom prst="rect">
+            <a:avLst/>
+          </a:prstGeom>
+          <a:noFill/>
+        </p:spPr>
+        <p:txBody>
+          <a:bodyPr wrap="square" rtlCol="0">
+            <a:spAutoFit/>
+          </a:bodyPr>
+          <a:lstStyle/>
+          <a:p>
+            <a:r>
+              <a:rPr lang="fr-FR" dirty="0"/>
+              <a:t>Changements:</a:t>
+            </a:r>
+          </a:p>
+          <a:p>
+            <a:endParaRPr lang="fr-FR" dirty="0"/>
+          </a:p>
+          <a:p>
+            <a:pPr marL="285750" indent="-285750">
+              <a:buFontTx/>
+              <a:buChar char="-"/>
+            </a:pPr>
+            <a:r>
+              <a:rPr lang="fr-FR" dirty="0"/>
+              <a:t>Player Handling se charge maintenant de l’authentification</a:t>
+            </a:r>
+          </a:p>
+          <a:p>
+            <a:pPr marL="285750" indent="-285750">
+              <a:buFontTx/>
+              <a:buChar char="-"/>
+            </a:pPr>
+            <a:endParaRPr lang="fr-FR" dirty="0"/>
+          </a:p>
+          <a:p>
+            <a:pPr marL="285750" indent="-285750">
+              <a:buFontTx/>
+              <a:buChar char="-"/>
+            </a:pPr>
+            <a:r>
+              <a:rPr lang="fr-FR" dirty="0"/>
+              <a:t>Au lieu de laisser les joueurs joindre la partie, il faut s’enregistrer et se login</a:t>
+            </a:r>
+          </a:p>
+          <a:p>
+            <a:pPr marL="285750" indent="-285750">
+              <a:buFontTx/>
+              <a:buChar char="-"/>
+            </a:pPr>
+            <a:endParaRPr lang="fr-FR" dirty="0"/>
+          </a:p>
+          <a:p>
+            <a:pPr marL="285750" indent="-285750">
+              <a:buFontTx/>
+              <a:buChar char="-"/>
+            </a:pPr>
+            <a:r>
+              <a:rPr lang="fr-FR" dirty="0"/>
+              <a:t>Les infos des joueurs sont persistantes</a:t>
+            </a:r>
+          </a:p>
+          <a:p>
+            <a:pPr marL="285750" indent="-285750">
+              <a:buFontTx/>
+              <a:buChar char="-"/>
+            </a:pPr>
+            <a:endParaRPr lang="fr-FR" dirty="0"/>
+          </a:p>
+        </p:txBody>
+      </p:sp>
     </p:spTree>
     <p:extLst>
       <p:ext uri="{BB962C8B-B14F-4D97-AF65-F5344CB8AC3E}">
@@ -3897,10 +4244,10 @@
       </p:sp>
       <p:pic>
         <p:nvPicPr>
-          <p:cNvPr id="5" name="Espace réservé du contenu 4">
-            <a:extLst>
-              <a:ext uri="{FF2B5EF4-FFF2-40B4-BE49-F238E27FC236}">
-                <a16:creationId xmlns:a16="http://schemas.microsoft.com/office/drawing/2014/main" id="{E1273B49-EDCC-BD74-D5C2-A66BCC4F03CD}"/>
+          <p:cNvPr id="15" name="Espace réservé du contenu 14">
+            <a:extLst>
+              <a:ext uri="{FF2B5EF4-FFF2-40B4-BE49-F238E27FC236}">
+                <a16:creationId xmlns:a16="http://schemas.microsoft.com/office/drawing/2014/main" id="{17C01AD7-76C3-A91C-9375-5D9B73813868}"/>
               </a:ext>
             </a:extLst>
           </p:cNvPr>
@@ -3925,14 +4272,77 @@
         </p:blipFill>
         <p:spPr>
           <a:xfrm>
-            <a:off x="775571" y="1792289"/>
-            <a:ext cx="10640858" cy="4450238"/>
+            <a:off x="956442" y="1485874"/>
+            <a:ext cx="9736752" cy="3380416"/>
           </a:xfrm>
           <a:prstGeom prst="rect">
             <a:avLst/>
           </a:prstGeom>
         </p:spPr>
       </p:pic>
+      <p:sp>
+        <p:nvSpPr>
+          <p:cNvPr id="16" name="ZoneTexte 15">
+            <a:extLst>
+              <a:ext uri="{FF2B5EF4-FFF2-40B4-BE49-F238E27FC236}">
+                <a16:creationId xmlns:a16="http://schemas.microsoft.com/office/drawing/2014/main" id="{49EC9D06-4915-AC97-BF0E-6B1E8A2A7C0D}"/>
+              </a:ext>
+            </a:extLst>
+          </p:cNvPr>
+          <p:cNvSpPr txBox="1"/>
+          <p:nvPr/>
+        </p:nvSpPr>
+        <p:spPr>
+          <a:xfrm>
+            <a:off x="725214" y="5213131"/>
+            <a:ext cx="10405241" cy="1200329"/>
+          </a:xfrm>
+          <a:prstGeom prst="rect">
+            <a:avLst/>
+          </a:prstGeom>
+          <a:noFill/>
+        </p:spPr>
+        <p:txBody>
+          <a:bodyPr wrap="square" rtlCol="0">
+            <a:spAutoFit/>
+          </a:bodyPr>
+          <a:lstStyle/>
+          <a:p>
+            <a:r>
+              <a:rPr lang="fr-FR" dirty="0"/>
+              <a:t>Changements:</a:t>
+            </a:r>
+          </a:p>
+          <a:p>
+            <a:pPr marL="285750" indent="-285750">
+              <a:buFontTx/>
+              <a:buChar char="-"/>
+            </a:pPr>
+            <a:r>
+              <a:rPr lang="fr-FR" dirty="0"/>
+              <a:t>Ajout d’un Game Storage (DB) pour sauvegarder les informations des joueurs</a:t>
+            </a:r>
+          </a:p>
+          <a:p>
+            <a:pPr marL="285750" indent="-285750">
+              <a:buFontTx/>
+              <a:buChar char="-"/>
+            </a:pPr>
+            <a:endParaRPr lang="fr-FR" dirty="0"/>
+          </a:p>
+          <a:p>
+            <a:pPr marL="285750" indent="-285750">
+              <a:buFontTx/>
+              <a:buChar char="-"/>
+            </a:pPr>
+            <a:r>
+              <a:rPr lang="fr-FR" dirty="0"/>
+              <a:t>Ajout d’un utilitaire pour chiffrer les communications</a:t>
+            </a:r>
+            <a:endParaRPr lang="fr-CH" dirty="0"/>
+          </a:p>
+        </p:txBody>
+      </p:sp>
     </p:spTree>
     <p:extLst>
       <p:ext uri="{BB962C8B-B14F-4D97-AF65-F5344CB8AC3E}">
@@ -3963,50 +4373,19 @@
           <a:chExt cx="0" cy="0"/>
         </a:xfrm>
       </p:grpSpPr>
-      <p:sp>
-        <p:nvSpPr>
-          <p:cNvPr id="2" name="Titre 1">
-            <a:extLst>
-              <a:ext uri="{FF2B5EF4-FFF2-40B4-BE49-F238E27FC236}">
-                <a16:creationId xmlns:a16="http://schemas.microsoft.com/office/drawing/2014/main" id="{6F8B31E1-F7FB-5E99-EA45-073B057750A6}"/>
-              </a:ext>
-            </a:extLst>
-          </p:cNvPr>
-          <p:cNvSpPr>
-            <a:spLocks noGrp="1"/>
-          </p:cNvSpPr>
-          <p:nvPr>
-            <p:ph type="title"/>
-          </p:nvPr>
-        </p:nvSpPr>
-        <p:spPr/>
-        <p:txBody>
-          <a:bodyPr/>
-          <a:lstStyle/>
-          <a:p>
-            <a:r>
-              <a:rPr lang="fr-FR" dirty="0"/>
-              <a:t>Diagramme de blocs</a:t>
-            </a:r>
-            <a:endParaRPr lang="fr-CH" dirty="0"/>
-          </a:p>
-        </p:txBody>
-      </p:sp>
       <p:pic>
         <p:nvPicPr>
-          <p:cNvPr id="5" name="Espace réservé du contenu 4">
-            <a:extLst>
-              <a:ext uri="{FF2B5EF4-FFF2-40B4-BE49-F238E27FC236}">
-                <a16:creationId xmlns:a16="http://schemas.microsoft.com/office/drawing/2014/main" id="{E89E930A-D959-FA9E-82AB-E2BB19F8313D}"/>
+          <p:cNvPr id="7" name="Image 6">
+            <a:extLst>
+              <a:ext uri="{FF2B5EF4-FFF2-40B4-BE49-F238E27FC236}">
+                <a16:creationId xmlns:a16="http://schemas.microsoft.com/office/drawing/2014/main" id="{34CD332B-F15E-0E2F-C8E9-76BE6EF1458A}"/>
               </a:ext>
             </a:extLst>
           </p:cNvPr>
           <p:cNvPicPr>
-            <a:picLocks noGrp="1" noChangeAspect="1"/>
+            <a:picLocks noChangeAspect="1"/>
           </p:cNvPicPr>
-          <p:nvPr>
-            <p:ph idx="1"/>
-          </p:nvPr>
+          <p:nvPr/>
         </p:nvPicPr>
         <p:blipFill>
           <a:blip r:embed="rId2">
@@ -4022,8 +4401,8 @@
         </p:blipFill>
         <p:spPr>
           <a:xfrm>
-            <a:off x="2862107" y="1393275"/>
-            <a:ext cx="6467785" cy="5099600"/>
+            <a:off x="415279" y="0"/>
+            <a:ext cx="11361441" cy="6858000"/>
           </a:xfrm>
           <a:prstGeom prst="rect">
             <a:avLst/>
@@ -4033,7 +4412,7 @@
     </p:spTree>
     <p:extLst>
       <p:ext uri="{BB962C8B-B14F-4D97-AF65-F5344CB8AC3E}">
-        <p14:creationId xmlns:p14="http://schemas.microsoft.com/office/powerpoint/2010/main" val="176408238"/>
+        <p14:creationId xmlns:p14="http://schemas.microsoft.com/office/powerpoint/2010/main" val="3081217100"/>
       </p:ext>
     </p:extLst>
   </p:cSld>
@@ -4060,41 +4439,12 @@
           <a:chExt cx="0" cy="0"/>
         </a:xfrm>
       </p:grpSpPr>
-      <p:sp>
-        <p:nvSpPr>
-          <p:cNvPr id="2" name="Titre 1">
-            <a:extLst>
-              <a:ext uri="{FF2B5EF4-FFF2-40B4-BE49-F238E27FC236}">
-                <a16:creationId xmlns:a16="http://schemas.microsoft.com/office/drawing/2014/main" id="{1F944A1B-5D11-648A-2775-DC7C5644520E}"/>
-              </a:ext>
-            </a:extLst>
-          </p:cNvPr>
-          <p:cNvSpPr>
-            <a:spLocks noGrp="1"/>
-          </p:cNvSpPr>
-          <p:nvPr>
-            <p:ph type="title"/>
-          </p:nvPr>
-        </p:nvSpPr>
-        <p:spPr/>
-        <p:txBody>
-          <a:bodyPr/>
-          <a:lstStyle/>
-          <a:p>
-            <a:r>
-              <a:rPr lang="fr-FR" dirty="0"/>
-              <a:t>Diagramme de déploiement</a:t>
-            </a:r>
-            <a:endParaRPr lang="fr-CH" dirty="0"/>
-          </a:p>
-        </p:txBody>
-      </p:sp>
       <p:pic>
         <p:nvPicPr>
           <p:cNvPr id="5" name="Espace réservé du contenu 4">
             <a:extLst>
               <a:ext uri="{FF2B5EF4-FFF2-40B4-BE49-F238E27FC236}">
-                <a16:creationId xmlns:a16="http://schemas.microsoft.com/office/drawing/2014/main" id="{C12F9334-8D35-9715-C0A0-0FA7393E9494}"/>
+                <a16:creationId xmlns:a16="http://schemas.microsoft.com/office/drawing/2014/main" id="{F0B4162C-C3D5-21C5-74B1-AB9A25B5132A}"/>
               </a:ext>
             </a:extLst>
           </p:cNvPr>
@@ -4119,8 +4469,8 @@
         </p:blipFill>
         <p:spPr>
           <a:xfrm>
-            <a:off x="386141" y="1690688"/>
-            <a:ext cx="11419718" cy="4459297"/>
+            <a:off x="642161" y="0"/>
+            <a:ext cx="10907678" cy="6858000"/>
           </a:xfrm>
           <a:prstGeom prst="rect">
             <a:avLst/>
@@ -4130,7 +4480,7 @@
     </p:spTree>
     <p:extLst>
       <p:ext uri="{BB962C8B-B14F-4D97-AF65-F5344CB8AC3E}">
-        <p14:creationId xmlns:p14="http://schemas.microsoft.com/office/powerpoint/2010/main" val="2074015821"/>
+        <p14:creationId xmlns:p14="http://schemas.microsoft.com/office/powerpoint/2010/main" val="2122524804"/>
       </p:ext>
     </p:extLst>
   </p:cSld>
@@ -4157,74 +4507,77 @@
           <a:chExt cx="0" cy="0"/>
         </a:xfrm>
       </p:grpSpPr>
+      <p:sp>
+        <p:nvSpPr>
+          <p:cNvPr id="2" name="Titre 1">
+            <a:extLst>
+              <a:ext uri="{FF2B5EF4-FFF2-40B4-BE49-F238E27FC236}">
+                <a16:creationId xmlns:a16="http://schemas.microsoft.com/office/drawing/2014/main" id="{6F8B31E1-F7FB-5E99-EA45-073B057750A6}"/>
+              </a:ext>
+            </a:extLst>
+          </p:cNvPr>
+          <p:cNvSpPr>
+            <a:spLocks noGrp="1"/>
+          </p:cNvSpPr>
+          <p:nvPr>
+            <p:ph type="title"/>
+          </p:nvPr>
+        </p:nvSpPr>
+        <p:spPr/>
+        <p:txBody>
+          <a:bodyPr/>
+          <a:lstStyle/>
+          <a:p>
+            <a:r>
+              <a:rPr lang="fr-FR" dirty="0"/>
+              <a:t>Diagramme de classes</a:t>
+            </a:r>
+            <a:endParaRPr lang="fr-CH" dirty="0"/>
+          </a:p>
+        </p:txBody>
+      </p:sp>
       <p:pic>
         <p:nvPicPr>
-          <p:cNvPr id="5" name="Picture 4">
-            <a:extLst>
-              <a:ext uri="{FF2B5EF4-FFF2-40B4-BE49-F238E27FC236}">
-                <a16:creationId xmlns:a16="http://schemas.microsoft.com/office/drawing/2014/main" id="{FCAA996A-572F-3A44-9C59-61D35639F6B8}"/>
+          <p:cNvPr id="7" name="Espace réservé du contenu 6">
+            <a:extLst>
+              <a:ext uri="{FF2B5EF4-FFF2-40B4-BE49-F238E27FC236}">
+                <a16:creationId xmlns:a16="http://schemas.microsoft.com/office/drawing/2014/main" id="{D8B6CC18-9E52-AC71-36F7-498250F244B7}"/>
               </a:ext>
             </a:extLst>
           </p:cNvPr>
           <p:cNvPicPr>
-            <a:picLocks noChangeAspect="1"/>
+            <a:picLocks noGrp="1" noChangeAspect="1"/>
           </p:cNvPicPr>
-          <p:nvPr/>
+          <p:nvPr>
+            <p:ph idx="1"/>
+          </p:nvPr>
         </p:nvPicPr>
         <p:blipFill>
-          <a:blip r:embed="rId2"/>
+          <a:blip r:embed="rId2">
+            <a:extLst>
+              <a:ext uri="{28A0092B-C50C-407E-A947-70E740481C1C}">
+                <a14:useLocalDpi xmlns:a14="http://schemas.microsoft.com/office/drawing/2010/main" val="0"/>
+              </a:ext>
+            </a:extLst>
+          </a:blip>
           <a:stretch>
             <a:fillRect/>
           </a:stretch>
         </p:blipFill>
         <p:spPr>
           <a:xfrm>
-            <a:off x="451630" y="597648"/>
-            <a:ext cx="6357962" cy="5662703"/>
+            <a:off x="1690445" y="1496026"/>
+            <a:ext cx="8811110" cy="4996849"/>
           </a:xfrm>
           <a:prstGeom prst="rect">
             <a:avLst/>
           </a:prstGeom>
         </p:spPr>
       </p:pic>
-      <p:sp>
-        <p:nvSpPr>
-          <p:cNvPr id="2" name="Titre 1">
-            <a:extLst>
-              <a:ext uri="{FF2B5EF4-FFF2-40B4-BE49-F238E27FC236}">
-                <a16:creationId xmlns:a16="http://schemas.microsoft.com/office/drawing/2014/main" id="{6F105A26-303C-8840-D40C-00BB8493D222}"/>
-              </a:ext>
-            </a:extLst>
-          </p:cNvPr>
-          <p:cNvSpPr>
-            <a:spLocks noGrp="1"/>
-          </p:cNvSpPr>
-          <p:nvPr>
-            <p:ph type="title"/>
-          </p:nvPr>
-        </p:nvSpPr>
-        <p:spPr>
-          <a:xfrm>
-            <a:off x="7213002" y="2766218"/>
-            <a:ext cx="4377466" cy="1325563"/>
-          </a:xfrm>
-        </p:spPr>
-        <p:txBody>
-          <a:bodyPr/>
-          <a:lstStyle/>
-          <a:p>
-            <a:pPr algn="ctr"/>
-            <a:r>
-              <a:rPr lang="fr-CH" b="1" dirty="0"/>
-              <a:t>Démonstration</a:t>
-            </a:r>
-          </a:p>
-        </p:txBody>
-      </p:sp>
     </p:spTree>
     <p:extLst>
       <p:ext uri="{BB962C8B-B14F-4D97-AF65-F5344CB8AC3E}">
-        <p14:creationId xmlns:p14="http://schemas.microsoft.com/office/powerpoint/2010/main" val="359236659"/>
+        <p14:creationId xmlns:p14="http://schemas.microsoft.com/office/powerpoint/2010/main" val="176408238"/>
       </p:ext>
     </p:extLst>
   </p:cSld>

</xml_diff>

<commit_message>
added security slide info
</commit_message>
<xml_diff>
--- a/doc/presentation.pptx
+++ b/doc/presentation.pptx
@@ -7,7 +7,7 @@
   <p:sldIdLst>
     <p:sldId id="256" r:id="rId2"/>
     <p:sldId id="257" r:id="rId3"/>
-    <p:sldId id="267" r:id="rId4"/>
+    <p:sldId id="274" r:id="rId4"/>
     <p:sldId id="268" r:id="rId5"/>
     <p:sldId id="269" r:id="rId6"/>
     <p:sldId id="270" r:id="rId7"/>
@@ -17,7 +17,7 @@
     <p:sldId id="261" r:id="rId11"/>
     <p:sldId id="265" r:id="rId12"/>
     <p:sldId id="266" r:id="rId13"/>
-    <p:sldId id="262" r:id="rId14"/>
+    <p:sldId id="273" r:id="rId14"/>
     <p:sldId id="263" r:id="rId15"/>
     <p:sldId id="271" r:id="rId16"/>
     <p:sldId id="272" r:id="rId17"/>
@@ -277,7 +277,7 @@
           <a:p>
             <a:fld id="{7D708B82-F97F-4828-9186-4C6AB2EFCAFD}" type="datetimeFigureOut">
               <a:rPr lang="en-CH" smtClean="0"/>
-              <a:t>27.05.2026</a:t>
+              <a:t>05/27/2026</a:t>
             </a:fld>
             <a:endParaRPr lang="en-CH"/>
           </a:p>
@@ -331,7 +331,7 @@
           <a:p>
             <a:fld id="{4DF3A20D-DBCC-4BDF-9F56-7F610081343B}" type="slidenum">
               <a:rPr lang="en-CH" smtClean="0"/>
-              <a:t>‹#›</a:t>
+              <a:t>‹N°›</a:t>
             </a:fld>
             <a:endParaRPr lang="en-CH"/>
           </a:p>
@@ -477,7 +477,7 @@
           <a:p>
             <a:fld id="{7D708B82-F97F-4828-9186-4C6AB2EFCAFD}" type="datetimeFigureOut">
               <a:rPr lang="en-CH" smtClean="0"/>
-              <a:t>27.05.2026</a:t>
+              <a:t>05/27/2026</a:t>
             </a:fld>
             <a:endParaRPr lang="en-CH"/>
           </a:p>
@@ -531,7 +531,7 @@
           <a:p>
             <a:fld id="{4DF3A20D-DBCC-4BDF-9F56-7F610081343B}" type="slidenum">
               <a:rPr lang="en-CH" smtClean="0"/>
-              <a:t>‹#›</a:t>
+              <a:t>‹N°›</a:t>
             </a:fld>
             <a:endParaRPr lang="en-CH"/>
           </a:p>
@@ -687,7 +687,7 @@
           <a:p>
             <a:fld id="{7D708B82-F97F-4828-9186-4C6AB2EFCAFD}" type="datetimeFigureOut">
               <a:rPr lang="en-CH" smtClean="0"/>
-              <a:t>27.05.2026</a:t>
+              <a:t>05/27/2026</a:t>
             </a:fld>
             <a:endParaRPr lang="en-CH"/>
           </a:p>
@@ -741,7 +741,7 @@
           <a:p>
             <a:fld id="{4DF3A20D-DBCC-4BDF-9F56-7F610081343B}" type="slidenum">
               <a:rPr lang="en-CH" smtClean="0"/>
-              <a:t>‹#›</a:t>
+              <a:t>‹N°›</a:t>
             </a:fld>
             <a:endParaRPr lang="en-CH"/>
           </a:p>
@@ -887,7 +887,7 @@
           <a:p>
             <a:fld id="{7D708B82-F97F-4828-9186-4C6AB2EFCAFD}" type="datetimeFigureOut">
               <a:rPr lang="en-CH" smtClean="0"/>
-              <a:t>27.05.2026</a:t>
+              <a:t>05/27/2026</a:t>
             </a:fld>
             <a:endParaRPr lang="en-CH"/>
           </a:p>
@@ -941,7 +941,7 @@
           <a:p>
             <a:fld id="{4DF3A20D-DBCC-4BDF-9F56-7F610081343B}" type="slidenum">
               <a:rPr lang="en-CH" smtClean="0"/>
-              <a:t>‹#›</a:t>
+              <a:t>‹N°›</a:t>
             </a:fld>
             <a:endParaRPr lang="en-CH"/>
           </a:p>
@@ -1163,7 +1163,7 @@
           <a:p>
             <a:fld id="{7D708B82-F97F-4828-9186-4C6AB2EFCAFD}" type="datetimeFigureOut">
               <a:rPr lang="en-CH" smtClean="0"/>
-              <a:t>27.05.2026</a:t>
+              <a:t>05/27/2026</a:t>
             </a:fld>
             <a:endParaRPr lang="en-CH"/>
           </a:p>
@@ -1217,7 +1217,7 @@
           <a:p>
             <a:fld id="{4DF3A20D-DBCC-4BDF-9F56-7F610081343B}" type="slidenum">
               <a:rPr lang="en-CH" smtClean="0"/>
-              <a:t>‹#›</a:t>
+              <a:t>‹N°›</a:t>
             </a:fld>
             <a:endParaRPr lang="en-CH"/>
           </a:p>
@@ -1431,7 +1431,7 @@
           <a:p>
             <a:fld id="{7D708B82-F97F-4828-9186-4C6AB2EFCAFD}" type="datetimeFigureOut">
               <a:rPr lang="en-CH" smtClean="0"/>
-              <a:t>27.05.2026</a:t>
+              <a:t>05/27/2026</a:t>
             </a:fld>
             <a:endParaRPr lang="en-CH"/>
           </a:p>
@@ -1485,7 +1485,7 @@
           <a:p>
             <a:fld id="{4DF3A20D-DBCC-4BDF-9F56-7F610081343B}" type="slidenum">
               <a:rPr lang="en-CH" smtClean="0"/>
-              <a:t>‹#›</a:t>
+              <a:t>‹N°›</a:t>
             </a:fld>
             <a:endParaRPr lang="en-CH"/>
           </a:p>
@@ -1846,7 +1846,7 @@
           <a:p>
             <a:fld id="{7D708B82-F97F-4828-9186-4C6AB2EFCAFD}" type="datetimeFigureOut">
               <a:rPr lang="en-CH" smtClean="0"/>
-              <a:t>27.05.2026</a:t>
+              <a:t>05/27/2026</a:t>
             </a:fld>
             <a:endParaRPr lang="en-CH"/>
           </a:p>
@@ -1900,7 +1900,7 @@
           <a:p>
             <a:fld id="{4DF3A20D-DBCC-4BDF-9F56-7F610081343B}" type="slidenum">
               <a:rPr lang="en-CH" smtClean="0"/>
-              <a:t>‹#›</a:t>
+              <a:t>‹N°›</a:t>
             </a:fld>
             <a:endParaRPr lang="en-CH"/>
           </a:p>
@@ -1988,7 +1988,7 @@
           <a:p>
             <a:fld id="{7D708B82-F97F-4828-9186-4C6AB2EFCAFD}" type="datetimeFigureOut">
               <a:rPr lang="en-CH" smtClean="0"/>
-              <a:t>27.05.2026</a:t>
+              <a:t>05/27/2026</a:t>
             </a:fld>
             <a:endParaRPr lang="en-CH"/>
           </a:p>
@@ -2042,7 +2042,7 @@
           <a:p>
             <a:fld id="{4DF3A20D-DBCC-4BDF-9F56-7F610081343B}" type="slidenum">
               <a:rPr lang="en-CH" smtClean="0"/>
-              <a:t>‹#›</a:t>
+              <a:t>‹N°›</a:t>
             </a:fld>
             <a:endParaRPr lang="en-CH"/>
           </a:p>
@@ -2101,7 +2101,7 @@
           <a:p>
             <a:fld id="{7D708B82-F97F-4828-9186-4C6AB2EFCAFD}" type="datetimeFigureOut">
               <a:rPr lang="en-CH" smtClean="0"/>
-              <a:t>27.05.2026</a:t>
+              <a:t>05/27/2026</a:t>
             </a:fld>
             <a:endParaRPr lang="en-CH"/>
           </a:p>
@@ -2155,7 +2155,7 @@
           <a:p>
             <a:fld id="{4DF3A20D-DBCC-4BDF-9F56-7F610081343B}" type="slidenum">
               <a:rPr lang="en-CH" smtClean="0"/>
-              <a:t>‹#›</a:t>
+              <a:t>‹N°›</a:t>
             </a:fld>
             <a:endParaRPr lang="en-CH"/>
           </a:p>
@@ -2414,7 +2414,7 @@
           <a:p>
             <a:fld id="{7D708B82-F97F-4828-9186-4C6AB2EFCAFD}" type="datetimeFigureOut">
               <a:rPr lang="en-CH" smtClean="0"/>
-              <a:t>27.05.2026</a:t>
+              <a:t>05/27/2026</a:t>
             </a:fld>
             <a:endParaRPr lang="en-CH"/>
           </a:p>
@@ -2468,7 +2468,7 @@
           <a:p>
             <a:fld id="{4DF3A20D-DBCC-4BDF-9F56-7F610081343B}" type="slidenum">
               <a:rPr lang="en-CH" smtClean="0"/>
-              <a:t>‹#›</a:t>
+              <a:t>‹N°›</a:t>
             </a:fld>
             <a:endParaRPr lang="en-CH"/>
           </a:p>
@@ -2703,7 +2703,7 @@
           <a:p>
             <a:fld id="{7D708B82-F97F-4828-9186-4C6AB2EFCAFD}" type="datetimeFigureOut">
               <a:rPr lang="en-CH" smtClean="0"/>
-              <a:t>27.05.2026</a:t>
+              <a:t>05/27/2026</a:t>
             </a:fld>
             <a:endParaRPr lang="en-CH"/>
           </a:p>
@@ -2757,7 +2757,7 @@
           <a:p>
             <a:fld id="{4DF3A20D-DBCC-4BDF-9F56-7F610081343B}" type="slidenum">
               <a:rPr lang="en-CH" smtClean="0"/>
-              <a:t>‹#›</a:t>
+              <a:t>‹N°›</a:t>
             </a:fld>
             <a:endParaRPr lang="en-CH"/>
           </a:p>
@@ -2946,7 +2946,7 @@
           <a:p>
             <a:fld id="{7D708B82-F97F-4828-9186-4C6AB2EFCAFD}" type="datetimeFigureOut">
               <a:rPr lang="en-CH" smtClean="0"/>
-              <a:t>27.05.2026</a:t>
+              <a:t>05/27/2026</a:t>
             </a:fld>
             <a:endParaRPr lang="en-CH"/>
           </a:p>
@@ -3036,7 +3036,7 @@
           <a:p>
             <a:fld id="{4DF3A20D-DBCC-4BDF-9F56-7F610081343B}" type="slidenum">
               <a:rPr lang="en-CH" smtClean="0"/>
-              <a:t>‹#›</a:t>
+              <a:t>‹N°›</a:t>
             </a:fld>
             <a:endParaRPr lang="en-CH"/>
           </a:p>
@@ -3805,18 +3805,90 @@
         </p:blipFill>
         <p:spPr>
           <a:xfrm>
-            <a:off x="1690445" y="1496026"/>
-            <a:ext cx="8811110" cy="4996849"/>
+            <a:off x="202467" y="1504340"/>
+            <a:ext cx="8692725" cy="4929712"/>
           </a:xfrm>
           <a:prstGeom prst="rect">
             <a:avLst/>
           </a:prstGeom>
         </p:spPr>
       </p:pic>
+      <p:sp>
+        <p:nvSpPr>
+          <p:cNvPr id="3" name="ZoneTexte 2">
+            <a:extLst>
+              <a:ext uri="{FF2B5EF4-FFF2-40B4-BE49-F238E27FC236}">
+                <a16:creationId xmlns:a16="http://schemas.microsoft.com/office/drawing/2014/main" id="{C6DFA2C3-AD1B-BA11-FA55-D2193C7065A1}"/>
+              </a:ext>
+            </a:extLst>
+          </p:cNvPr>
+          <p:cNvSpPr txBox="1"/>
+          <p:nvPr/>
+        </p:nvSpPr>
+        <p:spPr>
+          <a:xfrm>
+            <a:off x="9060873" y="1454727"/>
+            <a:ext cx="3050771" cy="2031325"/>
+          </a:xfrm>
+          <a:prstGeom prst="rect">
+            <a:avLst/>
+          </a:prstGeom>
+          <a:noFill/>
+        </p:spPr>
+        <p:txBody>
+          <a:bodyPr wrap="square" rtlCol="0">
+            <a:spAutoFit/>
+          </a:bodyPr>
+          <a:lstStyle/>
+          <a:p>
+            <a:r>
+              <a:rPr lang="fr-FR" dirty="0"/>
+              <a:t>Changements:</a:t>
+            </a:r>
+          </a:p>
+          <a:p>
+            <a:pPr marL="285750" indent="-285750">
+              <a:buFontTx/>
+              <a:buChar char="-"/>
+            </a:pPr>
+            <a:r>
+              <a:rPr lang="fr-FR" dirty="0"/>
+              <a:t>Deux </a:t>
+            </a:r>
+            <a:r>
+              <a:rPr lang="fr-FR" dirty="0" err="1"/>
+              <a:t>BoardState</a:t>
+            </a:r>
+            <a:r>
+              <a:rPr lang="fr-FR" dirty="0"/>
+              <a:t> au lieu de un</a:t>
+            </a:r>
+          </a:p>
+          <a:p>
+            <a:pPr marL="285750" indent="-285750">
+              <a:buFontTx/>
+              <a:buChar char="-"/>
+            </a:pPr>
+            <a:r>
+              <a:rPr lang="fr-FR" dirty="0"/>
+              <a:t>Ajout de </a:t>
+            </a:r>
+            <a:r>
+              <a:rPr lang="fr-FR" dirty="0" err="1"/>
+              <a:t>GameStorage</a:t>
+            </a:r>
+            <a:r>
+              <a:rPr lang="fr-FR" dirty="0"/>
+              <a:t> pour sauvegarder les comptes des joueurs et les résultats des parties</a:t>
+            </a:r>
+            <a:endParaRPr lang="fr-CH" dirty="0"/>
+          </a:p>
+        </p:txBody>
+      </p:sp>
     </p:spTree>
     <p:extLst>
       <p:ext uri="{BB962C8B-B14F-4D97-AF65-F5344CB8AC3E}">
-        <p14:creationId xmlns:p14="http://schemas.microsoft.com/office/powerpoint/2010/main" val="176408238"/>
+        <p14:creationId xmlns:p14="http://schemas.microsoft.com/office/powerpoint/2010/main" val="647219976"/>
       </p:ext>
     </p:extLst>
   </p:cSld>
@@ -4692,7 +4764,7 @@
               <a:rPr lang="en-US" b="1" dirty="0" err="1"/>
               <a:t>Securité</a:t>
             </a:r>
-            <a:endParaRPr lang="en-CH" b="1" dirty="0"/>
+            <a:endParaRPr lang="en-CH" dirty="0"/>
           </a:p>
         </p:txBody>
       </p:sp>
@@ -4721,31 +4793,40 @@
           <a:p>
             <a:r>
               <a:rPr lang="fr-FR" b="1" dirty="0"/>
-              <a:t>Projet initial :</a:t>
+              <a:t>Chiffrement des communications :</a:t>
             </a:r>
           </a:p>
           <a:p>
             <a:pPr lvl="1"/>
             <a:r>
               <a:rPr lang="fr-FR" dirty="0"/>
-              <a:t>Architecture : </a:t>
-            </a:r>
-            <a:r>
-              <a:rPr lang="fr-FR" i="1" dirty="0"/>
-              <a:t>Data </a:t>
-            </a:r>
-            <a:r>
-              <a:rPr lang="fr-FR" i="1" dirty="0" err="1"/>
-              <a:t>Centered</a:t>
-            </a:r>
-            <a:endParaRPr lang="fr-FR" i="1" dirty="0"/>
+              <a:t>Utilitaire </a:t>
+            </a:r>
+            <a:r>
+              <a:rPr lang="fr-FR" dirty="0" err="1"/>
+              <a:t>encryption.util</a:t>
+            </a:r>
+            <a:r>
+              <a:rPr lang="fr-FR" dirty="0"/>
+              <a:t> qui permet de chiffrer/déchiffrer des objets </a:t>
+            </a:r>
+            <a:r>
+              <a:rPr lang="fr-FR" dirty="0" err="1"/>
+              <a:t>json</a:t>
+            </a:r>
+            <a:endParaRPr lang="fr-FR" dirty="0"/>
           </a:p>
           <a:p>
             <a:pPr lvl="1"/>
             <a:r>
               <a:rPr lang="fr-FR" dirty="0"/>
-              <a:t>Jeu de roulette multijoueur</a:t>
-            </a:r>
+              <a:t>Les paquets sont chiffrés avant d’être envoyés dans le </a:t>
+            </a:r>
+            <a:r>
+              <a:rPr lang="fr-FR" dirty="0" err="1"/>
+              <a:t>WebSocket</a:t>
+            </a:r>
+            <a:endParaRPr lang="fr-FR" dirty="0"/>
           </a:p>
           <a:p>
             <a:pPr marL="457200" lvl="1" indent="0">
@@ -4756,49 +4837,45 @@
           <a:p>
             <a:r>
               <a:rPr lang="fr-FR" b="1" dirty="0"/>
-              <a:t>Phase 2 :</a:t>
+              <a:t>Gérer l’authentification des utilisateurs :</a:t>
             </a:r>
           </a:p>
           <a:p>
             <a:pPr lvl="1"/>
             <a:r>
-              <a:rPr lang="fr-FR" i="1" dirty="0"/>
-              <a:t>S : </a:t>
-            </a:r>
-            <a:r>
               <a:rPr lang="fr-FR" dirty="0"/>
-              <a:t>Système d’authentification et cryptage des échange de données</a:t>
+              <a:t>Sauvegarde des utilisateurs dans un fichier </a:t>
+            </a:r>
+            <a:r>
+              <a:rPr lang="fr-FR" dirty="0" err="1"/>
+              <a:t>json</a:t>
+            </a:r>
+            <a:r>
+              <a:rPr lang="fr-FR" dirty="0"/>
+              <a:t> qui fait office de DB</a:t>
             </a:r>
           </a:p>
           <a:p>
             <a:pPr lvl="1"/>
             <a:r>
-              <a:rPr lang="fr-FR" i="1" dirty="0"/>
-              <a:t>D :</a:t>
-            </a:r>
-            <a:r>
               <a:rPr lang="fr-FR" dirty="0"/>
-              <a:t> Tour transactionnel et persistant en cas de déconnexion</a:t>
-            </a:r>
-          </a:p>
-          <a:p>
-            <a:pPr lvl="1"/>
-            <a:r>
-              <a:rPr lang="fr-FR" i="1" dirty="0"/>
-              <a:t>M :</a:t>
+              <a:t>Pour se connecter, il faut fournir un </a:t>
+            </a:r>
+            <a:r>
+              <a:rPr lang="fr-FR" dirty="0" err="1"/>
+              <a:t>username</a:t>
             </a:r>
             <a:r>
               <a:rPr lang="fr-FR" dirty="0"/>
-              <a:t> Multiple plateau et paris sur une case</a:t>
-            </a:r>
-            <a:endParaRPr lang="fr-FR" i="1" dirty="0"/>
+              <a:t> et mot de passe qui sont comparés avec les utilisateurs stockés dans la base de données</a:t>
+            </a:r>
           </a:p>
         </p:txBody>
       </p:sp>
     </p:spTree>
     <p:extLst>
       <p:ext uri="{BB962C8B-B14F-4D97-AF65-F5344CB8AC3E}">
-        <p14:creationId xmlns:p14="http://schemas.microsoft.com/office/powerpoint/2010/main" val="2406016171"/>
+        <p14:creationId xmlns:p14="http://schemas.microsoft.com/office/powerpoint/2010/main" val="2115648596"/>
       </p:ext>
     </p:extLst>
   </p:cSld>

</xml_diff>

<commit_message>
added requirement diagram to ppt
</commit_message>
<xml_diff>
--- a/doc/presentation.pptx
+++ b/doc/presentation.pptx
@@ -14,7 +14,7 @@
     <p:sldId id="270" r:id="rId8"/>
     <p:sldId id="258" r:id="rId9"/>
     <p:sldId id="259" r:id="rId10"/>
-    <p:sldId id="260" r:id="rId11"/>
+    <p:sldId id="277" r:id="rId11"/>
     <p:sldId id="261" r:id="rId12"/>
     <p:sldId id="265" r:id="rId13"/>
     <p:sldId id="266" r:id="rId14"/>
@@ -278,7 +278,7 @@
           <a:p>
             <a:fld id="{7D708B82-F97F-4828-9186-4C6AB2EFCAFD}" type="datetimeFigureOut">
               <a:rPr lang="en-CH" smtClean="0"/>
-              <a:t>27.05.2026</a:t>
+              <a:t>05/27/2026</a:t>
             </a:fld>
             <a:endParaRPr lang="en-CH"/>
           </a:p>
@@ -332,7 +332,7 @@
           <a:p>
             <a:fld id="{4DF3A20D-DBCC-4BDF-9F56-7F610081343B}" type="slidenum">
               <a:rPr lang="en-CH" smtClean="0"/>
-              <a:t>‹#›</a:t>
+              <a:t>‹N°›</a:t>
             </a:fld>
             <a:endParaRPr lang="en-CH"/>
           </a:p>
@@ -478,7 +478,7 @@
           <a:p>
             <a:fld id="{7D708B82-F97F-4828-9186-4C6AB2EFCAFD}" type="datetimeFigureOut">
               <a:rPr lang="en-CH" smtClean="0"/>
-              <a:t>27.05.2026</a:t>
+              <a:t>05/27/2026</a:t>
             </a:fld>
             <a:endParaRPr lang="en-CH"/>
           </a:p>
@@ -532,7 +532,7 @@
           <a:p>
             <a:fld id="{4DF3A20D-DBCC-4BDF-9F56-7F610081343B}" type="slidenum">
               <a:rPr lang="en-CH" smtClean="0"/>
-              <a:t>‹#›</a:t>
+              <a:t>‹N°›</a:t>
             </a:fld>
             <a:endParaRPr lang="en-CH"/>
           </a:p>
@@ -688,7 +688,7 @@
           <a:p>
             <a:fld id="{7D708B82-F97F-4828-9186-4C6AB2EFCAFD}" type="datetimeFigureOut">
               <a:rPr lang="en-CH" smtClean="0"/>
-              <a:t>27.05.2026</a:t>
+              <a:t>05/27/2026</a:t>
             </a:fld>
             <a:endParaRPr lang="en-CH"/>
           </a:p>
@@ -742,7 +742,7 @@
           <a:p>
             <a:fld id="{4DF3A20D-DBCC-4BDF-9F56-7F610081343B}" type="slidenum">
               <a:rPr lang="en-CH" smtClean="0"/>
-              <a:t>‹#›</a:t>
+              <a:t>‹N°›</a:t>
             </a:fld>
             <a:endParaRPr lang="en-CH"/>
           </a:p>
@@ -888,7 +888,7 @@
           <a:p>
             <a:fld id="{7D708B82-F97F-4828-9186-4C6AB2EFCAFD}" type="datetimeFigureOut">
               <a:rPr lang="en-CH" smtClean="0"/>
-              <a:t>27.05.2026</a:t>
+              <a:t>05/27/2026</a:t>
             </a:fld>
             <a:endParaRPr lang="en-CH"/>
           </a:p>
@@ -942,7 +942,7 @@
           <a:p>
             <a:fld id="{4DF3A20D-DBCC-4BDF-9F56-7F610081343B}" type="slidenum">
               <a:rPr lang="en-CH" smtClean="0"/>
-              <a:t>‹#›</a:t>
+              <a:t>‹N°›</a:t>
             </a:fld>
             <a:endParaRPr lang="en-CH"/>
           </a:p>
@@ -1164,7 +1164,7 @@
           <a:p>
             <a:fld id="{7D708B82-F97F-4828-9186-4C6AB2EFCAFD}" type="datetimeFigureOut">
               <a:rPr lang="en-CH" smtClean="0"/>
-              <a:t>27.05.2026</a:t>
+              <a:t>05/27/2026</a:t>
             </a:fld>
             <a:endParaRPr lang="en-CH"/>
           </a:p>
@@ -1218,7 +1218,7 @@
           <a:p>
             <a:fld id="{4DF3A20D-DBCC-4BDF-9F56-7F610081343B}" type="slidenum">
               <a:rPr lang="en-CH" smtClean="0"/>
-              <a:t>‹#›</a:t>
+              <a:t>‹N°›</a:t>
             </a:fld>
             <a:endParaRPr lang="en-CH"/>
           </a:p>
@@ -1432,7 +1432,7 @@
           <a:p>
             <a:fld id="{7D708B82-F97F-4828-9186-4C6AB2EFCAFD}" type="datetimeFigureOut">
               <a:rPr lang="en-CH" smtClean="0"/>
-              <a:t>27.05.2026</a:t>
+              <a:t>05/27/2026</a:t>
             </a:fld>
             <a:endParaRPr lang="en-CH"/>
           </a:p>
@@ -1486,7 +1486,7 @@
           <a:p>
             <a:fld id="{4DF3A20D-DBCC-4BDF-9F56-7F610081343B}" type="slidenum">
               <a:rPr lang="en-CH" smtClean="0"/>
-              <a:t>‹#›</a:t>
+              <a:t>‹N°›</a:t>
             </a:fld>
             <a:endParaRPr lang="en-CH"/>
           </a:p>
@@ -1847,7 +1847,7 @@
           <a:p>
             <a:fld id="{7D708B82-F97F-4828-9186-4C6AB2EFCAFD}" type="datetimeFigureOut">
               <a:rPr lang="en-CH" smtClean="0"/>
-              <a:t>27.05.2026</a:t>
+              <a:t>05/27/2026</a:t>
             </a:fld>
             <a:endParaRPr lang="en-CH"/>
           </a:p>
@@ -1901,7 +1901,7 @@
           <a:p>
             <a:fld id="{4DF3A20D-DBCC-4BDF-9F56-7F610081343B}" type="slidenum">
               <a:rPr lang="en-CH" smtClean="0"/>
-              <a:t>‹#›</a:t>
+              <a:t>‹N°›</a:t>
             </a:fld>
             <a:endParaRPr lang="en-CH"/>
           </a:p>
@@ -1989,7 +1989,7 @@
           <a:p>
             <a:fld id="{7D708B82-F97F-4828-9186-4C6AB2EFCAFD}" type="datetimeFigureOut">
               <a:rPr lang="en-CH" smtClean="0"/>
-              <a:t>27.05.2026</a:t>
+              <a:t>05/27/2026</a:t>
             </a:fld>
             <a:endParaRPr lang="en-CH"/>
           </a:p>
@@ -2043,7 +2043,7 @@
           <a:p>
             <a:fld id="{4DF3A20D-DBCC-4BDF-9F56-7F610081343B}" type="slidenum">
               <a:rPr lang="en-CH" smtClean="0"/>
-              <a:t>‹#›</a:t>
+              <a:t>‹N°›</a:t>
             </a:fld>
             <a:endParaRPr lang="en-CH"/>
           </a:p>
@@ -2102,7 +2102,7 @@
           <a:p>
             <a:fld id="{7D708B82-F97F-4828-9186-4C6AB2EFCAFD}" type="datetimeFigureOut">
               <a:rPr lang="en-CH" smtClean="0"/>
-              <a:t>27.05.2026</a:t>
+              <a:t>05/27/2026</a:t>
             </a:fld>
             <a:endParaRPr lang="en-CH"/>
           </a:p>
@@ -2156,7 +2156,7 @@
           <a:p>
             <a:fld id="{4DF3A20D-DBCC-4BDF-9F56-7F610081343B}" type="slidenum">
               <a:rPr lang="en-CH" smtClean="0"/>
-              <a:t>‹#›</a:t>
+              <a:t>‹N°›</a:t>
             </a:fld>
             <a:endParaRPr lang="en-CH"/>
           </a:p>
@@ -2415,7 +2415,7 @@
           <a:p>
             <a:fld id="{7D708B82-F97F-4828-9186-4C6AB2EFCAFD}" type="datetimeFigureOut">
               <a:rPr lang="en-CH" smtClean="0"/>
-              <a:t>27.05.2026</a:t>
+              <a:t>05/27/2026</a:t>
             </a:fld>
             <a:endParaRPr lang="en-CH"/>
           </a:p>
@@ -2469,7 +2469,7 @@
           <a:p>
             <a:fld id="{4DF3A20D-DBCC-4BDF-9F56-7F610081343B}" type="slidenum">
               <a:rPr lang="en-CH" smtClean="0"/>
-              <a:t>‹#›</a:t>
+              <a:t>‹N°›</a:t>
             </a:fld>
             <a:endParaRPr lang="en-CH"/>
           </a:p>
@@ -2704,7 +2704,7 @@
           <a:p>
             <a:fld id="{7D708B82-F97F-4828-9186-4C6AB2EFCAFD}" type="datetimeFigureOut">
               <a:rPr lang="en-CH" smtClean="0"/>
-              <a:t>27.05.2026</a:t>
+              <a:t>05/27/2026</a:t>
             </a:fld>
             <a:endParaRPr lang="en-CH"/>
           </a:p>
@@ -2758,7 +2758,7 @@
           <a:p>
             <a:fld id="{4DF3A20D-DBCC-4BDF-9F56-7F610081343B}" type="slidenum">
               <a:rPr lang="en-CH" smtClean="0"/>
-              <a:t>‹#›</a:t>
+              <a:t>‹N°›</a:t>
             </a:fld>
             <a:endParaRPr lang="en-CH"/>
           </a:p>
@@ -2947,7 +2947,7 @@
           <a:p>
             <a:fld id="{7D708B82-F97F-4828-9186-4C6AB2EFCAFD}" type="datetimeFigureOut">
               <a:rPr lang="en-CH" smtClean="0"/>
-              <a:t>27.05.2026</a:t>
+              <a:t>05/27/2026</a:t>
             </a:fld>
             <a:endParaRPr lang="en-CH"/>
           </a:p>
@@ -3037,7 +3037,7 @@
           <a:p>
             <a:fld id="{4DF3A20D-DBCC-4BDF-9F56-7F610081343B}" type="slidenum">
               <a:rPr lang="en-CH" smtClean="0"/>
-              <a:t>‹#›</a:t>
+              <a:t>‹N°›</a:t>
             </a:fld>
             <a:endParaRPr lang="en-CH"/>
           </a:p>
@@ -3445,7 +3445,13 @@
   <p:cSld>
     <p:spTree>
       <p:nvGrpSpPr>
-        <p:cNvPr id="1" name=""/>
+        <p:cNvPr id="1" name="">
+          <a:extLst>
+            <a:ext uri="{FF2B5EF4-FFF2-40B4-BE49-F238E27FC236}">
+              <a16:creationId xmlns:a16="http://schemas.microsoft.com/office/drawing/2014/main" id="{20B8BF12-01CB-D324-E934-33F00DD39736}"/>
+            </a:ext>
+          </a:extLst>
+        </p:cNvPr>
         <p:cNvGrpSpPr/>
         <p:nvPr/>
       </p:nvGrpSpPr>
@@ -3462,7 +3468,7 @@
           <p:cNvPr id="2" name="Title 1">
             <a:extLst>
               <a:ext uri="{FF2B5EF4-FFF2-40B4-BE49-F238E27FC236}">
-                <a16:creationId xmlns:a16="http://schemas.microsoft.com/office/drawing/2014/main" id="{C7EB8027-468C-33F7-41AF-F5FA092620F3}"/>
+                <a16:creationId xmlns:a16="http://schemas.microsoft.com/office/drawing/2014/main" id="{33127BF4-153D-CA42-89C5-5EDA17292686}"/>
               </a:ext>
             </a:extLst>
           </p:cNvPr>
@@ -3498,10 +3504,10 @@
       </p:sp>
       <p:pic>
         <p:nvPicPr>
-          <p:cNvPr id="5" name="Espace réservé du contenu 4">
-            <a:extLst>
-              <a:ext uri="{FF2B5EF4-FFF2-40B4-BE49-F238E27FC236}">
-                <a16:creationId xmlns:a16="http://schemas.microsoft.com/office/drawing/2014/main" id="{73D1D0EA-95B7-C95A-E441-AE4DC24E6849}"/>
+          <p:cNvPr id="7" name="Espace réservé du contenu 6">
+            <a:extLst>
+              <a:ext uri="{FF2B5EF4-FFF2-40B4-BE49-F238E27FC236}">
+                <a16:creationId xmlns:a16="http://schemas.microsoft.com/office/drawing/2014/main" id="{138B8316-3ABD-17BC-642C-1D81BA5AF409}"/>
               </a:ext>
             </a:extLst>
           </p:cNvPr>
@@ -3526,8 +3532,8 @@
         </p:blipFill>
         <p:spPr>
           <a:xfrm>
-            <a:off x="1408355" y="764819"/>
-            <a:ext cx="8461807" cy="5728055"/>
+            <a:off x="1250178" y="692092"/>
+            <a:ext cx="9691644" cy="6039784"/>
           </a:xfrm>
           <a:prstGeom prst="rect">
             <a:avLst/>
@@ -3537,7 +3543,7 @@
     </p:spTree>
     <p:extLst>
       <p:ext uri="{BB962C8B-B14F-4D97-AF65-F5344CB8AC3E}">
-        <p14:creationId xmlns:p14="http://schemas.microsoft.com/office/powerpoint/2010/main" val="1821189700"/>
+        <p14:creationId xmlns:p14="http://schemas.microsoft.com/office/powerpoint/2010/main" val="2113619717"/>
       </p:ext>
     </p:extLst>
   </p:cSld>

</xml_diff>

<commit_message>
updated ppt explanation for component diagram + moved the network capture demo
</commit_message>
<xml_diff>
--- a/doc/presentation.pptx
+++ b/doc/presentation.pptx
@@ -4,6 +4,9 @@
   <p:sldMasterIdLst>
     <p:sldMasterId id="2147483648" r:id="rId1"/>
   </p:sldMasterIdLst>
+  <p:notesMasterIdLst>
+    <p:notesMasterId r:id="rId19"/>
+  </p:notesMasterIdLst>
   <p:sldIdLst>
     <p:sldId id="256" r:id="rId2"/>
     <p:sldId id="257" r:id="rId3"/>
@@ -16,13 +19,12 @@
     <p:sldId id="259" r:id="rId10"/>
     <p:sldId id="277" r:id="rId11"/>
     <p:sldId id="261" r:id="rId12"/>
-    <p:sldId id="265" r:id="rId13"/>
-    <p:sldId id="266" r:id="rId14"/>
-    <p:sldId id="273" r:id="rId15"/>
-    <p:sldId id="263" r:id="rId16"/>
-    <p:sldId id="271" r:id="rId17"/>
-    <p:sldId id="272" r:id="rId18"/>
-    <p:sldId id="264" r:id="rId19"/>
+    <p:sldId id="273" r:id="rId13"/>
+    <p:sldId id="263" r:id="rId14"/>
+    <p:sldId id="271" r:id="rId15"/>
+    <p:sldId id="272" r:id="rId16"/>
+    <p:sldId id="265" r:id="rId17"/>
+    <p:sldId id="264" r:id="rId18"/>
   </p:sldIdLst>
   <p:sldSz cx="12192000" cy="6858000"/>
   <p:notesSz cx="6858000" cy="9144000"/>
@@ -127,6 +129,452 @@
     </p:ext>
   </p:extLst>
 </p:presentation>
+</file>
+
+<file path=ppt/notesMasters/notesMaster1.xml><?xml version="1.0" encoding="utf-8"?>
+<p:notesMaster xmlns:a="http://schemas.openxmlformats.org/drawingml/2006/main" xmlns:r="http://schemas.openxmlformats.org/officeDocument/2006/relationships" xmlns:p="http://schemas.openxmlformats.org/presentationml/2006/main">
+  <p:cSld>
+    <p:bg>
+      <p:bgRef idx="1001">
+        <a:schemeClr val="bg1"/>
+      </p:bgRef>
+    </p:bg>
+    <p:spTree>
+      <p:nvGrpSpPr>
+        <p:cNvPr id="1" name=""/>
+        <p:cNvGrpSpPr/>
+        <p:nvPr/>
+      </p:nvGrpSpPr>
+      <p:grpSpPr>
+        <a:xfrm>
+          <a:off x="0" y="0"/>
+          <a:ext cx="0" cy="0"/>
+          <a:chOff x="0" y="0"/>
+          <a:chExt cx="0" cy="0"/>
+        </a:xfrm>
+      </p:grpSpPr>
+      <p:sp>
+        <p:nvSpPr>
+          <p:cNvPr id="2" name="Espace réservé de l'en-tête 1"/>
+          <p:cNvSpPr>
+            <a:spLocks noGrp="1"/>
+          </p:cNvSpPr>
+          <p:nvPr>
+            <p:ph type="hdr" sz="quarter"/>
+          </p:nvPr>
+        </p:nvSpPr>
+        <p:spPr>
+          <a:xfrm>
+            <a:off x="0" y="0"/>
+            <a:ext cx="2971800" cy="458788"/>
+          </a:xfrm>
+          <a:prstGeom prst="rect">
+            <a:avLst/>
+          </a:prstGeom>
+        </p:spPr>
+        <p:txBody>
+          <a:bodyPr vert="horz" lIns="91440" tIns="45720" rIns="91440" bIns="45720" rtlCol="0"/>
+          <a:lstStyle>
+            <a:lvl1pPr algn="l">
+              <a:defRPr sz="1200"/>
+            </a:lvl1pPr>
+          </a:lstStyle>
+          <a:p>
+            <a:endParaRPr lang="fr-CH"/>
+          </a:p>
+        </p:txBody>
+      </p:sp>
+      <p:sp>
+        <p:nvSpPr>
+          <p:cNvPr id="3" name="Espace réservé de la date 2"/>
+          <p:cNvSpPr>
+            <a:spLocks noGrp="1"/>
+          </p:cNvSpPr>
+          <p:nvPr>
+            <p:ph type="dt" idx="1"/>
+          </p:nvPr>
+        </p:nvSpPr>
+        <p:spPr>
+          <a:xfrm>
+            <a:off x="3884613" y="0"/>
+            <a:ext cx="2971800" cy="458788"/>
+          </a:xfrm>
+          <a:prstGeom prst="rect">
+            <a:avLst/>
+          </a:prstGeom>
+        </p:spPr>
+        <p:txBody>
+          <a:bodyPr vert="horz" lIns="91440" tIns="45720" rIns="91440" bIns="45720" rtlCol="0"/>
+          <a:lstStyle>
+            <a:lvl1pPr algn="r">
+              <a:defRPr sz="1200"/>
+            </a:lvl1pPr>
+          </a:lstStyle>
+          <a:p>
+            <a:fld id="{752F80B0-8EF7-4B5C-A99C-A6E549D6FFBB}" type="datetimeFigureOut">
+              <a:rPr lang="fr-CH" smtClean="0"/>
+              <a:t>27.05.2026</a:t>
+            </a:fld>
+            <a:endParaRPr lang="fr-CH"/>
+          </a:p>
+        </p:txBody>
+      </p:sp>
+      <p:sp>
+        <p:nvSpPr>
+          <p:cNvPr id="4" name="Espace réservé de l'image des diapositives 3"/>
+          <p:cNvSpPr>
+            <a:spLocks noGrp="1" noRot="1" noChangeAspect="1"/>
+          </p:cNvSpPr>
+          <p:nvPr>
+            <p:ph type="sldImg" idx="2"/>
+          </p:nvPr>
+        </p:nvSpPr>
+        <p:spPr>
+          <a:xfrm>
+            <a:off x="685800" y="1143000"/>
+            <a:ext cx="5486400" cy="3086100"/>
+          </a:xfrm>
+          <a:prstGeom prst="rect">
+            <a:avLst/>
+          </a:prstGeom>
+          <a:noFill/>
+          <a:ln w="12700">
+            <a:solidFill>
+              <a:prstClr val="black"/>
+            </a:solidFill>
+          </a:ln>
+        </p:spPr>
+        <p:txBody>
+          <a:bodyPr vert="horz" lIns="91440" tIns="45720" rIns="91440" bIns="45720" rtlCol="0" anchor="ctr"/>
+          <a:lstStyle/>
+          <a:p>
+            <a:endParaRPr lang="fr-CH"/>
+          </a:p>
+        </p:txBody>
+      </p:sp>
+      <p:sp>
+        <p:nvSpPr>
+          <p:cNvPr id="5" name="Espace réservé des notes 4"/>
+          <p:cNvSpPr>
+            <a:spLocks noGrp="1"/>
+          </p:cNvSpPr>
+          <p:nvPr>
+            <p:ph type="body" sz="quarter" idx="3"/>
+          </p:nvPr>
+        </p:nvSpPr>
+        <p:spPr>
+          <a:xfrm>
+            <a:off x="685800" y="4400550"/>
+            <a:ext cx="5486400" cy="3600450"/>
+          </a:xfrm>
+          <a:prstGeom prst="rect">
+            <a:avLst/>
+          </a:prstGeom>
+        </p:spPr>
+        <p:txBody>
+          <a:bodyPr vert="horz" lIns="91440" tIns="45720" rIns="91440" bIns="45720" rtlCol="0"/>
+          <a:lstStyle/>
+          <a:p>
+            <a:pPr lvl="0"/>
+            <a:r>
+              <a:rPr lang="fr-FR"/>
+              <a:t>Cliquez pour modifier les styles du texte du masque</a:t>
+            </a:r>
+          </a:p>
+          <a:p>
+            <a:pPr lvl="1"/>
+            <a:r>
+              <a:rPr lang="fr-FR"/>
+              <a:t>Deuxième niveau</a:t>
+            </a:r>
+          </a:p>
+          <a:p>
+            <a:pPr lvl="2"/>
+            <a:r>
+              <a:rPr lang="fr-FR"/>
+              <a:t>Troisième niveau</a:t>
+            </a:r>
+          </a:p>
+          <a:p>
+            <a:pPr lvl="3"/>
+            <a:r>
+              <a:rPr lang="fr-FR"/>
+              <a:t>Quatrième niveau</a:t>
+            </a:r>
+          </a:p>
+          <a:p>
+            <a:pPr lvl="4"/>
+            <a:r>
+              <a:rPr lang="fr-FR"/>
+              <a:t>Cinquième niveau</a:t>
+            </a:r>
+            <a:endParaRPr lang="fr-CH"/>
+          </a:p>
+        </p:txBody>
+      </p:sp>
+      <p:sp>
+        <p:nvSpPr>
+          <p:cNvPr id="6" name="Espace réservé du pied de page 5"/>
+          <p:cNvSpPr>
+            <a:spLocks noGrp="1"/>
+          </p:cNvSpPr>
+          <p:nvPr>
+            <p:ph type="ftr" sz="quarter" idx="4"/>
+          </p:nvPr>
+        </p:nvSpPr>
+        <p:spPr>
+          <a:xfrm>
+            <a:off x="0" y="8685213"/>
+            <a:ext cx="2971800" cy="458787"/>
+          </a:xfrm>
+          <a:prstGeom prst="rect">
+            <a:avLst/>
+          </a:prstGeom>
+        </p:spPr>
+        <p:txBody>
+          <a:bodyPr vert="horz" lIns="91440" tIns="45720" rIns="91440" bIns="45720" rtlCol="0" anchor="b"/>
+          <a:lstStyle>
+            <a:lvl1pPr algn="l">
+              <a:defRPr sz="1200"/>
+            </a:lvl1pPr>
+          </a:lstStyle>
+          <a:p>
+            <a:endParaRPr lang="fr-CH"/>
+          </a:p>
+        </p:txBody>
+      </p:sp>
+      <p:sp>
+        <p:nvSpPr>
+          <p:cNvPr id="7" name="Espace réservé du numéro de diapositive 6"/>
+          <p:cNvSpPr>
+            <a:spLocks noGrp="1"/>
+          </p:cNvSpPr>
+          <p:nvPr>
+            <p:ph type="sldNum" sz="quarter" idx="5"/>
+          </p:nvPr>
+        </p:nvSpPr>
+        <p:spPr>
+          <a:xfrm>
+            <a:off x="3884613" y="8685213"/>
+            <a:ext cx="2971800" cy="458787"/>
+          </a:xfrm>
+          <a:prstGeom prst="rect">
+            <a:avLst/>
+          </a:prstGeom>
+        </p:spPr>
+        <p:txBody>
+          <a:bodyPr vert="horz" lIns="91440" tIns="45720" rIns="91440" bIns="45720" rtlCol="0" anchor="b"/>
+          <a:lstStyle>
+            <a:lvl1pPr algn="r">
+              <a:defRPr sz="1200"/>
+            </a:lvl1pPr>
+          </a:lstStyle>
+          <a:p>
+            <a:fld id="{55C48163-D5D4-4651-A954-E994903C76AF}" type="slidenum">
+              <a:rPr lang="fr-CH" smtClean="0"/>
+              <a:t>‹N°›</a:t>
+            </a:fld>
+            <a:endParaRPr lang="fr-CH"/>
+          </a:p>
+        </p:txBody>
+      </p:sp>
+    </p:spTree>
+    <p:extLst>
+      <p:ext uri="{BB962C8B-B14F-4D97-AF65-F5344CB8AC3E}">
+        <p14:creationId xmlns:p14="http://schemas.microsoft.com/office/powerpoint/2010/main" val="119925819"/>
+      </p:ext>
+    </p:extLst>
+  </p:cSld>
+  <p:clrMap bg1="lt1" tx1="dk1" bg2="lt2" tx2="dk2" accent1="accent1" accent2="accent2" accent3="accent3" accent4="accent4" accent5="accent5" accent6="accent6" hlink="hlink" folHlink="folHlink"/>
+  <p:notesStyle>
+    <a:lvl1pPr marL="0" algn="l" defTabSz="914400" rtl="0" eaLnBrk="1" latinLnBrk="0" hangingPunct="1">
+      <a:defRPr sz="1200" kern="1200">
+        <a:solidFill>
+          <a:schemeClr val="tx1"/>
+        </a:solidFill>
+        <a:latin typeface="+mn-lt"/>
+        <a:ea typeface="+mn-ea"/>
+        <a:cs typeface="+mn-cs"/>
+      </a:defRPr>
+    </a:lvl1pPr>
+    <a:lvl2pPr marL="457200" algn="l" defTabSz="914400" rtl="0" eaLnBrk="1" latinLnBrk="0" hangingPunct="1">
+      <a:defRPr sz="1200" kern="1200">
+        <a:solidFill>
+          <a:schemeClr val="tx1"/>
+        </a:solidFill>
+        <a:latin typeface="+mn-lt"/>
+        <a:ea typeface="+mn-ea"/>
+        <a:cs typeface="+mn-cs"/>
+      </a:defRPr>
+    </a:lvl2pPr>
+    <a:lvl3pPr marL="914400" algn="l" defTabSz="914400" rtl="0" eaLnBrk="1" latinLnBrk="0" hangingPunct="1">
+      <a:defRPr sz="1200" kern="1200">
+        <a:solidFill>
+          <a:schemeClr val="tx1"/>
+        </a:solidFill>
+        <a:latin typeface="+mn-lt"/>
+        <a:ea typeface="+mn-ea"/>
+        <a:cs typeface="+mn-cs"/>
+      </a:defRPr>
+    </a:lvl3pPr>
+    <a:lvl4pPr marL="1371600" algn="l" defTabSz="914400" rtl="0" eaLnBrk="1" latinLnBrk="0" hangingPunct="1">
+      <a:defRPr sz="1200" kern="1200">
+        <a:solidFill>
+          <a:schemeClr val="tx1"/>
+        </a:solidFill>
+        <a:latin typeface="+mn-lt"/>
+        <a:ea typeface="+mn-ea"/>
+        <a:cs typeface="+mn-cs"/>
+      </a:defRPr>
+    </a:lvl4pPr>
+    <a:lvl5pPr marL="1828800" algn="l" defTabSz="914400" rtl="0" eaLnBrk="1" latinLnBrk="0" hangingPunct="1">
+      <a:defRPr sz="1200" kern="1200">
+        <a:solidFill>
+          <a:schemeClr val="tx1"/>
+        </a:solidFill>
+        <a:latin typeface="+mn-lt"/>
+        <a:ea typeface="+mn-ea"/>
+        <a:cs typeface="+mn-cs"/>
+      </a:defRPr>
+    </a:lvl5pPr>
+    <a:lvl6pPr marL="2286000" algn="l" defTabSz="914400" rtl="0" eaLnBrk="1" latinLnBrk="0" hangingPunct="1">
+      <a:defRPr sz="1200" kern="1200">
+        <a:solidFill>
+          <a:schemeClr val="tx1"/>
+        </a:solidFill>
+        <a:latin typeface="+mn-lt"/>
+        <a:ea typeface="+mn-ea"/>
+        <a:cs typeface="+mn-cs"/>
+      </a:defRPr>
+    </a:lvl6pPr>
+    <a:lvl7pPr marL="2743200" algn="l" defTabSz="914400" rtl="0" eaLnBrk="1" latinLnBrk="0" hangingPunct="1">
+      <a:defRPr sz="1200" kern="1200">
+        <a:solidFill>
+          <a:schemeClr val="tx1"/>
+        </a:solidFill>
+        <a:latin typeface="+mn-lt"/>
+        <a:ea typeface="+mn-ea"/>
+        <a:cs typeface="+mn-cs"/>
+      </a:defRPr>
+    </a:lvl7pPr>
+    <a:lvl8pPr marL="3200400" algn="l" defTabSz="914400" rtl="0" eaLnBrk="1" latinLnBrk="0" hangingPunct="1">
+      <a:defRPr sz="1200" kern="1200">
+        <a:solidFill>
+          <a:schemeClr val="tx1"/>
+        </a:solidFill>
+        <a:latin typeface="+mn-lt"/>
+        <a:ea typeface="+mn-ea"/>
+        <a:cs typeface="+mn-cs"/>
+      </a:defRPr>
+    </a:lvl8pPr>
+    <a:lvl9pPr marL="3657600" algn="l" defTabSz="914400" rtl="0" eaLnBrk="1" latinLnBrk="0" hangingPunct="1">
+      <a:defRPr sz="1200" kern="1200">
+        <a:solidFill>
+          <a:schemeClr val="tx1"/>
+        </a:solidFill>
+        <a:latin typeface="+mn-lt"/>
+        <a:ea typeface="+mn-ea"/>
+        <a:cs typeface="+mn-cs"/>
+      </a:defRPr>
+    </a:lvl9pPr>
+  </p:notesStyle>
+</p:notesMaster>
+</file>
+
+<file path=ppt/notesSlides/notesSlide1.xml><?xml version="1.0" encoding="utf-8"?>
+<p:notes xmlns:a="http://schemas.openxmlformats.org/drawingml/2006/main" xmlns:r="http://schemas.openxmlformats.org/officeDocument/2006/relationships" xmlns:p="http://schemas.openxmlformats.org/presentationml/2006/main">
+  <p:cSld>
+    <p:spTree>
+      <p:nvGrpSpPr>
+        <p:cNvPr id="1" name=""/>
+        <p:cNvGrpSpPr/>
+        <p:nvPr/>
+      </p:nvGrpSpPr>
+      <p:grpSpPr>
+        <a:xfrm>
+          <a:off x="0" y="0"/>
+          <a:ext cx="0" cy="0"/>
+          <a:chOff x="0" y="0"/>
+          <a:chExt cx="0" cy="0"/>
+        </a:xfrm>
+      </p:grpSpPr>
+      <p:sp>
+        <p:nvSpPr>
+          <p:cNvPr id="2" name="Espace réservé de l'image des diapositives 1"/>
+          <p:cNvSpPr>
+            <a:spLocks noGrp="1" noRot="1" noChangeAspect="1"/>
+          </p:cNvSpPr>
+          <p:nvPr>
+            <p:ph type="sldImg"/>
+          </p:nvPr>
+        </p:nvSpPr>
+        <p:spPr/>
+      </p:sp>
+      <p:sp>
+        <p:nvSpPr>
+          <p:cNvPr id="3" name="Espace réservé des notes 2"/>
+          <p:cNvSpPr>
+            <a:spLocks noGrp="1"/>
+          </p:cNvSpPr>
+          <p:nvPr>
+            <p:ph type="body" idx="1"/>
+          </p:nvPr>
+        </p:nvSpPr>
+        <p:spPr/>
+        <p:txBody>
+          <a:bodyPr/>
+          <a:lstStyle/>
+          <a:p>
+            <a:r>
+              <a:rPr lang="fr-FR" dirty="0"/>
+              <a:t>Seul changement: </a:t>
+            </a:r>
+            <a:r>
+              <a:rPr lang="fr-FR" dirty="0" err="1"/>
+              <a:t>game-storage.json</a:t>
+            </a:r>
+            <a:r>
+              <a:rPr lang="fr-FR" dirty="0"/>
+              <a:t> (pseudo DB)</a:t>
+            </a:r>
+            <a:endParaRPr lang="fr-CH" dirty="0"/>
+          </a:p>
+        </p:txBody>
+      </p:sp>
+      <p:sp>
+        <p:nvSpPr>
+          <p:cNvPr id="4" name="Espace réservé du numéro de diapositive 3"/>
+          <p:cNvSpPr>
+            <a:spLocks noGrp="1"/>
+          </p:cNvSpPr>
+          <p:nvPr>
+            <p:ph type="sldNum" sz="quarter" idx="5"/>
+          </p:nvPr>
+        </p:nvSpPr>
+        <p:spPr/>
+        <p:txBody>
+          <a:bodyPr/>
+          <a:lstStyle/>
+          <a:p>
+            <a:fld id="{55C48163-D5D4-4651-A954-E994903C76AF}" type="slidenum">
+              <a:rPr lang="fr-CH" smtClean="0"/>
+              <a:t>13</a:t>
+            </a:fld>
+            <a:endParaRPr lang="fr-CH"/>
+          </a:p>
+        </p:txBody>
+      </p:sp>
+    </p:spTree>
+    <p:extLst>
+      <p:ext uri="{BB962C8B-B14F-4D97-AF65-F5344CB8AC3E}">
+        <p14:creationId xmlns:p14="http://schemas.microsoft.com/office/powerpoint/2010/main" val="974947384"/>
+      </p:ext>
+    </p:extLst>
+  </p:cSld>
+  <p:clrMapOvr>
+    <a:masterClrMapping/>
+  </p:clrMapOvr>
+</p:notes>
 </file>
 
 <file path=ppt/slideLayouts/slideLayout1.xml><?xml version="1.0" encoding="utf-8"?>
@@ -3726,19 +4174,50 @@
           <a:chExt cx="0" cy="0"/>
         </a:xfrm>
       </p:grpSpPr>
+      <p:sp>
+        <p:nvSpPr>
+          <p:cNvPr id="2" name="Titre 1">
+            <a:extLst>
+              <a:ext uri="{FF2B5EF4-FFF2-40B4-BE49-F238E27FC236}">
+                <a16:creationId xmlns:a16="http://schemas.microsoft.com/office/drawing/2014/main" id="{6F8B31E1-F7FB-5E99-EA45-073B057750A6}"/>
+              </a:ext>
+            </a:extLst>
+          </p:cNvPr>
+          <p:cNvSpPr>
+            <a:spLocks noGrp="1"/>
+          </p:cNvSpPr>
+          <p:nvPr>
+            <p:ph type="title"/>
+          </p:nvPr>
+        </p:nvSpPr>
+        <p:spPr/>
+        <p:txBody>
+          <a:bodyPr/>
+          <a:lstStyle/>
+          <a:p>
+            <a:r>
+              <a:rPr lang="fr-FR" dirty="0"/>
+              <a:t>Diagramme de classes</a:t>
+            </a:r>
+            <a:endParaRPr lang="fr-CH" dirty="0"/>
+          </a:p>
+        </p:txBody>
+      </p:sp>
       <p:pic>
         <p:nvPicPr>
-          <p:cNvPr id="7" name="Image 6">
-            <a:extLst>
-              <a:ext uri="{FF2B5EF4-FFF2-40B4-BE49-F238E27FC236}">
-                <a16:creationId xmlns:a16="http://schemas.microsoft.com/office/drawing/2014/main" id="{34CD332B-F15E-0E2F-C8E9-76BE6EF1458A}"/>
+          <p:cNvPr id="7" name="Espace réservé du contenu 6">
+            <a:extLst>
+              <a:ext uri="{FF2B5EF4-FFF2-40B4-BE49-F238E27FC236}">
+                <a16:creationId xmlns:a16="http://schemas.microsoft.com/office/drawing/2014/main" id="{D8B6CC18-9E52-AC71-36F7-498250F244B7}"/>
               </a:ext>
             </a:extLst>
           </p:cNvPr>
           <p:cNvPicPr>
-            <a:picLocks noChangeAspect="1"/>
+            <a:picLocks noGrp="1" noChangeAspect="1"/>
           </p:cNvPicPr>
-          <p:nvPr/>
+          <p:nvPr>
+            <p:ph idx="1"/>
+          </p:nvPr>
         </p:nvPicPr>
         <p:blipFill>
           <a:blip r:embed="rId2">
@@ -3754,18 +4233,90 @@
         </p:blipFill>
         <p:spPr>
           <a:xfrm>
-            <a:off x="415279" y="0"/>
-            <a:ext cx="11361441" cy="6858000"/>
+            <a:off x="202467" y="1504340"/>
+            <a:ext cx="8692725" cy="4929712"/>
           </a:xfrm>
           <a:prstGeom prst="rect">
             <a:avLst/>
           </a:prstGeom>
         </p:spPr>
       </p:pic>
+      <p:sp>
+        <p:nvSpPr>
+          <p:cNvPr id="3" name="ZoneTexte 2">
+            <a:extLst>
+              <a:ext uri="{FF2B5EF4-FFF2-40B4-BE49-F238E27FC236}">
+                <a16:creationId xmlns:a16="http://schemas.microsoft.com/office/drawing/2014/main" id="{C6DFA2C3-AD1B-BA11-FA55-D2193C7065A1}"/>
+              </a:ext>
+            </a:extLst>
+          </p:cNvPr>
+          <p:cNvSpPr txBox="1"/>
+          <p:nvPr/>
+        </p:nvSpPr>
+        <p:spPr>
+          <a:xfrm>
+            <a:off x="9060873" y="1454727"/>
+            <a:ext cx="3050771" cy="2031325"/>
+          </a:xfrm>
+          <a:prstGeom prst="rect">
+            <a:avLst/>
+          </a:prstGeom>
+          <a:noFill/>
+        </p:spPr>
+        <p:txBody>
+          <a:bodyPr wrap="square" rtlCol="0">
+            <a:spAutoFit/>
+          </a:bodyPr>
+          <a:lstStyle/>
+          <a:p>
+            <a:r>
+              <a:rPr lang="fr-FR" dirty="0"/>
+              <a:t>Changements:</a:t>
+            </a:r>
+          </a:p>
+          <a:p>
+            <a:pPr marL="285750" indent="-285750">
+              <a:buFontTx/>
+              <a:buChar char="-"/>
+            </a:pPr>
+            <a:r>
+              <a:rPr lang="fr-FR" dirty="0"/>
+              <a:t>Deux </a:t>
+            </a:r>
+            <a:r>
+              <a:rPr lang="fr-FR" dirty="0" err="1"/>
+              <a:t>BoardState</a:t>
+            </a:r>
+            <a:r>
+              <a:rPr lang="fr-FR" dirty="0"/>
+              <a:t> au lieu de un</a:t>
+            </a:r>
+          </a:p>
+          <a:p>
+            <a:pPr marL="285750" indent="-285750">
+              <a:buFontTx/>
+              <a:buChar char="-"/>
+            </a:pPr>
+            <a:r>
+              <a:rPr lang="fr-FR" dirty="0"/>
+              <a:t>Ajout de </a:t>
+            </a:r>
+            <a:r>
+              <a:rPr lang="fr-FR" dirty="0" err="1"/>
+              <a:t>GameStorage</a:t>
+            </a:r>
+            <a:r>
+              <a:rPr lang="fr-FR" dirty="0"/>
+              <a:t> pour sauvegarder les comptes des joueurs et les résultats des parties</a:t>
+            </a:r>
+            <a:endParaRPr lang="fr-CH" dirty="0"/>
+          </a:p>
+        </p:txBody>
+      </p:sp>
     </p:spTree>
     <p:extLst>
       <p:ext uri="{BB962C8B-B14F-4D97-AF65-F5344CB8AC3E}">
-        <p14:creationId xmlns:p14="http://schemas.microsoft.com/office/powerpoint/2010/main" val="3081217100"/>
+        <p14:creationId xmlns:p14="http://schemas.microsoft.com/office/powerpoint/2010/main" val="647219976"/>
       </p:ext>
     </p:extLst>
   </p:cSld>
@@ -3792,12 +4343,41 @@
           <a:chExt cx="0" cy="0"/>
         </a:xfrm>
       </p:grpSpPr>
+      <p:sp>
+        <p:nvSpPr>
+          <p:cNvPr id="2" name="Titre 1">
+            <a:extLst>
+              <a:ext uri="{FF2B5EF4-FFF2-40B4-BE49-F238E27FC236}">
+                <a16:creationId xmlns:a16="http://schemas.microsoft.com/office/drawing/2014/main" id="{1F944A1B-5D11-648A-2775-DC7C5644520E}"/>
+              </a:ext>
+            </a:extLst>
+          </p:cNvPr>
+          <p:cNvSpPr>
+            <a:spLocks noGrp="1"/>
+          </p:cNvSpPr>
+          <p:nvPr>
+            <p:ph type="title"/>
+          </p:nvPr>
+        </p:nvSpPr>
+        <p:spPr/>
+        <p:txBody>
+          <a:bodyPr/>
+          <a:lstStyle/>
+          <a:p>
+            <a:r>
+              <a:rPr lang="fr-FR" dirty="0"/>
+              <a:t>Diagramme de déploiement</a:t>
+            </a:r>
+            <a:endParaRPr lang="fr-CH" dirty="0"/>
+          </a:p>
+        </p:txBody>
+      </p:sp>
       <p:pic>
         <p:nvPicPr>
-          <p:cNvPr id="5" name="Espace réservé du contenu 4">
-            <a:extLst>
-              <a:ext uri="{FF2B5EF4-FFF2-40B4-BE49-F238E27FC236}">
-                <a16:creationId xmlns:a16="http://schemas.microsoft.com/office/drawing/2014/main" id="{F0B4162C-C3D5-21C5-74B1-AB9A25B5132A}"/>
+          <p:cNvPr id="7" name="Espace réservé du contenu 6">
+            <a:extLst>
+              <a:ext uri="{FF2B5EF4-FFF2-40B4-BE49-F238E27FC236}">
+                <a16:creationId xmlns:a16="http://schemas.microsoft.com/office/drawing/2014/main" id="{5BA6DD6C-4CCD-D909-4577-093C98B4C25D}"/>
               </a:ext>
             </a:extLst>
           </p:cNvPr>
@@ -3809,7 +4389,7 @@
           </p:nvPr>
         </p:nvPicPr>
         <p:blipFill>
-          <a:blip r:embed="rId2">
+          <a:blip r:embed="rId3">
             <a:extLst>
               <a:ext uri="{28A0092B-C50C-407E-A947-70E740481C1C}">
                 <a14:useLocalDpi xmlns:a14="http://schemas.microsoft.com/office/drawing/2010/main" val="0"/>
@@ -3822,127 +4402,30 @@
         </p:blipFill>
         <p:spPr>
           <a:xfrm>
-            <a:off x="642161" y="0"/>
-            <a:ext cx="10907678" cy="6858000"/>
+            <a:off x="766821" y="2442572"/>
+            <a:ext cx="10181042" cy="3554971"/>
           </a:xfrm>
           <a:prstGeom prst="rect">
             <a:avLst/>
           </a:prstGeom>
         </p:spPr>
       </p:pic>
-    </p:spTree>
-    <p:extLst>
-      <p:ext uri="{BB962C8B-B14F-4D97-AF65-F5344CB8AC3E}">
-        <p14:creationId xmlns:p14="http://schemas.microsoft.com/office/powerpoint/2010/main" val="2122524804"/>
-      </p:ext>
-    </p:extLst>
-  </p:cSld>
-  <p:clrMapOvr>
-    <a:masterClrMapping/>
-  </p:clrMapOvr>
-</p:sld>
-</file>
-
-<file path=ppt/slides/slide14.xml><?xml version="1.0" encoding="utf-8"?>
-<p:sld xmlns:a="http://schemas.openxmlformats.org/drawingml/2006/main" xmlns:r="http://schemas.openxmlformats.org/officeDocument/2006/relationships" xmlns:p="http://schemas.openxmlformats.org/presentationml/2006/main">
-  <p:cSld>
-    <p:spTree>
-      <p:nvGrpSpPr>
-        <p:cNvPr id="1" name=""/>
-        <p:cNvGrpSpPr/>
-        <p:nvPr/>
-      </p:nvGrpSpPr>
-      <p:grpSpPr>
-        <a:xfrm>
-          <a:off x="0" y="0"/>
-          <a:ext cx="0" cy="0"/>
-          <a:chOff x="0" y="0"/>
-          <a:chExt cx="0" cy="0"/>
-        </a:xfrm>
-      </p:grpSpPr>
-      <p:sp>
-        <p:nvSpPr>
-          <p:cNvPr id="2" name="Titre 1">
-            <a:extLst>
-              <a:ext uri="{FF2B5EF4-FFF2-40B4-BE49-F238E27FC236}">
-                <a16:creationId xmlns:a16="http://schemas.microsoft.com/office/drawing/2014/main" id="{6F8B31E1-F7FB-5E99-EA45-073B057750A6}"/>
-              </a:ext>
-            </a:extLst>
-          </p:cNvPr>
-          <p:cNvSpPr>
-            <a:spLocks noGrp="1"/>
-          </p:cNvSpPr>
-          <p:nvPr>
-            <p:ph type="title"/>
-          </p:nvPr>
-        </p:nvSpPr>
-        <p:spPr/>
-        <p:txBody>
-          <a:bodyPr/>
-          <a:lstStyle/>
-          <a:p>
-            <a:r>
-              <a:rPr lang="fr-FR" dirty="0"/>
-              <a:t>Diagramme de classes</a:t>
-            </a:r>
-            <a:endParaRPr lang="fr-CH" dirty="0"/>
-          </a:p>
-        </p:txBody>
-      </p:sp>
-      <p:pic>
-        <p:nvPicPr>
-          <p:cNvPr id="7" name="Espace réservé du contenu 6">
-            <a:extLst>
-              <a:ext uri="{FF2B5EF4-FFF2-40B4-BE49-F238E27FC236}">
-                <a16:creationId xmlns:a16="http://schemas.microsoft.com/office/drawing/2014/main" id="{D8B6CC18-9E52-AC71-36F7-498250F244B7}"/>
-              </a:ext>
-            </a:extLst>
-          </p:cNvPr>
-          <p:cNvPicPr>
-            <a:picLocks noGrp="1" noChangeAspect="1"/>
-          </p:cNvPicPr>
-          <p:nvPr>
-            <p:ph idx="1"/>
-          </p:nvPr>
-        </p:nvPicPr>
-        <p:blipFill>
-          <a:blip r:embed="rId2">
-            <a:extLst>
-              <a:ext uri="{28A0092B-C50C-407E-A947-70E740481C1C}">
-                <a14:useLocalDpi xmlns:a14="http://schemas.microsoft.com/office/drawing/2010/main" val="0"/>
-              </a:ext>
-            </a:extLst>
-          </a:blip>
-          <a:stretch>
-            <a:fillRect/>
-          </a:stretch>
-        </p:blipFill>
+      <p:sp>
+        <p:nvSpPr>
+          <p:cNvPr id="3" name="ZoneTexte 2">
+            <a:extLst>
+              <a:ext uri="{FF2B5EF4-FFF2-40B4-BE49-F238E27FC236}">
+                <a16:creationId xmlns:a16="http://schemas.microsoft.com/office/drawing/2014/main" id="{8323A00E-7E6C-BEE3-CE36-55B30978D934}"/>
+              </a:ext>
+            </a:extLst>
+          </p:cNvPr>
+          <p:cNvSpPr txBox="1"/>
+          <p:nvPr/>
+        </p:nvSpPr>
         <p:spPr>
           <a:xfrm>
-            <a:off x="202467" y="1504340"/>
-            <a:ext cx="8692725" cy="4929712"/>
-          </a:xfrm>
-          <a:prstGeom prst="rect">
-            <a:avLst/>
-          </a:prstGeom>
-        </p:spPr>
-      </p:pic>
-      <p:sp>
-        <p:nvSpPr>
-          <p:cNvPr id="3" name="ZoneTexte 2">
-            <a:extLst>
-              <a:ext uri="{FF2B5EF4-FFF2-40B4-BE49-F238E27FC236}">
-                <a16:creationId xmlns:a16="http://schemas.microsoft.com/office/drawing/2014/main" id="{C6DFA2C3-AD1B-BA11-FA55-D2193C7065A1}"/>
-              </a:ext>
-            </a:extLst>
-          </p:cNvPr>
-          <p:cNvSpPr txBox="1"/>
-          <p:nvPr/>
-        </p:nvSpPr>
-        <p:spPr>
-          <a:xfrm>
-            <a:off x="9060873" y="1454727"/>
-            <a:ext cx="3050771" cy="2031325"/>
+            <a:off x="665018" y="1637507"/>
+            <a:ext cx="9892146" cy="369332"/>
           </a:xfrm>
           <a:prstGeom prst="rect">
             <a:avLst/>
@@ -3957,145 +4440,20 @@
           <a:p>
             <a:r>
               <a:rPr lang="fr-FR" dirty="0"/>
-              <a:t>Changements:</a:t>
-            </a:r>
-          </a:p>
-          <a:p>
-            <a:pPr marL="285750" indent="-285750">
-              <a:buFontTx/>
-              <a:buChar char="-"/>
-            </a:pPr>
+              <a:t>Changement: ajout du </a:t>
+            </a:r>
+            <a:r>
+              <a:rPr lang="fr-FR" dirty="0" err="1"/>
+              <a:t>game-storage.json</a:t>
+            </a:r>
             <a:r>
               <a:rPr lang="fr-FR" dirty="0"/>
-              <a:t>Deux </a:t>
-            </a:r>
-            <a:r>
-              <a:rPr lang="fr-FR" dirty="0" err="1"/>
-              <a:t>BoardState</a:t>
-            </a:r>
-            <a:r>
-              <a:rPr lang="fr-FR" dirty="0"/>
-              <a:t> au lieu de un</a:t>
-            </a:r>
-          </a:p>
-          <a:p>
-            <a:pPr marL="285750" indent="-285750">
-              <a:buFontTx/>
-              <a:buChar char="-"/>
-            </a:pPr>
-            <a:r>
-              <a:rPr lang="fr-FR" dirty="0"/>
-              <a:t>Ajout de </a:t>
-            </a:r>
-            <a:r>
-              <a:rPr lang="fr-FR" dirty="0" err="1"/>
-              <a:t>GameStorage</a:t>
-            </a:r>
-            <a:r>
-              <a:rPr lang="fr-FR" dirty="0"/>
-              <a:t> pour sauvegarder les comptes des joueurs et les résultats des parties</a:t>
+              <a:t> qui fait office de DB</a:t>
             </a:r>
             <a:endParaRPr lang="fr-CH" dirty="0"/>
           </a:p>
         </p:txBody>
       </p:sp>
-    </p:spTree>
-    <p:extLst>
-      <p:ext uri="{BB962C8B-B14F-4D97-AF65-F5344CB8AC3E}">
-        <p14:creationId xmlns:p14="http://schemas.microsoft.com/office/powerpoint/2010/main" val="647219976"/>
-      </p:ext>
-    </p:extLst>
-  </p:cSld>
-  <p:clrMapOvr>
-    <a:masterClrMapping/>
-  </p:clrMapOvr>
-</p:sld>
-</file>
-
-<file path=ppt/slides/slide15.xml><?xml version="1.0" encoding="utf-8"?>
-<p:sld xmlns:a="http://schemas.openxmlformats.org/drawingml/2006/main" xmlns:r="http://schemas.openxmlformats.org/officeDocument/2006/relationships" xmlns:p="http://schemas.openxmlformats.org/presentationml/2006/main">
-  <p:cSld>
-    <p:spTree>
-      <p:nvGrpSpPr>
-        <p:cNvPr id="1" name=""/>
-        <p:cNvGrpSpPr/>
-        <p:nvPr/>
-      </p:nvGrpSpPr>
-      <p:grpSpPr>
-        <a:xfrm>
-          <a:off x="0" y="0"/>
-          <a:ext cx="0" cy="0"/>
-          <a:chOff x="0" y="0"/>
-          <a:chExt cx="0" cy="0"/>
-        </a:xfrm>
-      </p:grpSpPr>
-      <p:sp>
-        <p:nvSpPr>
-          <p:cNvPr id="2" name="Titre 1">
-            <a:extLst>
-              <a:ext uri="{FF2B5EF4-FFF2-40B4-BE49-F238E27FC236}">
-                <a16:creationId xmlns:a16="http://schemas.microsoft.com/office/drawing/2014/main" id="{1F944A1B-5D11-648A-2775-DC7C5644520E}"/>
-              </a:ext>
-            </a:extLst>
-          </p:cNvPr>
-          <p:cNvSpPr>
-            <a:spLocks noGrp="1"/>
-          </p:cNvSpPr>
-          <p:nvPr>
-            <p:ph type="title"/>
-          </p:nvPr>
-        </p:nvSpPr>
-        <p:spPr/>
-        <p:txBody>
-          <a:bodyPr/>
-          <a:lstStyle/>
-          <a:p>
-            <a:r>
-              <a:rPr lang="fr-FR" dirty="0"/>
-              <a:t>Diagramme de déploiement</a:t>
-            </a:r>
-            <a:endParaRPr lang="fr-CH" dirty="0"/>
-          </a:p>
-        </p:txBody>
-      </p:sp>
-      <p:pic>
-        <p:nvPicPr>
-          <p:cNvPr id="7" name="Espace réservé du contenu 6">
-            <a:extLst>
-              <a:ext uri="{FF2B5EF4-FFF2-40B4-BE49-F238E27FC236}">
-                <a16:creationId xmlns:a16="http://schemas.microsoft.com/office/drawing/2014/main" id="{5BA6DD6C-4CCD-D909-4577-093C98B4C25D}"/>
-              </a:ext>
-            </a:extLst>
-          </p:cNvPr>
-          <p:cNvPicPr>
-            <a:picLocks noGrp="1" noChangeAspect="1"/>
-          </p:cNvPicPr>
-          <p:nvPr>
-            <p:ph idx="1"/>
-          </p:nvPr>
-        </p:nvPicPr>
-        <p:blipFill>
-          <a:blip r:embed="rId2">
-            <a:extLst>
-              <a:ext uri="{28A0092B-C50C-407E-A947-70E740481C1C}">
-                <a14:useLocalDpi xmlns:a14="http://schemas.microsoft.com/office/drawing/2010/main" val="0"/>
-              </a:ext>
-            </a:extLst>
-          </a:blip>
-          <a:stretch>
-            <a:fillRect/>
-          </a:stretch>
-        </p:blipFill>
-        <p:spPr>
-          <a:xfrm>
-            <a:off x="650442" y="1933904"/>
-            <a:ext cx="10891115" cy="3802911"/>
-          </a:xfrm>
-          <a:prstGeom prst="rect">
-            <a:avLst/>
-          </a:prstGeom>
-        </p:spPr>
-      </p:pic>
     </p:spTree>
     <p:extLst>
       <p:ext uri="{BB962C8B-B14F-4D97-AF65-F5344CB8AC3E}">
@@ -4109,7 +4467,7 @@
 </p:sld>
 </file>
 
-<file path=ppt/slides/slide16.xml><?xml version="1.0" encoding="utf-8"?>
+<file path=ppt/slides/slide14.xml><?xml version="1.0" encoding="utf-8"?>
 <p:sld xmlns:a="http://schemas.openxmlformats.org/drawingml/2006/main" xmlns:r="http://schemas.openxmlformats.org/officeDocument/2006/relationships" xmlns:p="http://schemas.openxmlformats.org/presentationml/2006/main">
   <p:cSld>
     <p:spTree>
@@ -4182,7 +4540,7 @@
 </p:sld>
 </file>
 
-<file path=ppt/slides/slide17.xml><?xml version="1.0" encoding="utf-8"?>
+<file path=ppt/slides/slide15.xml><?xml version="1.0" encoding="utf-8"?>
 <p:sld xmlns:a="http://schemas.openxmlformats.org/drawingml/2006/main" xmlns:r="http://schemas.openxmlformats.org/officeDocument/2006/relationships" xmlns:p="http://schemas.openxmlformats.org/presentationml/2006/main">
   <p:cSld>
     <p:spTree>
@@ -4580,7 +4938,151 @@
 </p:sld>
 </file>
 
-<file path=ppt/slides/slide18.xml><?xml version="1.0" encoding="utf-8"?>
+<file path=ppt/slides/slide16.xml><?xml version="1.0" encoding="utf-8"?>
+<p:sld xmlns:a="http://schemas.openxmlformats.org/drawingml/2006/main" xmlns:r="http://schemas.openxmlformats.org/officeDocument/2006/relationships" xmlns:p="http://schemas.openxmlformats.org/presentationml/2006/main">
+  <p:cSld>
+    <p:spTree>
+      <p:nvGrpSpPr>
+        <p:cNvPr id="1" name=""/>
+        <p:cNvGrpSpPr/>
+        <p:nvPr/>
+      </p:nvGrpSpPr>
+      <p:grpSpPr>
+        <a:xfrm>
+          <a:off x="0" y="0"/>
+          <a:ext cx="0" cy="0"/>
+          <a:chOff x="0" y="0"/>
+          <a:chExt cx="0" cy="0"/>
+        </a:xfrm>
+      </p:grpSpPr>
+      <p:pic>
+        <p:nvPicPr>
+          <p:cNvPr id="7" name="Image 6">
+            <a:extLst>
+              <a:ext uri="{FF2B5EF4-FFF2-40B4-BE49-F238E27FC236}">
+                <a16:creationId xmlns:a16="http://schemas.microsoft.com/office/drawing/2014/main" id="{34CD332B-F15E-0E2F-C8E9-76BE6EF1458A}"/>
+              </a:ext>
+            </a:extLst>
+          </p:cNvPr>
+          <p:cNvPicPr>
+            <a:picLocks noChangeAspect="1"/>
+          </p:cNvPicPr>
+          <p:nvPr/>
+        </p:nvPicPr>
+        <p:blipFill>
+          <a:blip r:embed="rId2">
+            <a:extLst>
+              <a:ext uri="{28A0092B-C50C-407E-A947-70E740481C1C}">
+                <a14:useLocalDpi xmlns:a14="http://schemas.microsoft.com/office/drawing/2010/main" val="0"/>
+              </a:ext>
+            </a:extLst>
+          </a:blip>
+          <a:srcRect l="55739" t="36736"/>
+          <a:stretch>
+            <a:fillRect/>
+          </a:stretch>
+        </p:blipFill>
+        <p:spPr>
+          <a:xfrm>
+            <a:off x="565266" y="1920240"/>
+            <a:ext cx="5010160" cy="4322618"/>
+          </a:xfrm>
+          <a:prstGeom prst="rect">
+            <a:avLst/>
+          </a:prstGeom>
+        </p:spPr>
+      </p:pic>
+      <p:pic>
+        <p:nvPicPr>
+          <p:cNvPr id="5" name="Espace réservé du contenu 4">
+            <a:extLst>
+              <a:ext uri="{FF2B5EF4-FFF2-40B4-BE49-F238E27FC236}">
+                <a16:creationId xmlns:a16="http://schemas.microsoft.com/office/drawing/2014/main" id="{F0B4162C-C3D5-21C5-74B1-AB9A25B5132A}"/>
+              </a:ext>
+            </a:extLst>
+          </p:cNvPr>
+          <p:cNvPicPr>
+            <a:picLocks noGrp="1" noChangeAspect="1"/>
+          </p:cNvPicPr>
+          <p:nvPr>
+            <p:ph idx="1"/>
+          </p:nvPr>
+        </p:nvPicPr>
+        <p:blipFill>
+          <a:blip r:embed="rId3">
+            <a:extLst>
+              <a:ext uri="{28A0092B-C50C-407E-A947-70E740481C1C}">
+                <a14:useLocalDpi xmlns:a14="http://schemas.microsoft.com/office/drawing/2010/main" val="0"/>
+              </a:ext>
+            </a:extLst>
+          </a:blip>
+          <a:srcRect l="55919" t="41576"/>
+          <a:stretch>
+            <a:fillRect/>
+          </a:stretch>
+        </p:blipFill>
+        <p:spPr>
+          <a:xfrm>
+            <a:off x="6135148" y="1920240"/>
+            <a:ext cx="5250873" cy="4375605"/>
+          </a:xfrm>
+          <a:prstGeom prst="rect">
+            <a:avLst/>
+          </a:prstGeom>
+        </p:spPr>
+      </p:pic>
+      <p:sp>
+        <p:nvSpPr>
+          <p:cNvPr id="2" name="Titre 1">
+            <a:extLst>
+              <a:ext uri="{FF2B5EF4-FFF2-40B4-BE49-F238E27FC236}">
+                <a16:creationId xmlns:a16="http://schemas.microsoft.com/office/drawing/2014/main" id="{6551FE5C-088B-769B-4B78-A89576858316}"/>
+              </a:ext>
+            </a:extLst>
+          </p:cNvPr>
+          <p:cNvSpPr>
+            <a:spLocks noGrp="1"/>
+          </p:cNvSpPr>
+          <p:nvPr>
+            <p:ph type="title"/>
+          </p:nvPr>
+        </p:nvSpPr>
+        <p:spPr>
+          <a:xfrm>
+            <a:off x="838200" y="365125"/>
+            <a:ext cx="10515600" cy="1325563"/>
+          </a:xfrm>
+        </p:spPr>
+        <p:txBody>
+          <a:bodyPr/>
+          <a:lstStyle/>
+          <a:p>
+            <a:r>
+              <a:rPr lang="fr-FR" dirty="0"/>
+              <a:t>Démo: Chiffrement avant </a:t>
+            </a:r>
+            <a:r>
+              <a:rPr lang="fr-FR"/>
+              <a:t>- après</a:t>
+            </a:r>
+            <a:endParaRPr lang="fr-CH" dirty="0"/>
+          </a:p>
+        </p:txBody>
+      </p:sp>
+    </p:spTree>
+    <p:extLst>
+      <p:ext uri="{BB962C8B-B14F-4D97-AF65-F5344CB8AC3E}">
+        <p14:creationId xmlns:p14="http://schemas.microsoft.com/office/powerpoint/2010/main" val="2369045636"/>
+      </p:ext>
+    </p:extLst>
+  </p:cSld>
+  <p:clrMapOvr>
+    <a:masterClrMapping/>
+  </p:clrMapOvr>
+</p:sld>
+</file>
+
+<file path=ppt/slides/slide17.xml><?xml version="1.0" encoding="utf-8"?>
 <p:sld xmlns:a="http://schemas.openxmlformats.org/drawingml/2006/main" xmlns:r="http://schemas.openxmlformats.org/officeDocument/2006/relationships" xmlns:p="http://schemas.openxmlformats.org/presentationml/2006/main">
   <p:cSld>
     <p:spTree>
@@ -6389,4 +6891,319 @@
     </a:ext>
   </a:extLst>
 </a:theme>
+</file>
+
+<file path=ppt/theme/theme2.xml><?xml version="1.0" encoding="utf-8"?>
+<a:theme xmlns:a="http://schemas.openxmlformats.org/drawingml/2006/main" name="Thème Office">
+  <a:themeElements>
+    <a:clrScheme name="Office">
+      <a:dk1>
+        <a:sysClr val="windowText" lastClr="000000"/>
+      </a:dk1>
+      <a:lt1>
+        <a:sysClr val="window" lastClr="FFFFFF"/>
+      </a:lt1>
+      <a:dk2>
+        <a:srgbClr val="0E2841"/>
+      </a:dk2>
+      <a:lt2>
+        <a:srgbClr val="E8E8E8"/>
+      </a:lt2>
+      <a:accent1>
+        <a:srgbClr val="156082"/>
+      </a:accent1>
+      <a:accent2>
+        <a:srgbClr val="E97132"/>
+      </a:accent2>
+      <a:accent3>
+        <a:srgbClr val="196B24"/>
+      </a:accent3>
+      <a:accent4>
+        <a:srgbClr val="0F9ED5"/>
+      </a:accent4>
+      <a:accent5>
+        <a:srgbClr val="A02B93"/>
+      </a:accent5>
+      <a:accent6>
+        <a:srgbClr val="4EA72E"/>
+      </a:accent6>
+      <a:hlink>
+        <a:srgbClr val="467886"/>
+      </a:hlink>
+      <a:folHlink>
+        <a:srgbClr val="96607D"/>
+      </a:folHlink>
+    </a:clrScheme>
+    <a:fontScheme name="Office">
+      <a:majorFont>
+        <a:latin typeface="Aptos Display" panose="02110004020202020204"/>
+        <a:ea typeface=""/>
+        <a:cs typeface=""/>
+        <a:font script="Jpan" typeface="游ゴシック Light"/>
+        <a:font script="Hang" typeface="맑은 고딕"/>
+        <a:font script="Hans" typeface="等线 Light"/>
+        <a:font script="Hant" typeface="新細明體"/>
+        <a:font script="Arab" typeface="Times New Roman"/>
+        <a:font script="Hebr" typeface="Times New Roman"/>
+        <a:font script="Thai" typeface="Angsana New"/>
+        <a:font script="Ethi" typeface="Nyala"/>
+        <a:font script="Beng" typeface="Vrinda"/>
+        <a:font script="Gujr" typeface="Shruti"/>
+        <a:font script="Khmr" typeface="MoolBoran"/>
+        <a:font script="Knda" typeface="Tunga"/>
+        <a:font script="Guru" typeface="Raavi"/>
+        <a:font script="Cans" typeface="Euphemia"/>
+        <a:font script="Cher" typeface="Plantagenet Cherokee"/>
+        <a:font script="Yiii" typeface="Microsoft Yi Baiti"/>
+        <a:font script="Tibt" typeface="Microsoft Himalaya"/>
+        <a:font script="Thaa" typeface="MV Boli"/>
+        <a:font script="Deva" typeface="Mangal"/>
+        <a:font script="Telu" typeface="Gautami"/>
+        <a:font script="Taml" typeface="Latha"/>
+        <a:font script="Syrc" typeface="Estrangelo Edessa"/>
+        <a:font script="Orya" typeface="Kalinga"/>
+        <a:font script="Mlym" typeface="Kartika"/>
+        <a:font script="Laoo" typeface="DokChampa"/>
+        <a:font script="Sinh" typeface="Iskoola Pota"/>
+        <a:font script="Mong" typeface="Mongolian Baiti"/>
+        <a:font script="Viet" typeface="Times New Roman"/>
+        <a:font script="Uigh" typeface="Microsoft Uighur"/>
+        <a:font script="Geor" typeface="Sylfaen"/>
+        <a:font script="Armn" typeface="Arial"/>
+        <a:font script="Bugi" typeface="Leelawadee UI"/>
+        <a:font script="Bopo" typeface="Microsoft JhengHei"/>
+        <a:font script="Java" typeface="Javanese Text"/>
+        <a:font script="Lisu" typeface="Segoe UI"/>
+        <a:font script="Mymr" typeface="Myanmar Text"/>
+        <a:font script="Nkoo" typeface="Ebrima"/>
+        <a:font script="Olck" typeface="Nirmala UI"/>
+        <a:font script="Osma" typeface="Ebrima"/>
+        <a:font script="Phag" typeface="Phagspa"/>
+        <a:font script="Syrn" typeface="Estrangelo Edessa"/>
+        <a:font script="Syrj" typeface="Estrangelo Edessa"/>
+        <a:font script="Syre" typeface="Estrangelo Edessa"/>
+        <a:font script="Sora" typeface="Nirmala UI"/>
+        <a:font script="Tale" typeface="Microsoft Tai Le"/>
+        <a:font script="Talu" typeface="Microsoft New Tai Lue"/>
+        <a:font script="Tfng" typeface="Ebrima"/>
+      </a:majorFont>
+      <a:minorFont>
+        <a:latin typeface="Aptos" panose="02110004020202020204"/>
+        <a:ea typeface=""/>
+        <a:cs typeface=""/>
+        <a:font script="Jpan" typeface="游ゴシック"/>
+        <a:font script="Hang" typeface="맑은 고딕"/>
+        <a:font script="Hans" typeface="等线"/>
+        <a:font script="Hant" typeface="新細明體"/>
+        <a:font script="Arab" typeface="Arial"/>
+        <a:font script="Hebr" typeface="Arial"/>
+        <a:font script="Thai" typeface="Cordia New"/>
+        <a:font script="Ethi" typeface="Nyala"/>
+        <a:font script="Beng" typeface="Vrinda"/>
+        <a:font script="Gujr" typeface="Shruti"/>
+        <a:font script="Khmr" typeface="DaunPenh"/>
+        <a:font script="Knda" typeface="Tunga"/>
+        <a:font script="Guru" typeface="Raavi"/>
+        <a:font script="Cans" typeface="Euphemia"/>
+        <a:font script="Cher" typeface="Plantagenet Cherokee"/>
+        <a:font script="Yiii" typeface="Microsoft Yi Baiti"/>
+        <a:font script="Tibt" typeface="Microsoft Himalaya"/>
+        <a:font script="Thaa" typeface="MV Boli"/>
+        <a:font script="Deva" typeface="Mangal"/>
+        <a:font script="Telu" typeface="Gautami"/>
+        <a:font script="Taml" typeface="Latha"/>
+        <a:font script="Syrc" typeface="Estrangelo Edessa"/>
+        <a:font script="Orya" typeface="Kalinga"/>
+        <a:font script="Mlym" typeface="Kartika"/>
+        <a:font script="Laoo" typeface="DokChampa"/>
+        <a:font script="Sinh" typeface="Iskoola Pota"/>
+        <a:font script="Mong" typeface="Mongolian Baiti"/>
+        <a:font script="Viet" typeface="Arial"/>
+        <a:font script="Uigh" typeface="Microsoft Uighur"/>
+        <a:font script="Geor" typeface="Sylfaen"/>
+        <a:font script="Armn" typeface="Arial"/>
+        <a:font script="Bugi" typeface="Leelawadee UI"/>
+        <a:font script="Bopo" typeface="Microsoft JhengHei"/>
+        <a:font script="Java" typeface="Javanese Text"/>
+        <a:font script="Lisu" typeface="Segoe UI"/>
+        <a:font script="Mymr" typeface="Myanmar Text"/>
+        <a:font script="Nkoo" typeface="Ebrima"/>
+        <a:font script="Olck" typeface="Nirmala UI"/>
+        <a:font script="Osma" typeface="Ebrima"/>
+        <a:font script="Phag" typeface="Phagspa"/>
+        <a:font script="Syrn" typeface="Estrangelo Edessa"/>
+        <a:font script="Syrj" typeface="Estrangelo Edessa"/>
+        <a:font script="Syre" typeface="Estrangelo Edessa"/>
+        <a:font script="Sora" typeface="Nirmala UI"/>
+        <a:font script="Tale" typeface="Microsoft Tai Le"/>
+        <a:font script="Talu" typeface="Microsoft New Tai Lue"/>
+        <a:font script="Tfng" typeface="Ebrima"/>
+      </a:minorFont>
+    </a:fontScheme>
+    <a:fmtScheme name="Office">
+      <a:fillStyleLst>
+        <a:solidFill>
+          <a:schemeClr val="phClr"/>
+        </a:solidFill>
+        <a:gradFill rotWithShape="1">
+          <a:gsLst>
+            <a:gs pos="0">
+              <a:schemeClr val="phClr">
+                <a:lumMod val="110000"/>
+                <a:satMod val="105000"/>
+                <a:tint val="67000"/>
+              </a:schemeClr>
+            </a:gs>
+            <a:gs pos="50000">
+              <a:schemeClr val="phClr">
+                <a:lumMod val="105000"/>
+                <a:satMod val="103000"/>
+                <a:tint val="73000"/>
+              </a:schemeClr>
+            </a:gs>
+            <a:gs pos="100000">
+              <a:schemeClr val="phClr">
+                <a:lumMod val="105000"/>
+                <a:satMod val="109000"/>
+                <a:tint val="81000"/>
+              </a:schemeClr>
+            </a:gs>
+          </a:gsLst>
+          <a:lin ang="5400000" scaled="0"/>
+        </a:gradFill>
+        <a:gradFill rotWithShape="1">
+          <a:gsLst>
+            <a:gs pos="0">
+              <a:schemeClr val="phClr">
+                <a:satMod val="103000"/>
+                <a:lumMod val="102000"/>
+                <a:tint val="94000"/>
+              </a:schemeClr>
+            </a:gs>
+            <a:gs pos="50000">
+              <a:schemeClr val="phClr">
+                <a:satMod val="110000"/>
+                <a:lumMod val="100000"/>
+                <a:shade val="100000"/>
+              </a:schemeClr>
+            </a:gs>
+            <a:gs pos="100000">
+              <a:schemeClr val="phClr">
+                <a:lumMod val="99000"/>
+                <a:satMod val="120000"/>
+                <a:shade val="78000"/>
+              </a:schemeClr>
+            </a:gs>
+          </a:gsLst>
+          <a:lin ang="5400000" scaled="0"/>
+        </a:gradFill>
+      </a:fillStyleLst>
+      <a:lnStyleLst>
+        <a:ln w="12700" cap="flat" cmpd="sng" algn="ctr">
+          <a:solidFill>
+            <a:schemeClr val="phClr"/>
+          </a:solidFill>
+          <a:prstDash val="solid"/>
+          <a:miter lim="800000"/>
+        </a:ln>
+        <a:ln w="19050" cap="flat" cmpd="sng" algn="ctr">
+          <a:solidFill>
+            <a:schemeClr val="phClr"/>
+          </a:solidFill>
+          <a:prstDash val="solid"/>
+          <a:miter lim="800000"/>
+        </a:ln>
+        <a:ln w="25400" cap="flat" cmpd="sng" algn="ctr">
+          <a:solidFill>
+            <a:schemeClr val="phClr"/>
+          </a:solidFill>
+          <a:prstDash val="solid"/>
+          <a:miter lim="800000"/>
+        </a:ln>
+      </a:lnStyleLst>
+      <a:effectStyleLst>
+        <a:effectStyle>
+          <a:effectLst/>
+        </a:effectStyle>
+        <a:effectStyle>
+          <a:effectLst/>
+        </a:effectStyle>
+        <a:effectStyle>
+          <a:effectLst>
+            <a:outerShdw blurRad="57150" dist="19050" dir="5400000" algn="ctr" rotWithShape="0">
+              <a:srgbClr val="000000">
+                <a:alpha val="63000"/>
+              </a:srgbClr>
+            </a:outerShdw>
+          </a:effectLst>
+        </a:effectStyle>
+      </a:effectStyleLst>
+      <a:bgFillStyleLst>
+        <a:solidFill>
+          <a:schemeClr val="phClr"/>
+        </a:solidFill>
+        <a:solidFill>
+          <a:schemeClr val="phClr">
+            <a:tint val="95000"/>
+            <a:satMod val="170000"/>
+          </a:schemeClr>
+        </a:solidFill>
+        <a:gradFill rotWithShape="1">
+          <a:gsLst>
+            <a:gs pos="0">
+              <a:schemeClr val="phClr">
+                <a:tint val="93000"/>
+                <a:satMod val="150000"/>
+                <a:shade val="98000"/>
+                <a:lumMod val="102000"/>
+              </a:schemeClr>
+            </a:gs>
+            <a:gs pos="50000">
+              <a:schemeClr val="phClr">
+                <a:tint val="98000"/>
+                <a:satMod val="130000"/>
+                <a:shade val="90000"/>
+                <a:lumMod val="103000"/>
+              </a:schemeClr>
+            </a:gs>
+            <a:gs pos="100000">
+              <a:schemeClr val="phClr">
+                <a:shade val="63000"/>
+                <a:satMod val="120000"/>
+              </a:schemeClr>
+            </a:gs>
+          </a:gsLst>
+          <a:lin ang="5400000" scaled="0"/>
+        </a:gradFill>
+      </a:bgFillStyleLst>
+    </a:fmtScheme>
+  </a:themeElements>
+  <a:objectDefaults>
+    <a:lnDef>
+      <a:spPr/>
+      <a:bodyPr/>
+      <a:lstStyle/>
+      <a:style>
+        <a:lnRef idx="2">
+          <a:schemeClr val="accent1"/>
+        </a:lnRef>
+        <a:fillRef idx="0">
+          <a:schemeClr val="accent1"/>
+        </a:fillRef>
+        <a:effectRef idx="1">
+          <a:schemeClr val="accent1"/>
+        </a:effectRef>
+        <a:fontRef idx="minor">
+          <a:schemeClr val="tx1"/>
+        </a:fontRef>
+      </a:style>
+    </a:lnDef>
+  </a:objectDefaults>
+  <a:extraClrSchemeLst/>
+  <a:extLst>
+    <a:ext uri="{05A4C25C-085E-4340-85A3-A5531E510DB2}">
+      <thm15:themeFamily xmlns:thm15="http://schemas.microsoft.com/office/thememl/2012/main" name="Office Theme" id="{2E142A2C-CD16-42D6-873A-C26D2A0506FA}" vid="{1BDDFF52-6CD6-40A5-AB3C-68EB2F1E4D0A}"/>
+    </a:ext>
+  </a:extLst>
+</a:theme>
 </file>
</xml_diff>

<commit_message>
add info in Slide
</commit_message>
<xml_diff>
--- a/doc/presentation.pptx
+++ b/doc/presentation.pptx
@@ -5,7 +5,7 @@
     <p:sldMasterId id="2147483648" r:id="rId1"/>
   </p:sldMasterIdLst>
   <p:notesMasterIdLst>
-    <p:notesMasterId r:id="rId19"/>
+    <p:notesMasterId r:id="rId21"/>
   </p:notesMasterIdLst>
   <p:sldIdLst>
     <p:sldId id="256" r:id="rId2"/>
@@ -14,17 +14,19 @@
     <p:sldId id="275" r:id="rId5"/>
     <p:sldId id="276" r:id="rId6"/>
     <p:sldId id="269" r:id="rId7"/>
-    <p:sldId id="270" r:id="rId8"/>
-    <p:sldId id="258" r:id="rId9"/>
-    <p:sldId id="259" r:id="rId10"/>
-    <p:sldId id="277" r:id="rId11"/>
-    <p:sldId id="261" r:id="rId12"/>
-    <p:sldId id="273" r:id="rId13"/>
-    <p:sldId id="263" r:id="rId14"/>
-    <p:sldId id="271" r:id="rId15"/>
-    <p:sldId id="272" r:id="rId16"/>
-    <p:sldId id="265" r:id="rId17"/>
-    <p:sldId id="264" r:id="rId18"/>
+    <p:sldId id="279" r:id="rId8"/>
+    <p:sldId id="280" r:id="rId9"/>
+    <p:sldId id="270" r:id="rId10"/>
+    <p:sldId id="258" r:id="rId11"/>
+    <p:sldId id="259" r:id="rId12"/>
+    <p:sldId id="277" r:id="rId13"/>
+    <p:sldId id="261" r:id="rId14"/>
+    <p:sldId id="273" r:id="rId15"/>
+    <p:sldId id="263" r:id="rId16"/>
+    <p:sldId id="271" r:id="rId17"/>
+    <p:sldId id="272" r:id="rId18"/>
+    <p:sldId id="265" r:id="rId19"/>
+    <p:sldId id="264" r:id="rId20"/>
   </p:sldIdLst>
   <p:sldSz cx="12192000" cy="6858000"/>
   <p:notesSz cx="6858000" cy="9144000"/>
@@ -558,7 +560,7 @@
           <a:p>
             <a:fld id="{55C48163-D5D4-4651-A954-E994903C76AF}" type="slidenum">
               <a:rPr lang="fr-CH" smtClean="0"/>
-              <a:t>13</a:t>
+              <a:t>15</a:t>
             </a:fld>
             <a:endParaRPr lang="fr-CH"/>
           </a:p>
@@ -3893,6 +3895,366 @@
   <p:cSld>
     <p:spTree>
       <p:nvGrpSpPr>
+        <p:cNvPr id="1" name=""/>
+        <p:cNvGrpSpPr/>
+        <p:nvPr/>
+      </p:nvGrpSpPr>
+      <p:grpSpPr>
+        <a:xfrm>
+          <a:off x="0" y="0"/>
+          <a:ext cx="0" cy="0"/>
+          <a:chOff x="0" y="0"/>
+          <a:chExt cx="0" cy="0"/>
+        </a:xfrm>
+      </p:grpSpPr>
+      <p:sp>
+        <p:nvSpPr>
+          <p:cNvPr id="2" name="Title 1">
+            <a:extLst>
+              <a:ext uri="{FF2B5EF4-FFF2-40B4-BE49-F238E27FC236}">
+                <a16:creationId xmlns:a16="http://schemas.microsoft.com/office/drawing/2014/main" id="{DC8C0BBD-B33A-5BF5-1A3D-5D6F55E62D93}"/>
+              </a:ext>
+            </a:extLst>
+          </p:cNvPr>
+          <p:cNvSpPr>
+            <a:spLocks noGrp="1"/>
+          </p:cNvSpPr>
+          <p:nvPr>
+            <p:ph type="title"/>
+          </p:nvPr>
+        </p:nvSpPr>
+        <p:spPr>
+          <a:xfrm>
+            <a:off x="838200" y="732987"/>
+            <a:ext cx="10515600" cy="1325563"/>
+          </a:xfrm>
+        </p:spPr>
+        <p:txBody>
+          <a:bodyPr/>
+          <a:lstStyle/>
+          <a:p>
+            <a:r>
+              <a:rPr lang="fr-FR" dirty="0"/>
+              <a:t>Diagramme de</a:t>
+            </a:r>
+            <a:br>
+              <a:rPr lang="fr-FR" dirty="0"/>
+            </a:br>
+            <a:r>
+              <a:rPr lang="fr-FR" dirty="0" err="1"/>
+              <a:t>Usecase</a:t>
+            </a:r>
+            <a:endParaRPr lang="en-CH" dirty="0"/>
+          </a:p>
+        </p:txBody>
+      </p:sp>
+      <p:pic>
+        <p:nvPicPr>
+          <p:cNvPr id="7" name="Espace réservé du contenu 6">
+            <a:extLst>
+              <a:ext uri="{FF2B5EF4-FFF2-40B4-BE49-F238E27FC236}">
+                <a16:creationId xmlns:a16="http://schemas.microsoft.com/office/drawing/2014/main" id="{46145EAE-B2DC-7C6C-6A5F-2F186CDA0BA8}"/>
+              </a:ext>
+            </a:extLst>
+          </p:cNvPr>
+          <p:cNvPicPr>
+            <a:picLocks noGrp="1" noChangeAspect="1"/>
+          </p:cNvPicPr>
+          <p:nvPr>
+            <p:ph idx="1"/>
+          </p:nvPr>
+        </p:nvPicPr>
+        <p:blipFill>
+          <a:blip r:embed="rId2">
+            <a:extLst>
+              <a:ext uri="{28A0092B-C50C-407E-A947-70E740481C1C}">
+                <a14:useLocalDpi xmlns:a14="http://schemas.microsoft.com/office/drawing/2010/main" val="0"/>
+              </a:ext>
+            </a:extLst>
+          </a:blip>
+          <a:stretch>
+            <a:fillRect/>
+          </a:stretch>
+        </p:blipFill>
+        <p:spPr>
+          <a:xfrm>
+            <a:off x="5363066" y="530144"/>
+            <a:ext cx="5620243" cy="5594869"/>
+          </a:xfrm>
+          <a:prstGeom prst="rect">
+            <a:avLst/>
+          </a:prstGeom>
+        </p:spPr>
+      </p:pic>
+      <p:sp>
+        <p:nvSpPr>
+          <p:cNvPr id="8" name="ZoneTexte 7">
+            <a:extLst>
+              <a:ext uri="{FF2B5EF4-FFF2-40B4-BE49-F238E27FC236}">
+                <a16:creationId xmlns:a16="http://schemas.microsoft.com/office/drawing/2014/main" id="{622F10BA-8BDE-647C-2FE3-05E029519E53}"/>
+              </a:ext>
+            </a:extLst>
+          </p:cNvPr>
+          <p:cNvSpPr txBox="1"/>
+          <p:nvPr/>
+        </p:nvSpPr>
+        <p:spPr>
+          <a:xfrm>
+            <a:off x="725214" y="2343807"/>
+            <a:ext cx="4267361" cy="1754326"/>
+          </a:xfrm>
+          <a:prstGeom prst="rect">
+            <a:avLst/>
+          </a:prstGeom>
+          <a:noFill/>
+        </p:spPr>
+        <p:txBody>
+          <a:bodyPr wrap="square" rtlCol="0">
+            <a:spAutoFit/>
+          </a:bodyPr>
+          <a:lstStyle/>
+          <a:p>
+            <a:r>
+              <a:rPr lang="fr-FR" dirty="0"/>
+              <a:t>Changement:</a:t>
+            </a:r>
+          </a:p>
+          <a:p>
+            <a:endParaRPr lang="fr-FR" dirty="0"/>
+          </a:p>
+          <a:p>
+            <a:pPr marL="285750" indent="-285750">
+              <a:buFontTx/>
+              <a:buChar char="-"/>
+            </a:pPr>
+            <a:r>
+              <a:rPr lang="fr-FR" dirty="0"/>
+              <a:t>Deux plateaux de jeu</a:t>
+            </a:r>
+          </a:p>
+          <a:p>
+            <a:pPr marL="285750" indent="-285750">
+              <a:buFontTx/>
+              <a:buChar char="-"/>
+            </a:pPr>
+            <a:endParaRPr lang="fr-FR" dirty="0"/>
+          </a:p>
+          <a:p>
+            <a:pPr marL="285750" indent="-285750">
+              <a:buFontTx/>
+              <a:buChar char="-"/>
+            </a:pPr>
+            <a:r>
+              <a:rPr lang="fr-FR" dirty="0"/>
+              <a:t>Les joueurs peuvent choisir le plateau sur lequel jouer entre chaque partie</a:t>
+            </a:r>
+          </a:p>
+        </p:txBody>
+      </p:sp>
+    </p:spTree>
+    <p:extLst>
+      <p:ext uri="{BB962C8B-B14F-4D97-AF65-F5344CB8AC3E}">
+        <p14:creationId xmlns:p14="http://schemas.microsoft.com/office/powerpoint/2010/main" val="2148361823"/>
+      </p:ext>
+    </p:extLst>
+  </p:cSld>
+  <p:clrMapOvr>
+    <a:masterClrMapping/>
+  </p:clrMapOvr>
+</p:sld>
+</file>
+
+<file path=ppt/slides/slide11.xml><?xml version="1.0" encoding="utf-8"?>
+<p:sld xmlns:a="http://schemas.openxmlformats.org/drawingml/2006/main" xmlns:r="http://schemas.openxmlformats.org/officeDocument/2006/relationships" xmlns:p="http://schemas.openxmlformats.org/presentationml/2006/main">
+  <p:cSld>
+    <p:spTree>
+      <p:nvGrpSpPr>
+        <p:cNvPr id="1" name=""/>
+        <p:cNvGrpSpPr/>
+        <p:nvPr/>
+      </p:nvGrpSpPr>
+      <p:grpSpPr>
+        <a:xfrm>
+          <a:off x="0" y="0"/>
+          <a:ext cx="0" cy="0"/>
+          <a:chOff x="0" y="0"/>
+          <a:chExt cx="0" cy="0"/>
+        </a:xfrm>
+      </p:grpSpPr>
+      <p:sp>
+        <p:nvSpPr>
+          <p:cNvPr id="2" name="Title 1">
+            <a:extLst>
+              <a:ext uri="{FF2B5EF4-FFF2-40B4-BE49-F238E27FC236}">
+                <a16:creationId xmlns:a16="http://schemas.microsoft.com/office/drawing/2014/main" id="{36F7B8CE-B221-F8E8-E3DF-09FDE7AF6F91}"/>
+              </a:ext>
+            </a:extLst>
+          </p:cNvPr>
+          <p:cNvSpPr>
+            <a:spLocks noGrp="1"/>
+          </p:cNvSpPr>
+          <p:nvPr>
+            <p:ph type="title"/>
+          </p:nvPr>
+        </p:nvSpPr>
+        <p:spPr/>
+        <p:txBody>
+          <a:bodyPr/>
+          <a:lstStyle/>
+          <a:p>
+            <a:r>
+              <a:rPr lang="fr-FR" dirty="0"/>
+              <a:t>DFD</a:t>
+            </a:r>
+            <a:endParaRPr lang="en-CH" dirty="0"/>
+          </a:p>
+        </p:txBody>
+      </p:sp>
+      <p:pic>
+        <p:nvPicPr>
+          <p:cNvPr id="7" name="Espace réservé du contenu 6">
+            <a:extLst>
+              <a:ext uri="{FF2B5EF4-FFF2-40B4-BE49-F238E27FC236}">
+                <a16:creationId xmlns:a16="http://schemas.microsoft.com/office/drawing/2014/main" id="{4987C348-78D1-4E51-9D58-97A6D15A2FAC}"/>
+              </a:ext>
+            </a:extLst>
+          </p:cNvPr>
+          <p:cNvPicPr>
+            <a:picLocks noGrp="1" noChangeAspect="1"/>
+          </p:cNvPicPr>
+          <p:nvPr>
+            <p:ph idx="1"/>
+          </p:nvPr>
+        </p:nvPicPr>
+        <p:blipFill>
+          <a:blip r:embed="rId2">
+            <a:extLst>
+              <a:ext uri="{28A0092B-C50C-407E-A947-70E740481C1C}">
+                <a14:useLocalDpi xmlns:a14="http://schemas.microsoft.com/office/drawing/2010/main" val="0"/>
+              </a:ext>
+            </a:extLst>
+          </a:blip>
+          <a:stretch>
+            <a:fillRect/>
+          </a:stretch>
+        </p:blipFill>
+        <p:spPr>
+          <a:xfrm>
+            <a:off x="4377894" y="234022"/>
+            <a:ext cx="6975906" cy="6258853"/>
+          </a:xfrm>
+          <a:prstGeom prst="rect">
+            <a:avLst/>
+          </a:prstGeom>
+        </p:spPr>
+      </p:pic>
+      <p:sp>
+        <p:nvSpPr>
+          <p:cNvPr id="8" name="ZoneTexte 7">
+            <a:extLst>
+              <a:ext uri="{FF2B5EF4-FFF2-40B4-BE49-F238E27FC236}">
+                <a16:creationId xmlns:a16="http://schemas.microsoft.com/office/drawing/2014/main" id="{8486416A-D519-8D5D-A582-E2519E7B9110}"/>
+              </a:ext>
+            </a:extLst>
+          </p:cNvPr>
+          <p:cNvSpPr txBox="1"/>
+          <p:nvPr/>
+        </p:nvSpPr>
+        <p:spPr>
+          <a:xfrm>
+            <a:off x="262759" y="1690688"/>
+            <a:ext cx="4035972" cy="3416320"/>
+          </a:xfrm>
+          <a:prstGeom prst="rect">
+            <a:avLst/>
+          </a:prstGeom>
+          <a:noFill/>
+        </p:spPr>
+        <p:txBody>
+          <a:bodyPr wrap="square" rtlCol="0">
+            <a:spAutoFit/>
+          </a:bodyPr>
+          <a:lstStyle/>
+          <a:p>
+            <a:r>
+              <a:rPr lang="fr-FR" dirty="0"/>
+              <a:t>Changements:</a:t>
+            </a:r>
+          </a:p>
+          <a:p>
+            <a:endParaRPr lang="fr-FR" dirty="0"/>
+          </a:p>
+          <a:p>
+            <a:pPr marL="285750" indent="-285750">
+              <a:buFontTx/>
+              <a:buChar char="-"/>
+            </a:pPr>
+            <a:r>
+              <a:rPr lang="fr-FR" dirty="0"/>
+              <a:t>Player Handling se charge maintenant de l’authentification</a:t>
+            </a:r>
+          </a:p>
+          <a:p>
+            <a:pPr marL="285750" indent="-285750">
+              <a:buFontTx/>
+              <a:buChar char="-"/>
+            </a:pPr>
+            <a:endParaRPr lang="fr-FR" dirty="0"/>
+          </a:p>
+          <a:p>
+            <a:pPr marL="285750" indent="-285750">
+              <a:buFontTx/>
+              <a:buChar char="-"/>
+            </a:pPr>
+            <a:r>
+              <a:rPr lang="fr-FR" dirty="0"/>
+              <a:t>Au lieu de laisser les joueurs joindre la partie, il faut s’enregistrer et se login</a:t>
+            </a:r>
+          </a:p>
+          <a:p>
+            <a:pPr marL="285750" indent="-285750">
+              <a:buFontTx/>
+              <a:buChar char="-"/>
+            </a:pPr>
+            <a:endParaRPr lang="fr-FR" dirty="0"/>
+          </a:p>
+          <a:p>
+            <a:pPr marL="285750" indent="-285750">
+              <a:buFontTx/>
+              <a:buChar char="-"/>
+            </a:pPr>
+            <a:r>
+              <a:rPr lang="fr-FR" dirty="0"/>
+              <a:t>Les infos des joueurs sont persistantes</a:t>
+            </a:r>
+          </a:p>
+          <a:p>
+            <a:pPr marL="285750" indent="-285750">
+              <a:buFontTx/>
+              <a:buChar char="-"/>
+            </a:pPr>
+            <a:endParaRPr lang="fr-FR" dirty="0"/>
+          </a:p>
+        </p:txBody>
+      </p:sp>
+    </p:spTree>
+    <p:extLst>
+      <p:ext uri="{BB962C8B-B14F-4D97-AF65-F5344CB8AC3E}">
+        <p14:creationId xmlns:p14="http://schemas.microsoft.com/office/powerpoint/2010/main" val="357446579"/>
+      </p:ext>
+    </p:extLst>
+  </p:cSld>
+  <p:clrMapOvr>
+    <a:masterClrMapping/>
+  </p:clrMapOvr>
+</p:sld>
+</file>
+
+<file path=ppt/slides/slide12.xml><?xml version="1.0" encoding="utf-8"?>
+<p:sld xmlns:a="http://schemas.openxmlformats.org/drawingml/2006/main" xmlns:r="http://schemas.openxmlformats.org/officeDocument/2006/relationships" xmlns:p="http://schemas.openxmlformats.org/presentationml/2006/main">
+  <p:cSld>
+    <p:spTree>
+      <p:nvGrpSpPr>
         <p:cNvPr id="1" name="">
           <a:extLst>
             <a:ext uri="{FF2B5EF4-FFF2-40B4-BE49-F238E27FC236}">
@@ -4001,331 +4363,6 @@
 </p:sld>
 </file>
 
-<file path=ppt/slides/slide11.xml><?xml version="1.0" encoding="utf-8"?>
-<p:sld xmlns:a="http://schemas.openxmlformats.org/drawingml/2006/main" xmlns:r="http://schemas.openxmlformats.org/officeDocument/2006/relationships" xmlns:p="http://schemas.openxmlformats.org/presentationml/2006/main">
-  <p:cSld>
-    <p:spTree>
-      <p:nvGrpSpPr>
-        <p:cNvPr id="1" name=""/>
-        <p:cNvGrpSpPr/>
-        <p:nvPr/>
-      </p:nvGrpSpPr>
-      <p:grpSpPr>
-        <a:xfrm>
-          <a:off x="0" y="0"/>
-          <a:ext cx="0" cy="0"/>
-          <a:chOff x="0" y="0"/>
-          <a:chExt cx="0" cy="0"/>
-        </a:xfrm>
-      </p:grpSpPr>
-      <p:sp>
-        <p:nvSpPr>
-          <p:cNvPr id="2" name="Titre 1">
-            <a:extLst>
-              <a:ext uri="{FF2B5EF4-FFF2-40B4-BE49-F238E27FC236}">
-                <a16:creationId xmlns:a16="http://schemas.microsoft.com/office/drawing/2014/main" id="{67EB3B64-2366-60B3-BFD9-2498BB6EE069}"/>
-              </a:ext>
-            </a:extLst>
-          </p:cNvPr>
-          <p:cNvSpPr>
-            <a:spLocks noGrp="1"/>
-          </p:cNvSpPr>
-          <p:nvPr>
-            <p:ph type="title"/>
-          </p:nvPr>
-        </p:nvSpPr>
-        <p:spPr/>
-        <p:txBody>
-          <a:bodyPr/>
-          <a:lstStyle/>
-          <a:p>
-            <a:r>
-              <a:rPr lang="fr-FR" dirty="0"/>
-              <a:t>Diagramme de composants</a:t>
-            </a:r>
-            <a:endParaRPr lang="fr-CH" dirty="0"/>
-          </a:p>
-        </p:txBody>
-      </p:sp>
-      <p:pic>
-        <p:nvPicPr>
-          <p:cNvPr id="15" name="Espace réservé du contenu 14">
-            <a:extLst>
-              <a:ext uri="{FF2B5EF4-FFF2-40B4-BE49-F238E27FC236}">
-                <a16:creationId xmlns:a16="http://schemas.microsoft.com/office/drawing/2014/main" id="{17C01AD7-76C3-A91C-9375-5D9B73813868}"/>
-              </a:ext>
-            </a:extLst>
-          </p:cNvPr>
-          <p:cNvPicPr>
-            <a:picLocks noGrp="1" noChangeAspect="1"/>
-          </p:cNvPicPr>
-          <p:nvPr>
-            <p:ph idx="1"/>
-          </p:nvPr>
-        </p:nvPicPr>
-        <p:blipFill>
-          <a:blip r:embed="rId2">
-            <a:extLst>
-              <a:ext uri="{28A0092B-C50C-407E-A947-70E740481C1C}">
-                <a14:useLocalDpi xmlns:a14="http://schemas.microsoft.com/office/drawing/2010/main" val="0"/>
-              </a:ext>
-            </a:extLst>
-          </a:blip>
-          <a:stretch>
-            <a:fillRect/>
-          </a:stretch>
-        </p:blipFill>
-        <p:spPr>
-          <a:xfrm>
-            <a:off x="956442" y="1485874"/>
-            <a:ext cx="9736752" cy="3380416"/>
-          </a:xfrm>
-          <a:prstGeom prst="rect">
-            <a:avLst/>
-          </a:prstGeom>
-        </p:spPr>
-      </p:pic>
-      <p:sp>
-        <p:nvSpPr>
-          <p:cNvPr id="16" name="ZoneTexte 15">
-            <a:extLst>
-              <a:ext uri="{FF2B5EF4-FFF2-40B4-BE49-F238E27FC236}">
-                <a16:creationId xmlns:a16="http://schemas.microsoft.com/office/drawing/2014/main" id="{49EC9D06-4915-AC97-BF0E-6B1E8A2A7C0D}"/>
-              </a:ext>
-            </a:extLst>
-          </p:cNvPr>
-          <p:cNvSpPr txBox="1"/>
-          <p:nvPr/>
-        </p:nvSpPr>
-        <p:spPr>
-          <a:xfrm>
-            <a:off x="741840" y="5121691"/>
-            <a:ext cx="10405241" cy="1477328"/>
-          </a:xfrm>
-          <a:prstGeom prst="rect">
-            <a:avLst/>
-          </a:prstGeom>
-          <a:noFill/>
-        </p:spPr>
-        <p:txBody>
-          <a:bodyPr wrap="square" rtlCol="0">
-            <a:spAutoFit/>
-          </a:bodyPr>
-          <a:lstStyle/>
-          <a:p>
-            <a:r>
-              <a:rPr lang="fr-FR" dirty="0"/>
-              <a:t>Changements:</a:t>
-            </a:r>
-          </a:p>
-          <a:p>
-            <a:endParaRPr lang="fr-FR" dirty="0"/>
-          </a:p>
-          <a:p>
-            <a:pPr marL="285750" indent="-285750">
-              <a:buFontTx/>
-              <a:buChar char="-"/>
-            </a:pPr>
-            <a:r>
-              <a:rPr lang="fr-FR" dirty="0"/>
-              <a:t>Ajout d’un Game Storage (DB) pour sauvegarder les informations des joueurs et les parties complétées</a:t>
-            </a:r>
-          </a:p>
-          <a:p>
-            <a:pPr marL="285750" indent="-285750">
-              <a:buFontTx/>
-              <a:buChar char="-"/>
-            </a:pPr>
-            <a:r>
-              <a:rPr lang="fr-FR" dirty="0"/>
-              <a:t>Ajout d’un utilitaire pour chiffrer les communications</a:t>
-            </a:r>
-            <a:endParaRPr lang="fr-CH" dirty="0"/>
-          </a:p>
-        </p:txBody>
-      </p:sp>
-    </p:spTree>
-    <p:extLst>
-      <p:ext uri="{BB962C8B-B14F-4D97-AF65-F5344CB8AC3E}">
-        <p14:creationId xmlns:p14="http://schemas.microsoft.com/office/powerpoint/2010/main" val="3567787778"/>
-      </p:ext>
-    </p:extLst>
-  </p:cSld>
-  <p:clrMapOvr>
-    <a:masterClrMapping/>
-  </p:clrMapOvr>
-</p:sld>
-</file>
-
-<file path=ppt/slides/slide12.xml><?xml version="1.0" encoding="utf-8"?>
-<p:sld xmlns:a="http://schemas.openxmlformats.org/drawingml/2006/main" xmlns:r="http://schemas.openxmlformats.org/officeDocument/2006/relationships" xmlns:p="http://schemas.openxmlformats.org/presentationml/2006/main">
-  <p:cSld>
-    <p:spTree>
-      <p:nvGrpSpPr>
-        <p:cNvPr id="1" name=""/>
-        <p:cNvGrpSpPr/>
-        <p:nvPr/>
-      </p:nvGrpSpPr>
-      <p:grpSpPr>
-        <a:xfrm>
-          <a:off x="0" y="0"/>
-          <a:ext cx="0" cy="0"/>
-          <a:chOff x="0" y="0"/>
-          <a:chExt cx="0" cy="0"/>
-        </a:xfrm>
-      </p:grpSpPr>
-      <p:sp>
-        <p:nvSpPr>
-          <p:cNvPr id="2" name="Titre 1">
-            <a:extLst>
-              <a:ext uri="{FF2B5EF4-FFF2-40B4-BE49-F238E27FC236}">
-                <a16:creationId xmlns:a16="http://schemas.microsoft.com/office/drawing/2014/main" id="{6F8B31E1-F7FB-5E99-EA45-073B057750A6}"/>
-              </a:ext>
-            </a:extLst>
-          </p:cNvPr>
-          <p:cNvSpPr>
-            <a:spLocks noGrp="1"/>
-          </p:cNvSpPr>
-          <p:nvPr>
-            <p:ph type="title"/>
-          </p:nvPr>
-        </p:nvSpPr>
-        <p:spPr/>
-        <p:txBody>
-          <a:bodyPr/>
-          <a:lstStyle/>
-          <a:p>
-            <a:r>
-              <a:rPr lang="fr-FR" dirty="0"/>
-              <a:t>Diagramme de classes</a:t>
-            </a:r>
-            <a:endParaRPr lang="fr-CH" dirty="0"/>
-          </a:p>
-        </p:txBody>
-      </p:sp>
-      <p:pic>
-        <p:nvPicPr>
-          <p:cNvPr id="7" name="Espace réservé du contenu 6">
-            <a:extLst>
-              <a:ext uri="{FF2B5EF4-FFF2-40B4-BE49-F238E27FC236}">
-                <a16:creationId xmlns:a16="http://schemas.microsoft.com/office/drawing/2014/main" id="{D8B6CC18-9E52-AC71-36F7-498250F244B7}"/>
-              </a:ext>
-            </a:extLst>
-          </p:cNvPr>
-          <p:cNvPicPr>
-            <a:picLocks noGrp="1" noChangeAspect="1"/>
-          </p:cNvPicPr>
-          <p:nvPr>
-            <p:ph idx="1"/>
-          </p:nvPr>
-        </p:nvPicPr>
-        <p:blipFill>
-          <a:blip r:embed="rId2">
-            <a:extLst>
-              <a:ext uri="{28A0092B-C50C-407E-A947-70E740481C1C}">
-                <a14:useLocalDpi xmlns:a14="http://schemas.microsoft.com/office/drawing/2010/main" val="0"/>
-              </a:ext>
-            </a:extLst>
-          </a:blip>
-          <a:stretch>
-            <a:fillRect/>
-          </a:stretch>
-        </p:blipFill>
-        <p:spPr>
-          <a:xfrm>
-            <a:off x="202467" y="1504340"/>
-            <a:ext cx="8692725" cy="4929712"/>
-          </a:xfrm>
-          <a:prstGeom prst="rect">
-            <a:avLst/>
-          </a:prstGeom>
-        </p:spPr>
-      </p:pic>
-      <p:sp>
-        <p:nvSpPr>
-          <p:cNvPr id="3" name="ZoneTexte 2">
-            <a:extLst>
-              <a:ext uri="{FF2B5EF4-FFF2-40B4-BE49-F238E27FC236}">
-                <a16:creationId xmlns:a16="http://schemas.microsoft.com/office/drawing/2014/main" id="{C6DFA2C3-AD1B-BA11-FA55-D2193C7065A1}"/>
-              </a:ext>
-            </a:extLst>
-          </p:cNvPr>
-          <p:cNvSpPr txBox="1"/>
-          <p:nvPr/>
-        </p:nvSpPr>
-        <p:spPr>
-          <a:xfrm>
-            <a:off x="9060873" y="1454727"/>
-            <a:ext cx="3050771" cy="2031325"/>
-          </a:xfrm>
-          <a:prstGeom prst="rect">
-            <a:avLst/>
-          </a:prstGeom>
-          <a:noFill/>
-        </p:spPr>
-        <p:txBody>
-          <a:bodyPr wrap="square" rtlCol="0">
-            <a:spAutoFit/>
-          </a:bodyPr>
-          <a:lstStyle/>
-          <a:p>
-            <a:r>
-              <a:rPr lang="fr-FR" dirty="0"/>
-              <a:t>Changements:</a:t>
-            </a:r>
-          </a:p>
-          <a:p>
-            <a:pPr marL="285750" indent="-285750">
-              <a:buFontTx/>
-              <a:buChar char="-"/>
-            </a:pPr>
-            <a:r>
-              <a:rPr lang="fr-FR" dirty="0"/>
-              <a:t>Deux </a:t>
-            </a:r>
-            <a:r>
-              <a:rPr lang="fr-FR" dirty="0" err="1"/>
-              <a:t>BoardState</a:t>
-            </a:r>
-            <a:r>
-              <a:rPr lang="fr-FR" dirty="0"/>
-              <a:t> au lieu de un</a:t>
-            </a:r>
-          </a:p>
-          <a:p>
-            <a:pPr marL="285750" indent="-285750">
-              <a:buFontTx/>
-              <a:buChar char="-"/>
-            </a:pPr>
-            <a:r>
-              <a:rPr lang="fr-FR" dirty="0"/>
-              <a:t>Ajout de </a:t>
-            </a:r>
-            <a:r>
-              <a:rPr lang="fr-FR" dirty="0" err="1"/>
-              <a:t>GameStorage</a:t>
-            </a:r>
-            <a:r>
-              <a:rPr lang="fr-FR" dirty="0"/>
-              <a:t> pour sauvegarder les comptes des joueurs et les résultats des parties</a:t>
-            </a:r>
-            <a:endParaRPr lang="fr-CH" dirty="0"/>
-          </a:p>
-        </p:txBody>
-      </p:sp>
-    </p:spTree>
-    <p:extLst>
-      <p:ext uri="{BB962C8B-B14F-4D97-AF65-F5344CB8AC3E}">
-        <p14:creationId xmlns:p14="http://schemas.microsoft.com/office/powerpoint/2010/main" val="647219976"/>
-      </p:ext>
-    </p:extLst>
-  </p:cSld>
-  <p:clrMapOvr>
-    <a:masterClrMapping/>
-  </p:clrMapOvr>
-</p:sld>
-</file>
-
 <file path=ppt/slides/slide13.xml><?xml version="1.0" encoding="utf-8"?>
 <p:sld xmlns:a="http://schemas.openxmlformats.org/drawingml/2006/main" xmlns:r="http://schemas.openxmlformats.org/officeDocument/2006/relationships" xmlns:p="http://schemas.openxmlformats.org/presentationml/2006/main">
   <p:cSld>
@@ -4348,6 +4385,331 @@
           <p:cNvPr id="2" name="Titre 1">
             <a:extLst>
               <a:ext uri="{FF2B5EF4-FFF2-40B4-BE49-F238E27FC236}">
+                <a16:creationId xmlns:a16="http://schemas.microsoft.com/office/drawing/2014/main" id="{67EB3B64-2366-60B3-BFD9-2498BB6EE069}"/>
+              </a:ext>
+            </a:extLst>
+          </p:cNvPr>
+          <p:cNvSpPr>
+            <a:spLocks noGrp="1"/>
+          </p:cNvSpPr>
+          <p:nvPr>
+            <p:ph type="title"/>
+          </p:nvPr>
+        </p:nvSpPr>
+        <p:spPr/>
+        <p:txBody>
+          <a:bodyPr/>
+          <a:lstStyle/>
+          <a:p>
+            <a:r>
+              <a:rPr lang="fr-FR" dirty="0"/>
+              <a:t>Diagramme de composants</a:t>
+            </a:r>
+            <a:endParaRPr lang="fr-CH" dirty="0"/>
+          </a:p>
+        </p:txBody>
+      </p:sp>
+      <p:pic>
+        <p:nvPicPr>
+          <p:cNvPr id="15" name="Espace réservé du contenu 14">
+            <a:extLst>
+              <a:ext uri="{FF2B5EF4-FFF2-40B4-BE49-F238E27FC236}">
+                <a16:creationId xmlns:a16="http://schemas.microsoft.com/office/drawing/2014/main" id="{17C01AD7-76C3-A91C-9375-5D9B73813868}"/>
+              </a:ext>
+            </a:extLst>
+          </p:cNvPr>
+          <p:cNvPicPr>
+            <a:picLocks noGrp="1" noChangeAspect="1"/>
+          </p:cNvPicPr>
+          <p:nvPr>
+            <p:ph idx="1"/>
+          </p:nvPr>
+        </p:nvPicPr>
+        <p:blipFill>
+          <a:blip r:embed="rId2">
+            <a:extLst>
+              <a:ext uri="{28A0092B-C50C-407E-A947-70E740481C1C}">
+                <a14:useLocalDpi xmlns:a14="http://schemas.microsoft.com/office/drawing/2010/main" val="0"/>
+              </a:ext>
+            </a:extLst>
+          </a:blip>
+          <a:stretch>
+            <a:fillRect/>
+          </a:stretch>
+        </p:blipFill>
+        <p:spPr>
+          <a:xfrm>
+            <a:off x="956442" y="1485874"/>
+            <a:ext cx="9736752" cy="3380416"/>
+          </a:xfrm>
+          <a:prstGeom prst="rect">
+            <a:avLst/>
+          </a:prstGeom>
+        </p:spPr>
+      </p:pic>
+      <p:sp>
+        <p:nvSpPr>
+          <p:cNvPr id="16" name="ZoneTexte 15">
+            <a:extLst>
+              <a:ext uri="{FF2B5EF4-FFF2-40B4-BE49-F238E27FC236}">
+                <a16:creationId xmlns:a16="http://schemas.microsoft.com/office/drawing/2014/main" id="{49EC9D06-4915-AC97-BF0E-6B1E8A2A7C0D}"/>
+              </a:ext>
+            </a:extLst>
+          </p:cNvPr>
+          <p:cNvSpPr txBox="1"/>
+          <p:nvPr/>
+        </p:nvSpPr>
+        <p:spPr>
+          <a:xfrm>
+            <a:off x="741840" y="5121691"/>
+            <a:ext cx="10405241" cy="1477328"/>
+          </a:xfrm>
+          <a:prstGeom prst="rect">
+            <a:avLst/>
+          </a:prstGeom>
+          <a:noFill/>
+        </p:spPr>
+        <p:txBody>
+          <a:bodyPr wrap="square" rtlCol="0">
+            <a:spAutoFit/>
+          </a:bodyPr>
+          <a:lstStyle/>
+          <a:p>
+            <a:r>
+              <a:rPr lang="fr-FR" dirty="0"/>
+              <a:t>Changements:</a:t>
+            </a:r>
+          </a:p>
+          <a:p>
+            <a:endParaRPr lang="fr-FR" dirty="0"/>
+          </a:p>
+          <a:p>
+            <a:pPr marL="285750" indent="-285750">
+              <a:buFontTx/>
+              <a:buChar char="-"/>
+            </a:pPr>
+            <a:r>
+              <a:rPr lang="fr-FR" dirty="0"/>
+              <a:t>Ajout d’un Game Storage (DB) pour sauvegarder les informations des joueurs et les parties complétées</a:t>
+            </a:r>
+          </a:p>
+          <a:p>
+            <a:pPr marL="285750" indent="-285750">
+              <a:buFontTx/>
+              <a:buChar char="-"/>
+            </a:pPr>
+            <a:r>
+              <a:rPr lang="fr-FR" dirty="0"/>
+              <a:t>Ajout d’un utilitaire pour chiffrer les communications</a:t>
+            </a:r>
+            <a:endParaRPr lang="fr-CH" dirty="0"/>
+          </a:p>
+        </p:txBody>
+      </p:sp>
+    </p:spTree>
+    <p:extLst>
+      <p:ext uri="{BB962C8B-B14F-4D97-AF65-F5344CB8AC3E}">
+        <p14:creationId xmlns:p14="http://schemas.microsoft.com/office/powerpoint/2010/main" val="3567787778"/>
+      </p:ext>
+    </p:extLst>
+  </p:cSld>
+  <p:clrMapOvr>
+    <a:masterClrMapping/>
+  </p:clrMapOvr>
+</p:sld>
+</file>
+
+<file path=ppt/slides/slide14.xml><?xml version="1.0" encoding="utf-8"?>
+<p:sld xmlns:a="http://schemas.openxmlformats.org/drawingml/2006/main" xmlns:r="http://schemas.openxmlformats.org/officeDocument/2006/relationships" xmlns:p="http://schemas.openxmlformats.org/presentationml/2006/main">
+  <p:cSld>
+    <p:spTree>
+      <p:nvGrpSpPr>
+        <p:cNvPr id="1" name=""/>
+        <p:cNvGrpSpPr/>
+        <p:nvPr/>
+      </p:nvGrpSpPr>
+      <p:grpSpPr>
+        <a:xfrm>
+          <a:off x="0" y="0"/>
+          <a:ext cx="0" cy="0"/>
+          <a:chOff x="0" y="0"/>
+          <a:chExt cx="0" cy="0"/>
+        </a:xfrm>
+      </p:grpSpPr>
+      <p:sp>
+        <p:nvSpPr>
+          <p:cNvPr id="2" name="Titre 1">
+            <a:extLst>
+              <a:ext uri="{FF2B5EF4-FFF2-40B4-BE49-F238E27FC236}">
+                <a16:creationId xmlns:a16="http://schemas.microsoft.com/office/drawing/2014/main" id="{6F8B31E1-F7FB-5E99-EA45-073B057750A6}"/>
+              </a:ext>
+            </a:extLst>
+          </p:cNvPr>
+          <p:cNvSpPr>
+            <a:spLocks noGrp="1"/>
+          </p:cNvSpPr>
+          <p:nvPr>
+            <p:ph type="title"/>
+          </p:nvPr>
+        </p:nvSpPr>
+        <p:spPr/>
+        <p:txBody>
+          <a:bodyPr/>
+          <a:lstStyle/>
+          <a:p>
+            <a:r>
+              <a:rPr lang="fr-FR" dirty="0"/>
+              <a:t>Diagramme de classes</a:t>
+            </a:r>
+            <a:endParaRPr lang="fr-CH" dirty="0"/>
+          </a:p>
+        </p:txBody>
+      </p:sp>
+      <p:pic>
+        <p:nvPicPr>
+          <p:cNvPr id="7" name="Espace réservé du contenu 6">
+            <a:extLst>
+              <a:ext uri="{FF2B5EF4-FFF2-40B4-BE49-F238E27FC236}">
+                <a16:creationId xmlns:a16="http://schemas.microsoft.com/office/drawing/2014/main" id="{D8B6CC18-9E52-AC71-36F7-498250F244B7}"/>
+              </a:ext>
+            </a:extLst>
+          </p:cNvPr>
+          <p:cNvPicPr>
+            <a:picLocks noGrp="1" noChangeAspect="1"/>
+          </p:cNvPicPr>
+          <p:nvPr>
+            <p:ph idx="1"/>
+          </p:nvPr>
+        </p:nvPicPr>
+        <p:blipFill>
+          <a:blip r:embed="rId2">
+            <a:extLst>
+              <a:ext uri="{28A0092B-C50C-407E-A947-70E740481C1C}">
+                <a14:useLocalDpi xmlns:a14="http://schemas.microsoft.com/office/drawing/2010/main" val="0"/>
+              </a:ext>
+            </a:extLst>
+          </a:blip>
+          <a:stretch>
+            <a:fillRect/>
+          </a:stretch>
+        </p:blipFill>
+        <p:spPr>
+          <a:xfrm>
+            <a:off x="202467" y="1504340"/>
+            <a:ext cx="8692725" cy="4929712"/>
+          </a:xfrm>
+          <a:prstGeom prst="rect">
+            <a:avLst/>
+          </a:prstGeom>
+        </p:spPr>
+      </p:pic>
+      <p:sp>
+        <p:nvSpPr>
+          <p:cNvPr id="3" name="ZoneTexte 2">
+            <a:extLst>
+              <a:ext uri="{FF2B5EF4-FFF2-40B4-BE49-F238E27FC236}">
+                <a16:creationId xmlns:a16="http://schemas.microsoft.com/office/drawing/2014/main" id="{C6DFA2C3-AD1B-BA11-FA55-D2193C7065A1}"/>
+              </a:ext>
+            </a:extLst>
+          </p:cNvPr>
+          <p:cNvSpPr txBox="1"/>
+          <p:nvPr/>
+        </p:nvSpPr>
+        <p:spPr>
+          <a:xfrm>
+            <a:off x="9060873" y="1454727"/>
+            <a:ext cx="3050771" cy="2031325"/>
+          </a:xfrm>
+          <a:prstGeom prst="rect">
+            <a:avLst/>
+          </a:prstGeom>
+          <a:noFill/>
+        </p:spPr>
+        <p:txBody>
+          <a:bodyPr wrap="square" rtlCol="0">
+            <a:spAutoFit/>
+          </a:bodyPr>
+          <a:lstStyle/>
+          <a:p>
+            <a:r>
+              <a:rPr lang="fr-FR" dirty="0"/>
+              <a:t>Changements:</a:t>
+            </a:r>
+          </a:p>
+          <a:p>
+            <a:pPr marL="285750" indent="-285750">
+              <a:buFontTx/>
+              <a:buChar char="-"/>
+            </a:pPr>
+            <a:r>
+              <a:rPr lang="fr-FR" dirty="0"/>
+              <a:t>Deux </a:t>
+            </a:r>
+            <a:r>
+              <a:rPr lang="fr-FR" dirty="0" err="1"/>
+              <a:t>BoardState</a:t>
+            </a:r>
+            <a:r>
+              <a:rPr lang="fr-FR" dirty="0"/>
+              <a:t> au lieu de un</a:t>
+            </a:r>
+          </a:p>
+          <a:p>
+            <a:pPr marL="285750" indent="-285750">
+              <a:buFontTx/>
+              <a:buChar char="-"/>
+            </a:pPr>
+            <a:r>
+              <a:rPr lang="fr-FR" dirty="0"/>
+              <a:t>Ajout de </a:t>
+            </a:r>
+            <a:r>
+              <a:rPr lang="fr-FR" dirty="0" err="1"/>
+              <a:t>GameStorage</a:t>
+            </a:r>
+            <a:r>
+              <a:rPr lang="fr-FR" dirty="0"/>
+              <a:t> pour sauvegarder les comptes des joueurs et les résultats des parties</a:t>
+            </a:r>
+            <a:endParaRPr lang="fr-CH" dirty="0"/>
+          </a:p>
+        </p:txBody>
+      </p:sp>
+    </p:spTree>
+    <p:extLst>
+      <p:ext uri="{BB962C8B-B14F-4D97-AF65-F5344CB8AC3E}">
+        <p14:creationId xmlns:p14="http://schemas.microsoft.com/office/powerpoint/2010/main" val="647219976"/>
+      </p:ext>
+    </p:extLst>
+  </p:cSld>
+  <p:clrMapOvr>
+    <a:masterClrMapping/>
+  </p:clrMapOvr>
+</p:sld>
+</file>
+
+<file path=ppt/slides/slide15.xml><?xml version="1.0" encoding="utf-8"?>
+<p:sld xmlns:a="http://schemas.openxmlformats.org/drawingml/2006/main" xmlns:r="http://schemas.openxmlformats.org/officeDocument/2006/relationships" xmlns:p="http://schemas.openxmlformats.org/presentationml/2006/main">
+  <p:cSld>
+    <p:spTree>
+      <p:nvGrpSpPr>
+        <p:cNvPr id="1" name=""/>
+        <p:cNvGrpSpPr/>
+        <p:nvPr/>
+      </p:nvGrpSpPr>
+      <p:grpSpPr>
+        <a:xfrm>
+          <a:off x="0" y="0"/>
+          <a:ext cx="0" cy="0"/>
+          <a:chOff x="0" y="0"/>
+          <a:chExt cx="0" cy="0"/>
+        </a:xfrm>
+      </p:grpSpPr>
+      <p:sp>
+        <p:nvSpPr>
+          <p:cNvPr id="2" name="Titre 1">
+            <a:extLst>
+              <a:ext uri="{FF2B5EF4-FFF2-40B4-BE49-F238E27FC236}">
                 <a16:creationId xmlns:a16="http://schemas.microsoft.com/office/drawing/2014/main" id="{1F944A1B-5D11-648A-2775-DC7C5644520E}"/>
               </a:ext>
             </a:extLst>
@@ -4467,7 +4829,7 @@
 </p:sld>
 </file>
 
-<file path=ppt/slides/slide14.xml><?xml version="1.0" encoding="utf-8"?>
+<file path=ppt/slides/slide16.xml><?xml version="1.0" encoding="utf-8"?>
 <p:sld xmlns:a="http://schemas.openxmlformats.org/drawingml/2006/main" xmlns:r="http://schemas.openxmlformats.org/officeDocument/2006/relationships" xmlns:p="http://schemas.openxmlformats.org/presentationml/2006/main">
   <p:cSld>
     <p:spTree>
@@ -4540,7 +4902,7 @@
 </p:sld>
 </file>
 
-<file path=ppt/slides/slide15.xml><?xml version="1.0" encoding="utf-8"?>
+<file path=ppt/slides/slide17.xml><?xml version="1.0" encoding="utf-8"?>
 <p:sld xmlns:a="http://schemas.openxmlformats.org/drawingml/2006/main" xmlns:r="http://schemas.openxmlformats.org/officeDocument/2006/relationships" xmlns:p="http://schemas.openxmlformats.org/presentationml/2006/main">
   <p:cSld>
     <p:spTree>
@@ -4938,7 +5300,7 @@
 </p:sld>
 </file>
 
-<file path=ppt/slides/slide16.xml><?xml version="1.0" encoding="utf-8"?>
+<file path=ppt/slides/slide18.xml><?xml version="1.0" encoding="utf-8"?>
 <p:sld xmlns:a="http://schemas.openxmlformats.org/drawingml/2006/main" xmlns:r="http://schemas.openxmlformats.org/officeDocument/2006/relationships" xmlns:p="http://schemas.openxmlformats.org/presentationml/2006/main">
   <p:cSld>
     <p:spTree>
@@ -5082,7 +5444,7 @@
 </p:sld>
 </file>
 
-<file path=ppt/slides/slide17.xml><?xml version="1.0" encoding="utf-8"?>
+<file path=ppt/slides/slide19.xml><?xml version="1.0" encoding="utf-8"?>
 <p:sld xmlns:a="http://schemas.openxmlformats.org/drawingml/2006/main" xmlns:r="http://schemas.openxmlformats.org/officeDocument/2006/relationships" xmlns:p="http://schemas.openxmlformats.org/presentationml/2006/main">
   <p:cSld>
     <p:spTree>
@@ -6153,6 +6515,335 @@
         <p:cNvPr id="1" name="">
           <a:extLst>
             <a:ext uri="{FF2B5EF4-FFF2-40B4-BE49-F238E27FC236}">
+              <a16:creationId xmlns:a16="http://schemas.microsoft.com/office/drawing/2014/main" id="{F3AE104D-CFB4-514D-D227-FCECB5C1741E}"/>
+            </a:ext>
+          </a:extLst>
+        </p:cNvPr>
+        <p:cNvGrpSpPr/>
+        <p:nvPr/>
+      </p:nvGrpSpPr>
+      <p:grpSpPr>
+        <a:xfrm>
+          <a:off x="0" y="0"/>
+          <a:ext cx="0" cy="0"/>
+          <a:chOff x="0" y="0"/>
+          <a:chExt cx="0" cy="0"/>
+        </a:xfrm>
+      </p:grpSpPr>
+      <p:sp>
+        <p:nvSpPr>
+          <p:cNvPr id="2" name="Title 1">
+            <a:extLst>
+              <a:ext uri="{FF2B5EF4-FFF2-40B4-BE49-F238E27FC236}">
+                <a16:creationId xmlns:a16="http://schemas.microsoft.com/office/drawing/2014/main" id="{E953B858-6690-34CA-4BD4-06255BE14D3B}"/>
+              </a:ext>
+            </a:extLst>
+          </p:cNvPr>
+          <p:cNvSpPr>
+            <a:spLocks noGrp="1"/>
+          </p:cNvSpPr>
+          <p:nvPr>
+            <p:ph type="title"/>
+          </p:nvPr>
+        </p:nvSpPr>
+        <p:spPr/>
+        <p:txBody>
+          <a:bodyPr/>
+          <a:lstStyle/>
+          <a:p>
+            <a:r>
+              <a:rPr lang="fr-CH" b="1" dirty="0">
+                <a:latin typeface="Aptos Display (En-têtes)"/>
+              </a:rPr>
+              <a:t>M1 : Multi-plateaux</a:t>
+            </a:r>
+            <a:endParaRPr lang="en-CH" b="1" dirty="0">
+              <a:latin typeface="Aptos Display (En-têtes)"/>
+            </a:endParaRPr>
+          </a:p>
+        </p:txBody>
+      </p:sp>
+      <p:sp>
+        <p:nvSpPr>
+          <p:cNvPr id="3" name="Content Placeholder 2">
+            <a:extLst>
+              <a:ext uri="{FF2B5EF4-FFF2-40B4-BE49-F238E27FC236}">
+                <a16:creationId xmlns:a16="http://schemas.microsoft.com/office/drawing/2014/main" id="{6A5599DC-13B0-0FED-79A6-A26359CB1671}"/>
+              </a:ext>
+            </a:extLst>
+          </p:cNvPr>
+          <p:cNvSpPr>
+            <a:spLocks noGrp="1"/>
+          </p:cNvSpPr>
+          <p:nvPr>
+            <p:ph idx="1"/>
+          </p:nvPr>
+        </p:nvSpPr>
+        <p:spPr/>
+        <p:txBody>
+          <a:bodyPr>
+            <a:normAutofit/>
+          </a:bodyPr>
+          <a:lstStyle/>
+          <a:p>
+            <a:r>
+              <a:rPr lang="fr-FR" b="1" dirty="0"/>
+              <a:t>Stratégie :</a:t>
+            </a:r>
+          </a:p>
+          <a:p>
+            <a:pPr lvl="1"/>
+            <a:r>
+              <a:rPr lang="fr-FR" dirty="0"/>
+              <a:t>Mise en place de deux plateaux </a:t>
+            </a:r>
+            <a:r>
+              <a:rPr lang="fr-FR" dirty="0">
+                <a:latin typeface="Avenir Next LT Pro Light" panose="020B0304020202020204" pitchFamily="34" charset="0"/>
+              </a:rPr>
+              <a:t>(</a:t>
+            </a:r>
+            <a:r>
+              <a:rPr lang="fr-FR" dirty="0" err="1">
+                <a:latin typeface="Avenir Next LT Pro Light" panose="020B0304020202020204" pitchFamily="34" charset="0"/>
+              </a:rPr>
+              <a:t>european</a:t>
+            </a:r>
+            <a:r>
+              <a:rPr lang="fr-FR" dirty="0">
+                <a:latin typeface="Avenir Next LT Pro Light" panose="020B0304020202020204" pitchFamily="34" charset="0"/>
+              </a:rPr>
+              <a:t> et mini)</a:t>
+            </a:r>
+            <a:endParaRPr lang="fr-FR" i="1" dirty="0">
+              <a:latin typeface="Avenir Next LT Pro Light" panose="020B0304020202020204" pitchFamily="34" charset="0"/>
+            </a:endParaRPr>
+          </a:p>
+          <a:p>
+            <a:pPr lvl="1"/>
+            <a:r>
+              <a:rPr lang="fr-FR" dirty="0"/>
+              <a:t>Chaque joueur est verrouillé sur son premier plateau choisi</a:t>
+            </a:r>
+          </a:p>
+          <a:p>
+            <a:pPr lvl="1"/>
+            <a:r>
+              <a:rPr lang="fr-FR" dirty="0"/>
+              <a:t>Traitement des paris séparé selon le plateau</a:t>
+            </a:r>
+          </a:p>
+          <a:p>
+            <a:pPr marL="457200" lvl="1" indent="0">
+              <a:buNone/>
+            </a:pPr>
+            <a:endParaRPr lang="fr-FR" dirty="0"/>
+          </a:p>
+          <a:p>
+            <a:r>
+              <a:rPr lang="fr-CH" b="1" dirty="0"/>
+              <a:t>Coût / Complexité </a:t>
+            </a:r>
+            <a:r>
+              <a:rPr lang="fr-FR" b="1" dirty="0"/>
+              <a:t> :</a:t>
+            </a:r>
+          </a:p>
+          <a:p>
+            <a:pPr lvl="1"/>
+            <a:r>
+              <a:rPr lang="fr-FR" i="1" dirty="0"/>
+              <a:t> </a:t>
+            </a:r>
+            <a:r>
+              <a:rPr lang="fr-FR" dirty="0"/>
+              <a:t>Complexité moyenne, adaptation des modèles et des règles métier</a:t>
+            </a:r>
+          </a:p>
+          <a:p>
+            <a:pPr lvl="1"/>
+            <a:r>
+              <a:rPr lang="fr-FR" dirty="0"/>
+              <a:t>Coût faible, logique réutilisée entre les plateaux</a:t>
+            </a:r>
+            <a:endParaRPr lang="fr-FR" i="1" dirty="0"/>
+          </a:p>
+        </p:txBody>
+      </p:sp>
+    </p:spTree>
+    <p:extLst>
+      <p:ext uri="{BB962C8B-B14F-4D97-AF65-F5344CB8AC3E}">
+        <p14:creationId xmlns:p14="http://schemas.microsoft.com/office/powerpoint/2010/main" val="4214559735"/>
+      </p:ext>
+    </p:extLst>
+  </p:cSld>
+  <p:clrMapOvr>
+    <a:masterClrMapping/>
+  </p:clrMapOvr>
+</p:sld>
+</file>
+
+<file path=ppt/slides/slide8.xml><?xml version="1.0" encoding="utf-8"?>
+<p:sld xmlns:a="http://schemas.openxmlformats.org/drawingml/2006/main" xmlns:r="http://schemas.openxmlformats.org/officeDocument/2006/relationships" xmlns:p="http://schemas.openxmlformats.org/presentationml/2006/main">
+  <p:cSld>
+    <p:spTree>
+      <p:nvGrpSpPr>
+        <p:cNvPr id="1" name="">
+          <a:extLst>
+            <a:ext uri="{FF2B5EF4-FFF2-40B4-BE49-F238E27FC236}">
+              <a16:creationId xmlns:a16="http://schemas.microsoft.com/office/drawing/2014/main" id="{E348C80F-B5F0-10E0-D4F3-F8C5FEFA33A5}"/>
+            </a:ext>
+          </a:extLst>
+        </p:cNvPr>
+        <p:cNvGrpSpPr/>
+        <p:nvPr/>
+      </p:nvGrpSpPr>
+      <p:grpSpPr>
+        <a:xfrm>
+          <a:off x="0" y="0"/>
+          <a:ext cx="0" cy="0"/>
+          <a:chOff x="0" y="0"/>
+          <a:chExt cx="0" cy="0"/>
+        </a:xfrm>
+      </p:grpSpPr>
+      <p:sp>
+        <p:nvSpPr>
+          <p:cNvPr id="2" name="Title 1">
+            <a:extLst>
+              <a:ext uri="{FF2B5EF4-FFF2-40B4-BE49-F238E27FC236}">
+                <a16:creationId xmlns:a16="http://schemas.microsoft.com/office/drawing/2014/main" id="{B2C3B44C-E900-9605-971B-88BE481A0648}"/>
+              </a:ext>
+            </a:extLst>
+          </p:cNvPr>
+          <p:cNvSpPr>
+            <a:spLocks noGrp="1"/>
+          </p:cNvSpPr>
+          <p:nvPr>
+            <p:ph type="title"/>
+          </p:nvPr>
+        </p:nvSpPr>
+        <p:spPr/>
+        <p:txBody>
+          <a:bodyPr/>
+          <a:lstStyle/>
+          <a:p>
+            <a:r>
+              <a:rPr lang="fr-FR" b="1" dirty="0"/>
+              <a:t>M2 : Paris simultanés sur une même case</a:t>
+            </a:r>
+            <a:endParaRPr lang="en-CH" b="1" dirty="0">
+              <a:latin typeface="Aptos Display (En-têtes)"/>
+            </a:endParaRPr>
+          </a:p>
+        </p:txBody>
+      </p:sp>
+      <p:sp>
+        <p:nvSpPr>
+          <p:cNvPr id="3" name="Content Placeholder 2">
+            <a:extLst>
+              <a:ext uri="{FF2B5EF4-FFF2-40B4-BE49-F238E27FC236}">
+                <a16:creationId xmlns:a16="http://schemas.microsoft.com/office/drawing/2014/main" id="{1C61ABCB-4067-B4EB-028D-BD6A0F9B8B57}"/>
+              </a:ext>
+            </a:extLst>
+          </p:cNvPr>
+          <p:cNvSpPr>
+            <a:spLocks noGrp="1"/>
+          </p:cNvSpPr>
+          <p:nvPr>
+            <p:ph idx="1"/>
+          </p:nvPr>
+        </p:nvSpPr>
+        <p:spPr/>
+        <p:txBody>
+          <a:bodyPr>
+            <a:normAutofit/>
+          </a:bodyPr>
+          <a:lstStyle/>
+          <a:p>
+            <a:r>
+              <a:rPr lang="fr-FR" b="1" dirty="0"/>
+              <a:t>Stratégie :</a:t>
+            </a:r>
+          </a:p>
+          <a:p>
+            <a:pPr lvl="1"/>
+            <a:r>
+              <a:rPr lang="fr-FR" dirty="0"/>
+              <a:t>Plusieurs joueurs peuvent parier sur le même numéro</a:t>
+            </a:r>
+          </a:p>
+          <a:p>
+            <a:pPr lvl="1"/>
+            <a:r>
+              <a:rPr lang="fr-FR" dirty="0"/>
+              <a:t>Les paris sont stockés individuellement par utilisateur</a:t>
+            </a:r>
+          </a:p>
+          <a:p>
+            <a:pPr lvl="1"/>
+            <a:r>
+              <a:rPr lang="fr-FR" dirty="0"/>
+              <a:t>Les gains sont calculés séparément pour chaque joueur</a:t>
+            </a:r>
+          </a:p>
+          <a:p>
+            <a:pPr marL="457200" lvl="1" indent="0">
+              <a:buNone/>
+            </a:pPr>
+            <a:endParaRPr lang="fr-FR" dirty="0"/>
+          </a:p>
+          <a:p>
+            <a:r>
+              <a:rPr lang="fr-CH" b="1" dirty="0"/>
+              <a:t>Coût / Complexité </a:t>
+            </a:r>
+            <a:r>
+              <a:rPr lang="fr-FR" b="1" dirty="0"/>
+              <a:t> :</a:t>
+            </a:r>
+          </a:p>
+          <a:p>
+            <a:pPr lvl="1"/>
+            <a:r>
+              <a:rPr lang="fr-FR" i="1" dirty="0"/>
+              <a:t> </a:t>
+            </a:r>
+            <a:r>
+              <a:rPr lang="fr-FR" dirty="0"/>
+              <a:t>Complexité faible à moyenne, adaptation de la gestion des paris</a:t>
+            </a:r>
+          </a:p>
+          <a:p>
+            <a:pPr lvl="1"/>
+            <a:r>
+              <a:rPr lang="fr-FR" dirty="0"/>
+              <a:t>Coût faible, extension de la structure existante des bets</a:t>
+            </a:r>
+            <a:endParaRPr lang="fr-FR" i="1" dirty="0"/>
+          </a:p>
+        </p:txBody>
+      </p:sp>
+    </p:spTree>
+    <p:extLst>
+      <p:ext uri="{BB962C8B-B14F-4D97-AF65-F5344CB8AC3E}">
+        <p14:creationId xmlns:p14="http://schemas.microsoft.com/office/powerpoint/2010/main" val="1938041985"/>
+      </p:ext>
+    </p:extLst>
+  </p:cSld>
+  <p:clrMapOvr>
+    <a:masterClrMapping/>
+  </p:clrMapOvr>
+</p:sld>
+</file>
+
+<file path=ppt/slides/slide9.xml><?xml version="1.0" encoding="utf-8"?>
+<p:sld xmlns:a="http://schemas.openxmlformats.org/drawingml/2006/main" xmlns:r="http://schemas.openxmlformats.org/officeDocument/2006/relationships" xmlns:p="http://schemas.openxmlformats.org/presentationml/2006/main">
+  <p:cSld>
+    <p:spTree>
+      <p:nvGrpSpPr>
+        <p:cNvPr id="1" name="">
+          <a:extLst>
+            <a:ext uri="{FF2B5EF4-FFF2-40B4-BE49-F238E27FC236}">
               <a16:creationId xmlns:a16="http://schemas.microsoft.com/office/drawing/2014/main" id="{37E36248-B648-6411-FA48-C63F5833B1CD}"/>
             </a:ext>
           </a:extLst>
@@ -6209,366 +6900,6 @@
     <p:extLst>
       <p:ext uri="{BB962C8B-B14F-4D97-AF65-F5344CB8AC3E}">
         <p14:creationId xmlns:p14="http://schemas.microsoft.com/office/powerpoint/2010/main" val="2353254362"/>
-      </p:ext>
-    </p:extLst>
-  </p:cSld>
-  <p:clrMapOvr>
-    <a:masterClrMapping/>
-  </p:clrMapOvr>
-</p:sld>
-</file>
-
-<file path=ppt/slides/slide8.xml><?xml version="1.0" encoding="utf-8"?>
-<p:sld xmlns:a="http://schemas.openxmlformats.org/drawingml/2006/main" xmlns:r="http://schemas.openxmlformats.org/officeDocument/2006/relationships" xmlns:p="http://schemas.openxmlformats.org/presentationml/2006/main">
-  <p:cSld>
-    <p:spTree>
-      <p:nvGrpSpPr>
-        <p:cNvPr id="1" name=""/>
-        <p:cNvGrpSpPr/>
-        <p:nvPr/>
-      </p:nvGrpSpPr>
-      <p:grpSpPr>
-        <a:xfrm>
-          <a:off x="0" y="0"/>
-          <a:ext cx="0" cy="0"/>
-          <a:chOff x="0" y="0"/>
-          <a:chExt cx="0" cy="0"/>
-        </a:xfrm>
-      </p:grpSpPr>
-      <p:sp>
-        <p:nvSpPr>
-          <p:cNvPr id="2" name="Title 1">
-            <a:extLst>
-              <a:ext uri="{FF2B5EF4-FFF2-40B4-BE49-F238E27FC236}">
-                <a16:creationId xmlns:a16="http://schemas.microsoft.com/office/drawing/2014/main" id="{DC8C0BBD-B33A-5BF5-1A3D-5D6F55E62D93}"/>
-              </a:ext>
-            </a:extLst>
-          </p:cNvPr>
-          <p:cNvSpPr>
-            <a:spLocks noGrp="1"/>
-          </p:cNvSpPr>
-          <p:nvPr>
-            <p:ph type="title"/>
-          </p:nvPr>
-        </p:nvSpPr>
-        <p:spPr>
-          <a:xfrm>
-            <a:off x="838200" y="732987"/>
-            <a:ext cx="10515600" cy="1325563"/>
-          </a:xfrm>
-        </p:spPr>
-        <p:txBody>
-          <a:bodyPr/>
-          <a:lstStyle/>
-          <a:p>
-            <a:r>
-              <a:rPr lang="fr-FR" dirty="0"/>
-              <a:t>Diagramme de</a:t>
-            </a:r>
-            <a:br>
-              <a:rPr lang="fr-FR" dirty="0"/>
-            </a:br>
-            <a:r>
-              <a:rPr lang="fr-FR" dirty="0" err="1"/>
-              <a:t>Usecase</a:t>
-            </a:r>
-            <a:endParaRPr lang="en-CH" dirty="0"/>
-          </a:p>
-        </p:txBody>
-      </p:sp>
-      <p:pic>
-        <p:nvPicPr>
-          <p:cNvPr id="7" name="Espace réservé du contenu 6">
-            <a:extLst>
-              <a:ext uri="{FF2B5EF4-FFF2-40B4-BE49-F238E27FC236}">
-                <a16:creationId xmlns:a16="http://schemas.microsoft.com/office/drawing/2014/main" id="{46145EAE-B2DC-7C6C-6A5F-2F186CDA0BA8}"/>
-              </a:ext>
-            </a:extLst>
-          </p:cNvPr>
-          <p:cNvPicPr>
-            <a:picLocks noGrp="1" noChangeAspect="1"/>
-          </p:cNvPicPr>
-          <p:nvPr>
-            <p:ph idx="1"/>
-          </p:nvPr>
-        </p:nvPicPr>
-        <p:blipFill>
-          <a:blip r:embed="rId2">
-            <a:extLst>
-              <a:ext uri="{28A0092B-C50C-407E-A947-70E740481C1C}">
-                <a14:useLocalDpi xmlns:a14="http://schemas.microsoft.com/office/drawing/2010/main" val="0"/>
-              </a:ext>
-            </a:extLst>
-          </a:blip>
-          <a:stretch>
-            <a:fillRect/>
-          </a:stretch>
-        </p:blipFill>
-        <p:spPr>
-          <a:xfrm>
-            <a:off x="5363066" y="530144"/>
-            <a:ext cx="5620243" cy="5594869"/>
-          </a:xfrm>
-          <a:prstGeom prst="rect">
-            <a:avLst/>
-          </a:prstGeom>
-        </p:spPr>
-      </p:pic>
-      <p:sp>
-        <p:nvSpPr>
-          <p:cNvPr id="8" name="ZoneTexte 7">
-            <a:extLst>
-              <a:ext uri="{FF2B5EF4-FFF2-40B4-BE49-F238E27FC236}">
-                <a16:creationId xmlns:a16="http://schemas.microsoft.com/office/drawing/2014/main" id="{622F10BA-8BDE-647C-2FE3-05E029519E53}"/>
-              </a:ext>
-            </a:extLst>
-          </p:cNvPr>
-          <p:cNvSpPr txBox="1"/>
-          <p:nvPr/>
-        </p:nvSpPr>
-        <p:spPr>
-          <a:xfrm>
-            <a:off x="725214" y="2343807"/>
-            <a:ext cx="4267361" cy="1754326"/>
-          </a:xfrm>
-          <a:prstGeom prst="rect">
-            <a:avLst/>
-          </a:prstGeom>
-          <a:noFill/>
-        </p:spPr>
-        <p:txBody>
-          <a:bodyPr wrap="square" rtlCol="0">
-            <a:spAutoFit/>
-          </a:bodyPr>
-          <a:lstStyle/>
-          <a:p>
-            <a:r>
-              <a:rPr lang="fr-FR" dirty="0"/>
-              <a:t>Changement:</a:t>
-            </a:r>
-          </a:p>
-          <a:p>
-            <a:endParaRPr lang="fr-FR" dirty="0"/>
-          </a:p>
-          <a:p>
-            <a:pPr marL="285750" indent="-285750">
-              <a:buFontTx/>
-              <a:buChar char="-"/>
-            </a:pPr>
-            <a:r>
-              <a:rPr lang="fr-FR" dirty="0"/>
-              <a:t>Deux plateaux de jeu</a:t>
-            </a:r>
-          </a:p>
-          <a:p>
-            <a:pPr marL="285750" indent="-285750">
-              <a:buFontTx/>
-              <a:buChar char="-"/>
-            </a:pPr>
-            <a:endParaRPr lang="fr-FR" dirty="0"/>
-          </a:p>
-          <a:p>
-            <a:pPr marL="285750" indent="-285750">
-              <a:buFontTx/>
-              <a:buChar char="-"/>
-            </a:pPr>
-            <a:r>
-              <a:rPr lang="fr-FR" dirty="0"/>
-              <a:t>Les joueurs peuvent choisir le plateau sur lequel jouer entre chaque partie</a:t>
-            </a:r>
-          </a:p>
-        </p:txBody>
-      </p:sp>
-    </p:spTree>
-    <p:extLst>
-      <p:ext uri="{BB962C8B-B14F-4D97-AF65-F5344CB8AC3E}">
-        <p14:creationId xmlns:p14="http://schemas.microsoft.com/office/powerpoint/2010/main" val="2148361823"/>
-      </p:ext>
-    </p:extLst>
-  </p:cSld>
-  <p:clrMapOvr>
-    <a:masterClrMapping/>
-  </p:clrMapOvr>
-</p:sld>
-</file>
-
-<file path=ppt/slides/slide9.xml><?xml version="1.0" encoding="utf-8"?>
-<p:sld xmlns:a="http://schemas.openxmlformats.org/drawingml/2006/main" xmlns:r="http://schemas.openxmlformats.org/officeDocument/2006/relationships" xmlns:p="http://schemas.openxmlformats.org/presentationml/2006/main">
-  <p:cSld>
-    <p:spTree>
-      <p:nvGrpSpPr>
-        <p:cNvPr id="1" name=""/>
-        <p:cNvGrpSpPr/>
-        <p:nvPr/>
-      </p:nvGrpSpPr>
-      <p:grpSpPr>
-        <a:xfrm>
-          <a:off x="0" y="0"/>
-          <a:ext cx="0" cy="0"/>
-          <a:chOff x="0" y="0"/>
-          <a:chExt cx="0" cy="0"/>
-        </a:xfrm>
-      </p:grpSpPr>
-      <p:sp>
-        <p:nvSpPr>
-          <p:cNvPr id="2" name="Title 1">
-            <a:extLst>
-              <a:ext uri="{FF2B5EF4-FFF2-40B4-BE49-F238E27FC236}">
-                <a16:creationId xmlns:a16="http://schemas.microsoft.com/office/drawing/2014/main" id="{36F7B8CE-B221-F8E8-E3DF-09FDE7AF6F91}"/>
-              </a:ext>
-            </a:extLst>
-          </p:cNvPr>
-          <p:cNvSpPr>
-            <a:spLocks noGrp="1"/>
-          </p:cNvSpPr>
-          <p:nvPr>
-            <p:ph type="title"/>
-          </p:nvPr>
-        </p:nvSpPr>
-        <p:spPr/>
-        <p:txBody>
-          <a:bodyPr/>
-          <a:lstStyle/>
-          <a:p>
-            <a:r>
-              <a:rPr lang="fr-FR" dirty="0"/>
-              <a:t>DFD</a:t>
-            </a:r>
-            <a:endParaRPr lang="en-CH" dirty="0"/>
-          </a:p>
-        </p:txBody>
-      </p:sp>
-      <p:pic>
-        <p:nvPicPr>
-          <p:cNvPr id="7" name="Espace réservé du contenu 6">
-            <a:extLst>
-              <a:ext uri="{FF2B5EF4-FFF2-40B4-BE49-F238E27FC236}">
-                <a16:creationId xmlns:a16="http://schemas.microsoft.com/office/drawing/2014/main" id="{4987C348-78D1-4E51-9D58-97A6D15A2FAC}"/>
-              </a:ext>
-            </a:extLst>
-          </p:cNvPr>
-          <p:cNvPicPr>
-            <a:picLocks noGrp="1" noChangeAspect="1"/>
-          </p:cNvPicPr>
-          <p:nvPr>
-            <p:ph idx="1"/>
-          </p:nvPr>
-        </p:nvPicPr>
-        <p:blipFill>
-          <a:blip r:embed="rId2">
-            <a:extLst>
-              <a:ext uri="{28A0092B-C50C-407E-A947-70E740481C1C}">
-                <a14:useLocalDpi xmlns:a14="http://schemas.microsoft.com/office/drawing/2010/main" val="0"/>
-              </a:ext>
-            </a:extLst>
-          </a:blip>
-          <a:stretch>
-            <a:fillRect/>
-          </a:stretch>
-        </p:blipFill>
-        <p:spPr>
-          <a:xfrm>
-            <a:off x="4377894" y="234022"/>
-            <a:ext cx="6975906" cy="6258853"/>
-          </a:xfrm>
-          <a:prstGeom prst="rect">
-            <a:avLst/>
-          </a:prstGeom>
-        </p:spPr>
-      </p:pic>
-      <p:sp>
-        <p:nvSpPr>
-          <p:cNvPr id="8" name="ZoneTexte 7">
-            <a:extLst>
-              <a:ext uri="{FF2B5EF4-FFF2-40B4-BE49-F238E27FC236}">
-                <a16:creationId xmlns:a16="http://schemas.microsoft.com/office/drawing/2014/main" id="{8486416A-D519-8D5D-A582-E2519E7B9110}"/>
-              </a:ext>
-            </a:extLst>
-          </p:cNvPr>
-          <p:cNvSpPr txBox="1"/>
-          <p:nvPr/>
-        </p:nvSpPr>
-        <p:spPr>
-          <a:xfrm>
-            <a:off x="262759" y="1690688"/>
-            <a:ext cx="4035972" cy="3416320"/>
-          </a:xfrm>
-          <a:prstGeom prst="rect">
-            <a:avLst/>
-          </a:prstGeom>
-          <a:noFill/>
-        </p:spPr>
-        <p:txBody>
-          <a:bodyPr wrap="square" rtlCol="0">
-            <a:spAutoFit/>
-          </a:bodyPr>
-          <a:lstStyle/>
-          <a:p>
-            <a:r>
-              <a:rPr lang="fr-FR" dirty="0"/>
-              <a:t>Changements:</a:t>
-            </a:r>
-          </a:p>
-          <a:p>
-            <a:endParaRPr lang="fr-FR" dirty="0"/>
-          </a:p>
-          <a:p>
-            <a:pPr marL="285750" indent="-285750">
-              <a:buFontTx/>
-              <a:buChar char="-"/>
-            </a:pPr>
-            <a:r>
-              <a:rPr lang="fr-FR" dirty="0"/>
-              <a:t>Player Handling se charge maintenant de l’authentification</a:t>
-            </a:r>
-          </a:p>
-          <a:p>
-            <a:pPr marL="285750" indent="-285750">
-              <a:buFontTx/>
-              <a:buChar char="-"/>
-            </a:pPr>
-            <a:endParaRPr lang="fr-FR" dirty="0"/>
-          </a:p>
-          <a:p>
-            <a:pPr marL="285750" indent="-285750">
-              <a:buFontTx/>
-              <a:buChar char="-"/>
-            </a:pPr>
-            <a:r>
-              <a:rPr lang="fr-FR" dirty="0"/>
-              <a:t>Au lieu de laisser les joueurs joindre la partie, il faut s’enregistrer et se login</a:t>
-            </a:r>
-          </a:p>
-          <a:p>
-            <a:pPr marL="285750" indent="-285750">
-              <a:buFontTx/>
-              <a:buChar char="-"/>
-            </a:pPr>
-            <a:endParaRPr lang="fr-FR" dirty="0"/>
-          </a:p>
-          <a:p>
-            <a:pPr marL="285750" indent="-285750">
-              <a:buFontTx/>
-              <a:buChar char="-"/>
-            </a:pPr>
-            <a:r>
-              <a:rPr lang="fr-FR" dirty="0"/>
-              <a:t>Les infos des joueurs sont persistantes</a:t>
-            </a:r>
-          </a:p>
-          <a:p>
-            <a:pPr marL="285750" indent="-285750">
-              <a:buFontTx/>
-              <a:buChar char="-"/>
-            </a:pPr>
-            <a:endParaRPr lang="fr-FR" dirty="0"/>
-          </a:p>
-        </p:txBody>
-      </p:sp>
-    </p:spTree>
-    <p:extLst>
-      <p:ext uri="{BB962C8B-B14F-4D97-AF65-F5344CB8AC3E}">
-        <p14:creationId xmlns:p14="http://schemas.microsoft.com/office/powerpoint/2010/main" val="357446579"/>
       </p:ext>
     </p:extLst>
   </p:cSld>

</xml_diff>